<commit_message>
Add cumulative time intervals to slide speaker notes
Replace the rough «⏱ ~XX сек  ·  слайд N/18» on each slide with a
proper cumulative interval like «⏱ 2:37 – 3:15  ·  слайд 6/18».
Computed from actual word count at 2.3 words/sec — total runs 8:51,
within the 10-min slide budget.

Adds thesis/scripts/add_slide_time_intervals.py for re-running if
notes ever change.

Co-Authored-By: Claude Opus 4.7 (1M context) <noreply@anthropic.com>
</commit_message>
<xml_diff>
--- a/thesis/2026_М_ПІ_ІПЗм-24-1_Нестеренко_В_В.pptx
+++ b/thesis/2026_М_ПІ_ІПЗм-24-1_Нестеренко_В_В.pptx
@@ -5367,7 +5367,7 @@
           <a:lstStyle/>
           <a:p>
             <a:r>
-              <a:t>⏱ ~25 сек  ·  слайд 1/18</a:t>
+              <a:t>⏱ 0:00 – 0:19  ·  слайд 1/18</a:t>
             </a:r>
             <a:endParaRPr lang="en-US" dirty="0"/>
           </a:p>
@@ -5459,7 +5459,7 @@
           <a:lstStyle/>
           <a:p>
             <a:r>
-              <a:t>⏱ ~20 сек  ·  слайд 10/18</a:t>
+              <a:t>⏱ 4:47 – 4:59  ·  слайд 10/18</a:t>
             </a:r>
             <a:endParaRPr lang="en-US" dirty="0"/>
           </a:p>
@@ -5551,7 +5551,7 @@
           <a:lstStyle/>
           <a:p>
             <a:r>
-              <a:t>⏱ ~45 сек  ·  слайд 11/18</a:t>
+              <a:t>⏱ 4:59 – 5:34  ·  слайд 11/18</a:t>
             </a:r>
             <a:endParaRPr lang="en-US" dirty="0"/>
           </a:p>
@@ -5658,7 +5658,7 @@
           <a:lstStyle/>
           <a:p>
             <a:r>
-              <a:t>⏱ ~15 сек  ·  слайд 12/18</a:t>
+              <a:t>⏱ 5:34 – 5:47  ·  слайд 12/18</a:t>
             </a:r>
             <a:endParaRPr lang="en-US" dirty="0"/>
           </a:p>
@@ -5750,7 +5750,7 @@
           <a:lstStyle/>
           <a:p>
             <a:r>
-              <a:t>⏱ ~70 сек  ·  слайд 13/18</a:t>
+              <a:t>⏱ 5:47 – 6:33  ·  слайд 13/18</a:t>
             </a:r>
             <a:endParaRPr lang="en-US" dirty="0"/>
           </a:p>
@@ -5857,7 +5857,7 @@
           <a:lstStyle/>
           <a:p>
             <a:r>
-              <a:t>⏱ ~25 сек  ·  слайд 14/18</a:t>
+              <a:t>⏱ 6:33 – 6:50  ·  слайд 14/18</a:t>
             </a:r>
             <a:endParaRPr lang="en-US" dirty="0"/>
           </a:p>
@@ -5949,7 +5949,7 @@
           <a:lstStyle/>
           <a:p>
             <a:r>
-              <a:t>⏱ ~35 сек  ·  слайд 15/18</a:t>
+              <a:t>⏱ 6:50 – 7:17  ·  слайд 15/18</a:t>
             </a:r>
             <a:endParaRPr lang="en-US" dirty="0"/>
           </a:p>
@@ -6041,7 +6041,7 @@
           <a:lstStyle/>
           <a:p>
             <a:r>
-              <a:t>⏱ ~55 сек  ·  слайд 16/18</a:t>
+              <a:t>⏱ 7:17 – 7:51  ·  слайд 16/18</a:t>
             </a:r>
             <a:endParaRPr lang="en-US" dirty="0"/>
           </a:p>
@@ -6153,7 +6153,7 @@
           <a:lstStyle/>
           <a:p>
             <a:r>
-              <a:t>⏱ ~25 сек  ·  слайд 17/18</a:t>
+              <a:t>⏱ 7:51 – 8:13  ·  слайд 17/18</a:t>
             </a:r>
             <a:endParaRPr lang="en-US" dirty="0"/>
           </a:p>
@@ -6245,7 +6245,7 @@
           <a:lstStyle/>
           <a:p>
             <a:r>
-              <a:t>⏱ ~60 сек  ·  слайд 18/18</a:t>
+              <a:t>⏱ 8:13 – 8:51  ·  слайд 18/18</a:t>
             </a:r>
             <a:endParaRPr lang="en-US" dirty="0"/>
           </a:p>
@@ -6367,7 +6367,7 @@
           <a:lstStyle/>
           <a:p>
             <a:r>
-              <a:t>⏱ ~70 сек  ·  слайд 2/18</a:t>
+              <a:t>⏱ 0:19 – 1:11  ·  слайд 2/18</a:t>
             </a:r>
             <a:endParaRPr lang="en-US" dirty="0"/>
           </a:p>
@@ -6474,7 +6474,7 @@
           <a:lstStyle/>
           <a:p>
             <a:r>
-              <a:t>⏱ ~35 сек  ·  слайд 3/18</a:t>
+              <a:t>⏱ 1:11 – 1:29  ·  слайд 3/18</a:t>
             </a:r>
             <a:endParaRPr lang="en-US" dirty="0"/>
           </a:p>
@@ -6566,7 +6566,7 @@
           <a:lstStyle/>
           <a:p>
             <a:r>
-              <a:t>⏱ ~50 сек  ·  слайд 4/18</a:t>
+              <a:t>⏱ 1:29 – 2:09  ·  слайд 4/18</a:t>
             </a:r>
             <a:endParaRPr lang="en-US" dirty="0"/>
           </a:p>
@@ -6663,7 +6663,7 @@
           <a:lstStyle/>
           <a:p>
             <a:r>
-              <a:t>⏱ ~45 сек  ·  слайд 5/18</a:t>
+              <a:t>⏱ 2:09 – 2:37  ·  слайд 5/18</a:t>
             </a:r>
             <a:endParaRPr lang="en-US" dirty="0"/>
           </a:p>
@@ -6755,7 +6755,7 @@
           <a:lstStyle/>
           <a:p>
             <a:r>
-              <a:t>⏱ ~50 сек  ·  слайд 6/18</a:t>
+              <a:t>⏱ 2:37 – 3:15  ·  слайд 6/18</a:t>
             </a:r>
             <a:endParaRPr lang="en-US" dirty="0"/>
           </a:p>
@@ -6852,7 +6852,7 @@
           <a:lstStyle/>
           <a:p>
             <a:r>
-              <a:t>⏱ ~35 сек  ·  слайд 7/18</a:t>
+              <a:t>⏱ 3:15 – 3:38  ·  слайд 7/18</a:t>
             </a:r>
             <a:endParaRPr lang="en-US" dirty="0"/>
           </a:p>
@@ -6944,7 +6944,7 @@
           <a:lstStyle/>
           <a:p>
             <a:r>
-              <a:t>⏱ ~40 сек  ·  слайд 8/18</a:t>
+              <a:t>⏱ 3:38 – 4:07  ·  слайд 8/18</a:t>
             </a:r>
             <a:endParaRPr lang="en-US" dirty="0"/>
           </a:p>
@@ -7036,7 +7036,7 @@
           <a:lstStyle/>
           <a:p>
             <a:r>
-              <a:t>⏱ ~50 сек  ·  слайд 9/18</a:t>
+              <a:t>⏱ 4:07 – 4:47  ·  слайд 9/18</a:t>
             </a:r>
             <a:endParaRPr lang="en-US" dirty="0"/>
           </a:p>

</xml_diff>

<commit_message>
Trim 5 longest slide notes by ~30% (8:51 → 7:41)
Slides 2, 4, 6, 9, 13 had the densest voice-overs and were eating
into the 10-min budget. Cut filler («Перейдемо до головних
результатів…», «Для забезпечення достовірності результатів
застосовано три методи аналізу…», academic «Об'єктом дослідження є
процеси…» preambles) and merged listy enumerations.

Word counts: 119→86, 92→59, 88→54, 93→64, 104→73.

Total slide time: 8:51 → 7:41 (-70s). With demo 4:32: ~12:13 total
at 2.3 wps; ~14:14 at slower 2.0 wps — both fit 15-min budget.

Intervals on every slide auto-refreshed via
add_slide_time_intervals.py.

Co-Authored-By: Claude Opus 4.7 (1M context) <noreply@anthropic.com>
</commit_message>
<xml_diff>
--- a/thesis/2026_М_ПІ_ІПЗм-24-1_Нестеренко_В_В.pptx
+++ b/thesis/2026_М_ПІ_ІПЗм-24-1_Нестеренко_В_В.pptx
@@ -5459,7 +5459,7 @@
           <a:lstStyle/>
           <a:p>
             <a:r>
-              <a:t>⏱ 4:47 – 4:59  ·  слайд 10/18</a:t>
+              <a:t>⏱ 3:51 – 4:03  ·  слайд 10/18</a:t>
             </a:r>
             <a:endParaRPr lang="en-US" dirty="0"/>
           </a:p>
@@ -5551,7 +5551,7 @@
           <a:lstStyle/>
           <a:p>
             <a:r>
-              <a:t>⏱ 4:59 – 5:34  ·  слайд 11/18</a:t>
+              <a:t>⏱ 4:03 – 4:38  ·  слайд 11/18</a:t>
             </a:r>
             <a:endParaRPr lang="en-US" dirty="0"/>
           </a:p>
@@ -5658,7 +5658,7 @@
           <a:lstStyle/>
           <a:p>
             <a:r>
-              <a:t>⏱ 5:34 – 5:47  ·  слайд 12/18</a:t>
+              <a:t>⏱ 4:38 – 4:51  ·  слайд 12/18</a:t>
             </a:r>
             <a:endParaRPr lang="en-US" dirty="0"/>
           </a:p>
@@ -5750,28 +5750,24 @@
           <a:lstStyle/>
           <a:p>
             <a:r>
-              <a:t>⏱ 5:47 – 6:33  ·  слайд 13/18</a:t>
+              <a:t>⏱ 4:51 – 5:23  ·  слайд 13/18</a:t>
             </a:r>
             <a:endParaRPr lang="en-US" dirty="0"/>
           </a:p>
-          <a:p>
-            <a:r>
-              <a:t>Перейдемо до головних результатів експерименту. У таблиці — середнє значення nDCG@10 по всіх трьох доменах.</a:t>
-            </a:r>
-          </a:p>
-          <a:p>
-            <a:r>
-              <a:t>Перше місце посідає BGE-M3 з результатом 0.4708. Друге — Qwen3 з результатом 0.4385. Третє — E5-base з 0.4199. Четверте — лексична baseline BM25 з результатом 0.3319. На останньому місці — nomic з результатом 0.2128, що навіть нижче BM25.</a:t>
-            </a:r>
-          </a:p>
-          <a:p>
-            <a:r>
-              <a:t>Ключовий висновок: три з чотирьох embedding-моделей перевершують лексичну baseline BM25.</a:t>
-            </a:r>
-          </a:p>
-          <a:p>
-            <a:r>
-              <a:t>Достовірність підтверджена бутстреп-аналізом: 2000 повторних вибірок з поверненням. На технічному домені 95% довірчий інтервал для BGE-M3 склав від 0.606 до 0.737, а для BM25 — від 0.431 до 0.541. Інтервали не перетинаються, отже перевага семантичного пошуку над лексичним є статистично значущою.</a:t>
+          <a:p/>
+          <a:p>
+            <a:r>
+              <a:t>Головні результати. У таблиці — середнє nDCG@10 по трьох доменах. Перше — BGE-M3 з 0.4708. Друге — Qwen3 з 0.4385. Третє — E5-base з 0.4199. Четверте — BM25 з 0.3319. Останнє — nomic з 0.2128, навіть нижче BM25.</a:t>
+            </a:r>
+          </a:p>
+          <a:p>
+            <a:r>
+              <a:t>Ключовий висновок: три з чотирьох embedding-моделей перевершують BM25.</a:t>
+            </a:r>
+          </a:p>
+          <a:p>
+            <a:r>
+              <a:t>Достовірність підтверджена бутстрепом (2000 вибірок). На технічному домені 95% CI для BGE-M3 — 0.606–0.737, для BM25 — 0.431–0.541. Інтервали не перетинаються — перевага семантичного пошуку статистично значуща.</a:t>
             </a:r>
           </a:p>
         </p:txBody>
@@ -5857,7 +5853,7 @@
           <a:lstStyle/>
           <a:p>
             <a:r>
-              <a:t>⏱ 6:33 – 6:50  ·  слайд 14/18</a:t>
+              <a:t>⏱ 5:23 – 5:40  ·  слайд 14/18</a:t>
             </a:r>
             <a:endParaRPr lang="en-US" dirty="0"/>
           </a:p>
@@ -5949,7 +5945,7 @@
           <a:lstStyle/>
           <a:p>
             <a:r>
-              <a:t>⏱ 6:50 – 7:17  ·  слайд 15/18</a:t>
+              <a:t>⏱ 5:40 – 6:07  ·  слайд 15/18</a:t>
             </a:r>
             <a:endParaRPr lang="en-US" dirty="0"/>
           </a:p>
@@ -6041,7 +6037,7 @@
           <a:lstStyle/>
           <a:p>
             <a:r>
-              <a:t>⏱ 7:17 – 7:51  ·  слайд 16/18</a:t>
+              <a:t>⏱ 6:07 – 6:42  ·  слайд 16/18</a:t>
             </a:r>
             <a:endParaRPr lang="en-US" dirty="0"/>
           </a:p>
@@ -6153,7 +6149,7 @@
           <a:lstStyle/>
           <a:p>
             <a:r>
-              <a:t>⏱ 7:51 – 8:13  ·  слайд 17/18</a:t>
+              <a:t>⏱ 6:42 – 7:03  ·  слайд 17/18</a:t>
             </a:r>
             <a:endParaRPr lang="en-US" dirty="0"/>
           </a:p>
@@ -6245,7 +6241,7 @@
           <a:lstStyle/>
           <a:p>
             <a:r>
-              <a:t>⏱ 8:13 – 8:51  ·  слайд 18/18</a:t>
+              <a:t>⏱ 7:03 – 7:41  ·  слайд 18/18</a:t>
             </a:r>
             <a:endParaRPr lang="en-US" dirty="0"/>
           </a:p>
@@ -6367,28 +6363,29 @@
           <a:lstStyle/>
           <a:p>
             <a:r>
-              <a:t>⏱ 0:19 – 1:11  ·  слайд 2/18</a:t>
+              <a:t>⏱ 0:19 – 0:57  ·  слайд 2/18</a:t>
             </a:r>
             <a:endParaRPr lang="en-US" dirty="0"/>
           </a:p>
-          <a:p>
-            <a:r>
-              <a:t>Актуальність роботи зумовлена тим, що обсяги корпоративної текстової інформації стрімко зростають, а традиційний лексичний пошук — за ключовими словами — погано працює з синонімією, перефразуванням і мультимовним контентом. Сучасні моделі векторних ембеддінгів дозволяють шукати за змістом, а не за збігом слів.</a:t>
-            </a:r>
-          </a:p>
-          <a:p>
-            <a:r>
-              <a:t>Мета дослідження — визначити доцільність застосування сучасних embedding-моделей для підвищення ефективності семантичного пошуку у корпоративних базах знань шляхом порівняльного експериментального дослідження.</a:t>
-            </a:r>
-          </a:p>
-          <a:p>
-            <a:r>
-              <a:t>Об'єктом дослідження є процеси формування та використання векторних подань текстових даних у системах семантичного пошуку. Предметом — самі моделі векторних ембеддінгів для застосування в корпоративних базах знань.</a:t>
-            </a:r>
-          </a:p>
-          <a:p>
-            <a:r>
-              <a:t>Для досягнення мети поставлено шість задач: проаналізувати предметну галузь; здійснити огляд сучасних embedding-моделей; сформувати україномовний benchmark-набір; реалізувати систему пошуку; оцінити якість моделей за стандартними метриками; та обґрунтовано обрати оптимальну модель.</a:t>
+          <a:p/>
+          <a:p>
+            <a:r>
+              <a:t>Обсяги корпоративної текстової інформації стрімко зростають, а традиційний лексичний пошук погано працює з синонімією, перефразуванням і мультимовним контентом. Сучасні embedding-моделі дозволяють шукати за змістом, а не за збігом слів.</a:t>
+            </a:r>
+          </a:p>
+          <a:p>
+            <a:r>
+              <a:t>Мета — визначити доцільність застосування сучасних embedding-моделей для семантичного пошуку у корпоративних базах знань шляхом порівняльного експериментального дослідження.</a:t>
+            </a:r>
+          </a:p>
+          <a:p>
+            <a:r>
+              <a:t>Об'єкт дослідження — процеси векторних подань тексту; предмет — самі embedding-моделі для корпоративних баз знань.</a:t>
+            </a:r>
+          </a:p>
+          <a:p>
+            <a:r>
+              <a:t>Поставлено шість задач: проаналізувати предметну галузь; здійснити огляд embedding-моделей; сформувати україномовний benchmark; реалізувати систему пошуку; оцінити моделі за стандартними метриками; обґрунтовано обрати оптимальну модель.</a:t>
             </a:r>
           </a:p>
         </p:txBody>
@@ -6474,7 +6471,7 @@
           <a:lstStyle/>
           <a:p>
             <a:r>
-              <a:t>⏱ 1:11 – 1:29  ·  слайд 3/18</a:t>
+              <a:t>⏱ 0:57 – 1:14  ·  слайд 3/18</a:t>
             </a:r>
             <a:endParaRPr lang="en-US" dirty="0"/>
           </a:p>
@@ -6566,18 +6563,19 @@
           <a:lstStyle/>
           <a:p>
             <a:r>
-              <a:t>⏱ 1:29 – 2:09  ·  слайд 4/18</a:t>
+              <a:t>⏱ 1:14 – 1:40  ·  слайд 4/18</a:t>
             </a:r>
             <a:endParaRPr lang="en-US" dirty="0"/>
           </a:p>
-          <a:p>
-            <a:r>
-              <a:t>З огляду на виявлену прогалину сформульовано постановку задачі. Просто застосувати сучасну embedding-модель недостатньо — необхідно обґрунтовано вибрати модель, яка забезпечує оптимальний баланс між якістю пошуку, швидкодією, вимогами до ресурсів, мовною підтримкою та типом колекції документів.</a:t>
-            </a:r>
-          </a:p>
-          <a:p>
-            <a:r>
-              <a:t>Очікувані результати роботи: перше — повноцінна система семантичного пошуку з підтримкою форматів PDF, DOCX, TXT та Markdown. Друге — власноруч сформований україномовний benchmark з трьох доменів. Третє — кількісне порівняння чотирьох embedding-моделей та лексичної baseline-моделі BM25. Четверте — багатокритеріальний вибір моделі за Парето-фронтом і лінійною згорткою. І п'яте — обґрунтовані практичні рекомендації для впровадження у виробничі системи.</a:t>
+          <a:p/>
+          <a:p>
+            <a:r>
+              <a:t>Постановка задачі: просто застосувати embedding-модель недостатньо — треба обґрунтовано обрати ту, що забезпечує баланс між якістю пошуку, швидкодією, ресурсами, мовною підтримкою та типом колекції.</a:t>
+            </a:r>
+          </a:p>
+          <a:p>
+            <a:r>
+              <a:t>П'ять очікуваних результатів: повноцінна система семантичного пошуку з підтримкою PDF, DOCX, TXT, Markdown; україномовний benchmark з трьох доменів; кількісне порівняння чотирьох embedding-моделей та BM25; багатокритеріальний вибір за Парето-фронтом і лінійною згорткою; обґрунтовані рекомендації для впровадження.</a:t>
             </a:r>
           </a:p>
         </p:txBody>
@@ -6663,7 +6661,7 @@
           <a:lstStyle/>
           <a:p>
             <a:r>
-              <a:t>⏱ 2:09 – 2:37  ·  слайд 5/18</a:t>
+              <a:t>⏱ 1:40 – 2:08  ·  слайд 5/18</a:t>
             </a:r>
             <a:endParaRPr lang="en-US" dirty="0"/>
           </a:p>
@@ -6755,18 +6753,19 @@
           <a:lstStyle/>
           <a:p>
             <a:r>
-              <a:t>⏱ 2:37 – 3:15  ·  слайд 6/18</a:t>
+              <a:t>⏱ 2:08 – 2:31  ·  слайд 6/18</a:t>
             </a:r>
             <a:endParaRPr lang="en-US" dirty="0"/>
           </a:p>
-          <a:p>
-            <a:r>
-              <a:t>Методологія оцінювання базується на чотирьох метриках retrieval-якості, які є стандартом у сфері інформаційного пошуку: nDCG@10 — основна метрика якості ранжування; MRR@10 — позиція першого релевантного документа; Recall@10 — повнота пошуку; та Precision@10 — точність видачі. Окремо вимірюється швидкодія в мілісекундах на запит.</a:t>
-            </a:r>
-          </a:p>
-          <a:p>
-            <a:r>
-              <a:t>Для забезпечення достовірності результатів застосовано три методи аналізу. Перший — бутстреп-довірчі інтервали: 2000 повторних вибірок із поверненням, що дозволяє оцінити 95% довірчий інтервал для nDCG@10. Другий — Парето-домінування для виявлення недомінованих альтернатив. Третій — лінійна адитивна згортка для обчислення інтегральної оцінки корисності з ваговими коефіцієнтами критеріїв.</a:t>
+          <a:p/>
+          <a:p>
+            <a:r>
+              <a:t>Оцінювання базується на чотирьох стандартних метриках retrieval-якості: nDCG@10 — якість ранжування; MRR@10 — позиція першого релевантного; Recall@10 — повнота; Precision@10 — точність. Окремо вимірюється швидкодія в мілісекундах.</a:t>
+            </a:r>
+          </a:p>
+          <a:p>
+            <a:r>
+              <a:t>Для достовірності — три методи аналізу: бутстреп-довірчі інтервали (2000 повторних вибірок, 95% CI); Парето-домінування для виявлення недомінованих альтернатив; лінійна адитивна згортка для інтегральної оцінки з ваговими коефіцієнтами.</a:t>
             </a:r>
           </a:p>
         </p:txBody>
@@ -6852,7 +6851,7 @@
           <a:lstStyle/>
           <a:p>
             <a:r>
-              <a:t>⏱ 3:15 – 3:38  ·  слайд 7/18</a:t>
+              <a:t>⏱ 2:31 – 2:54  ·  слайд 7/18</a:t>
             </a:r>
             <a:endParaRPr lang="en-US" dirty="0"/>
           </a:p>
@@ -6944,7 +6943,7 @@
           <a:lstStyle/>
           <a:p>
             <a:r>
-              <a:t>⏱ 3:38 – 4:07  ·  слайд 8/18</a:t>
+              <a:t>⏱ 2:54 – 3:23  ·  слайд 8/18</a:t>
             </a:r>
             <a:endParaRPr lang="en-US" dirty="0"/>
           </a:p>
@@ -7036,23 +7035,14 @@
           <a:lstStyle/>
           <a:p>
             <a:r>
-              <a:t>⏱ 4:07 – 4:47  ·  слайд 9/18</a:t>
+              <a:t>⏱ 3:23 – 3:51  ·  слайд 9/18</a:t>
             </a:r>
             <a:endParaRPr lang="en-US" dirty="0"/>
           </a:p>
-          <a:p>
-            <a:r>
-              <a:t>Архітектура системи побудована у вигляді pipeline. На вході — документи у форматах PDF, DOCX, TXT або Markdown. Документи розбиваються на чанки приблизно по 600 слів з перекриттям, що зберігає контекстну зв'язність.</a:t>
-            </a:r>
-          </a:p>
-          <a:p>
-            <a:r>
-              <a:t>Далі кожен чанк перетворюється на вектор за допомогою однієї з чотирьох embedding-моделей. Вектори L2-нормалізуються та індексуються у FAISS — використовується точний індекс IndexFlatIP, який обчислює внутрішній добуток, що для нормалізованих векторів еквівалентне косинусній мірі.</a:t>
-            </a:r>
-          </a:p>
-          <a:p>
-            <a:r>
-              <a:t>Запит користувача проходить ту саму обробку, і за косинусною схожістю повертаються топ-K найрелевантніших чанків. Усе це обгорнуто у Flask веб-застосунок. Основні модулі — build_index, evaluate_benchmark, embedding_models та app.</a:t>
+          <a:p/>
+          <a:p>
+            <a:r>
+              <a:t>Архітектура у вигляді pipeline. На вході — PDF, DOCX, TXT або Markdown. Документи розбиваються на чанки ~600 слів з перекриттям. Далі чанк перетворюється на вектор однією з чотирьох embedding-моделей, L2-нормалізується та індексується у FAISS — точний IndexFlatIP, що для нормалізованих векторів еквівалентне косинусній мірі. Запит проходить ту саму обробку — повертаються топ-K найрелевантніших чанків. Усе обгорнуто у Flask. Основні модулі: build_index, evaluate_benchmark, embedding_models, app.</a:t>
             </a:r>
           </a:p>
         </p:txBody>

</xml_diff>

<commit_message>
Address supervisor pre-defense feedback
Slide 17 (Підсумки): replace abstract subtitles with concrete numbers
that supervisor flagged as «заабстрактно».
- BGE-M3: «Найкраща якість, стабільність у різних доменах» →
  «Лідер за nDCG@10 у tech (0.672) і medical (0.434), топ-2 у legal»
- BM25: «Залишається сильним у доменах, де важлива швидкість пошуку»
  → «Найшвидша (1–3 мс/запит) — у >100× швидше за BGE-M3»

Real BM25 avg latencies from benchmark JSON: 0.36 ms tech, 3.09 ms
legal, 0.62 ms medical. BGE-M3 avg ~228 ms across all domains.
Ratio ~160×.

Committee Q&A (study/15_committee_qa.md): add new Section 0 with the
six pre-defense questions from supervisor (новизна, практ.значущість,
системи, мови, домени, датасет) with ready answers — these are the
priority items to memorize.

Co-Authored-By: Claude Opus 4.7 (1M context) <noreply@anthropic.com>
</commit_message>
<xml_diff>
--- a/thesis/2026_М_ПІ_ІПЗм-24-1_Нестеренко_В_В.pptx
+++ b/thesis/2026_М_ПІ_ІПЗм-24-1_Нестеренко_В_В.pptx
@@ -24,8 +24,8 @@
     <p:sldId id="269" r:id="rId15"/>
     <p:sldId id="270" r:id="rId16"/>
     <p:sldId id="271" r:id="rId17"/>
-    <p:sldId id="272" r:id="rId18"/>
-    <p:sldId id="273" r:id="rId19"/>
+    <p:sldId id="273" r:id="rId18"/>
+    <p:sldId id="272" r:id="rId19"/>
   </p:sldIdLst>
   <p:sldSz cx="9144000" cy="5143500" type="screen16x9"/>
   <p:notesSz cx="5143500" cy="9144000"/>
@@ -5754,7 +5754,9 @@
             </a:r>
             <a:endParaRPr lang="en-US" dirty="0"/>
           </a:p>
-          <a:p/>
+          <a:p>
+            <a:endParaRPr lang="en-US" dirty="0"/>
+          </a:p>
           <a:p>
             <a:r>
               <a:t>Головні результати. У таблиці — середнє nDCG@10 по трьох доменах. Перше — BGE-M3 з 0.4708. Друге — Qwen3 з 0.4385. Третє — E5-base з 0.4199. Четверте — BM25 з 0.3319. Останнє — nomic з 0.2128, навіть нижче BM25.</a:t>
@@ -6149,13 +6151,43 @@
           <a:lstStyle/>
           <a:p>
             <a:r>
-              <a:t>⏱ 6:42 – 7:03  ·  слайд 17/18</a:t>
+              <a:t>⏱ 7:03 – 7:41  ·  слайд 18/18</a:t>
             </a:r>
             <a:endParaRPr lang="en-US" dirty="0"/>
           </a:p>
           <a:p>
             <a:r>
-              <a:t>Апробація: опубліковано дві наукові праці у співавторстві з науковим керівником. Перша — стаття на 2-й конференції «Innovative Research in Science and Economy» з benchmark-методологією. Друга — тези на 30-му форумі «Радіоелектроніка та молодь у XXI столітті» в ХНУРЕ про підвищення якості retrieval. Загалом — два виступи на міжнародних конференціях.</a:t>
+              <a:t>Підсумовуючи: у роботі обґрунтовано доцільність застосування сучасних embedding-моделей для семантичного пошуку у корпоративних базах знань. Сформульовано практичні рекомендації щодо вибору моделі.</a:t>
+            </a:r>
+          </a:p>
+          <a:p>
+            <a:r>
+              <a:t>BGE-M3 — основна модель для впровадження: найкраща якість і стабільність у різних доменах.</a:t>
+            </a:r>
+          </a:p>
+          <a:p>
+            <a:r>
+              <a:t>E5-base — швидка альтернатива з прийнятною якістю та триразовою перевагою за швидкодією.</a:t>
+            </a:r>
+          </a:p>
+          <a:p>
+            <a:r>
+              <a:t>Qwen3 — оптимальний вибір для юридичних колекцій, де він демонструє найвищу якість.</a:t>
+            </a:r>
+          </a:p>
+          <a:p>
+            <a:r>
+              <a:t>BM25 — залишається конкурентним baseline у певних доменах і за дуже жорстких вимог до швидкості.</a:t>
+            </a:r>
+          </a:p>
+          <a:p>
+            <a:r>
+              <a:t>Усі задачі, поставлені в роботі, виконано. Мета досягнута.</a:t>
+            </a:r>
+          </a:p>
+          <a:p>
+            <a:r>
+              <a:t>Дякую за увагу! Готовий відповісти на запитання.</a:t>
             </a:r>
           </a:p>
         </p:txBody>
@@ -6241,43 +6273,13 @@
           <a:lstStyle/>
           <a:p>
             <a:r>
-              <a:t>⏱ 7:03 – 7:41  ·  слайд 18/18</a:t>
+              <a:t>⏱ 6:42 – 7:03  ·  слайд 17/18</a:t>
             </a:r>
             <a:endParaRPr lang="en-US" dirty="0"/>
           </a:p>
           <a:p>
             <a:r>
-              <a:t>Підсумовуючи: у роботі обґрунтовано доцільність застосування сучасних embedding-моделей для семантичного пошуку у корпоративних базах знань. Сформульовано практичні рекомендації щодо вибору моделі.</a:t>
-            </a:r>
-          </a:p>
-          <a:p>
-            <a:r>
-              <a:t>BGE-M3 — основна модель для впровадження: найкраща якість і стабільність у різних доменах.</a:t>
-            </a:r>
-          </a:p>
-          <a:p>
-            <a:r>
-              <a:t>E5-base — швидка альтернатива з прийнятною якістю та триразовою перевагою за швидкодією.</a:t>
-            </a:r>
-          </a:p>
-          <a:p>
-            <a:r>
-              <a:t>Qwen3 — оптимальний вибір для юридичних колекцій, де він демонструє найвищу якість.</a:t>
-            </a:r>
-          </a:p>
-          <a:p>
-            <a:r>
-              <a:t>BM25 — залишається конкурентним baseline у певних доменах і за дуже жорстких вимог до швидкості.</a:t>
-            </a:r>
-          </a:p>
-          <a:p>
-            <a:r>
-              <a:t>Усі задачі, поставлені в роботі, виконано. Мета досягнута.</a:t>
-            </a:r>
-          </a:p>
-          <a:p>
-            <a:r>
-              <a:t>Дякую за увагу! Готовий відповісти на запитання.</a:t>
+              <a:t>Апробація: опубліковано дві наукові праці у співавторстві з науковим керівником. Перша — стаття на 2-й конференції «Innovative Research in Science and Economy» з benchmark-методологією. Друга — тези на 30-му форумі «Радіоелектроніка та молодь у XXI столітті» в ХНУРЕ про підвищення якості retrieval. Загалом — два виступи на міжнародних конференціях.</a:t>
             </a:r>
           </a:p>
         </p:txBody>
@@ -6367,7 +6369,9 @@
             </a:r>
             <a:endParaRPr lang="en-US" dirty="0"/>
           </a:p>
-          <a:p/>
+          <a:p>
+            <a:endParaRPr lang="en-US" dirty="0"/>
+          </a:p>
           <a:p>
             <a:r>
               <a:t>Обсяги корпоративної текстової інформації стрімко зростають, а традиційний лексичний пошук погано працює з синонімією, перефразуванням і мультимовним контентом. Сучасні embedding-моделі дозволяють шукати за змістом, а не за збігом слів.</a:t>
@@ -6567,7 +6571,9 @@
             </a:r>
             <a:endParaRPr lang="en-US" dirty="0"/>
           </a:p>
-          <a:p/>
+          <a:p>
+            <a:endParaRPr lang="en-US" dirty="0"/>
+          </a:p>
           <a:p>
             <a:r>
               <a:t>Постановка задачі: просто застосувати embedding-модель недостатньо — треба обґрунтовано обрати ту, що забезпечує баланс між якістю пошуку, швидкодією, ресурсами, мовною підтримкою та типом колекції.</a:t>
@@ -6757,7 +6763,9 @@
             </a:r>
             <a:endParaRPr lang="en-US" dirty="0"/>
           </a:p>
-          <a:p/>
+          <a:p>
+            <a:endParaRPr lang="en-US" dirty="0"/>
+          </a:p>
           <a:p>
             <a:r>
               <a:t>Оцінювання базується на чотирьох стандартних метриках retrieval-якості: nDCG@10 — якість ранжування; MRR@10 — позиція першого релевантного; Recall@10 — повнота; Precision@10 — точність. Окремо вимірюється швидкодія в мілісекундах.</a:t>
@@ -7039,7 +7047,9 @@
             </a:r>
             <a:endParaRPr lang="en-US" dirty="0"/>
           </a:p>
-          <a:p/>
+          <a:p>
+            <a:endParaRPr lang="en-US" dirty="0"/>
+          </a:p>
           <a:p>
             <a:r>
               <a:t>Архітектура у вигляді pipeline. На вході — PDF, DOCX, TXT або Markdown. Документи розбиваються на чанки ~600 слів з перекриттям. Далі чанк перетворюється на вектор однією з чотирьох embedding-моделей, L2-нормалізується та індексується у FAISS — точний IndexFlatIP, що для нормалізованих векторів еквівалентне косинусній мірі. Запит проходить ту саму обробку — повертаються топ-K найрелевантніших чанків. Усе обгорнуто у Flask. Основні модулі: build_index, evaluate_benchmark, embedding_models, app.</a:t>
@@ -18438,6 +18448,1371 @@
 
 <file path=ppt/slides/slide17.xml><?xml version="1.0" encoding="utf-8"?>
 <p:sld xmlns:a="http://schemas.openxmlformats.org/drawingml/2006/main" xmlns:r="http://schemas.openxmlformats.org/officeDocument/2006/relationships" xmlns:p="http://schemas.openxmlformats.org/presentationml/2006/main">
+  <p:cSld name="Slide 18">
+    <p:bg>
+      <p:bgPr>
+        <a:solidFill>
+          <a:srgbClr val="FFFFFF"/>
+        </a:solidFill>
+        <a:effectLst/>
+      </p:bgPr>
+    </p:bg>
+    <p:spTree>
+      <p:nvGrpSpPr>
+        <p:cNvPr id="1" name=""/>
+        <p:cNvGrpSpPr/>
+        <p:nvPr/>
+      </p:nvGrpSpPr>
+      <p:grpSpPr>
+        <a:xfrm>
+          <a:off x="0" y="0"/>
+          <a:ext cx="0" cy="0"/>
+          <a:chOff x="0" y="0"/>
+          <a:chExt cx="0" cy="0"/>
+        </a:xfrm>
+      </p:grpSpPr>
+      <p:sp>
+        <p:nvSpPr>
+          <p:cNvPr id="2" name="Shape 0"/>
+          <p:cNvSpPr/>
+          <p:nvPr/>
+        </p:nvSpPr>
+        <p:spPr>
+          <a:xfrm>
+            <a:off x="-914400" y="-914400"/>
+            <a:ext cx="3657600" cy="3657600"/>
+          </a:xfrm>
+          <a:prstGeom prst="ellipse">
+            <a:avLst/>
+          </a:prstGeom>
+          <a:solidFill>
+            <a:srgbClr val="EFF6FF"/>
+          </a:solidFill>
+          <a:ln/>
+        </p:spPr>
+        <p:txBody>
+          <a:bodyPr/>
+          <a:lstStyle/>
+          <a:p>
+            <a:endParaRPr lang="en-US"/>
+          </a:p>
+        </p:txBody>
+      </p:sp>
+      <p:sp>
+        <p:nvSpPr>
+          <p:cNvPr id="3" name="Shape 1"/>
+          <p:cNvSpPr/>
+          <p:nvPr/>
+        </p:nvSpPr>
+        <p:spPr>
+          <a:xfrm>
+            <a:off x="7315200" y="3657600"/>
+            <a:ext cx="3200400" cy="3200400"/>
+          </a:xfrm>
+          <a:prstGeom prst="ellipse">
+            <a:avLst/>
+          </a:prstGeom>
+          <a:solidFill>
+            <a:srgbClr val="F59E0B">
+              <a:alpha val="20000"/>
+            </a:srgbClr>
+          </a:solidFill>
+          <a:ln/>
+        </p:spPr>
+        <p:txBody>
+          <a:bodyPr/>
+          <a:lstStyle/>
+          <a:p>
+            <a:endParaRPr lang="en-US"/>
+          </a:p>
+        </p:txBody>
+      </p:sp>
+      <p:sp>
+        <p:nvSpPr>
+          <p:cNvPr id="4" name="Text 2"/>
+          <p:cNvSpPr/>
+          <p:nvPr/>
+        </p:nvSpPr>
+        <p:spPr>
+          <a:xfrm>
+            <a:off x="411480" y="91440"/>
+            <a:ext cx="8321040" cy="182880"/>
+          </a:xfrm>
+          <a:prstGeom prst="rect">
+            <a:avLst/>
+          </a:prstGeom>
+          <a:noFill/>
+          <a:ln/>
+        </p:spPr>
+        <p:txBody>
+          <a:bodyPr wrap="square" lIns="0" tIns="0" rIns="0" bIns="0" rtlCol="0" anchor="ctr"/>
+          <a:lstStyle/>
+          <a:p>
+            <a:pPr marL="0" indent="0" algn="l">
+              <a:buNone/>
+            </a:pPr>
+            <a:r>
+              <a:rPr lang="en-US" sz="850" b="1" kern="0" spc="300" dirty="0">
+                <a:solidFill>
+                  <a:srgbClr val="64748B"/>
+                </a:solidFill>
+                <a:latin typeface="Calibri" pitchFamily="34" charset="0"/>
+                <a:ea typeface="Calibri" pitchFamily="34" charset="-122"/>
+                <a:cs typeface="Calibri" pitchFamily="34" charset="-120"/>
+              </a:rPr>
+              <a:t>РОЗДІЛ 11 · ПІДСУМКИ</a:t>
+            </a:r>
+            <a:endParaRPr lang="en-US" sz="850" dirty="0"/>
+          </a:p>
+        </p:txBody>
+      </p:sp>
+      <p:sp>
+        <p:nvSpPr>
+          <p:cNvPr id="5" name="Shape 3"/>
+          <p:cNvSpPr/>
+          <p:nvPr/>
+        </p:nvSpPr>
+        <p:spPr>
+          <a:xfrm>
+            <a:off x="411480" y="420624"/>
+            <a:ext cx="201168" cy="201168"/>
+          </a:xfrm>
+          <a:prstGeom prst="ellipse">
+            <a:avLst/>
+          </a:prstGeom>
+          <a:solidFill>
+            <a:srgbClr val="F59E0B"/>
+          </a:solidFill>
+          <a:ln/>
+        </p:spPr>
+        <p:txBody>
+          <a:bodyPr/>
+          <a:lstStyle/>
+          <a:p>
+            <a:endParaRPr lang="en-US"/>
+          </a:p>
+        </p:txBody>
+      </p:sp>
+      <p:sp>
+        <p:nvSpPr>
+          <p:cNvPr id="6" name="Text 4"/>
+          <p:cNvSpPr/>
+          <p:nvPr/>
+        </p:nvSpPr>
+        <p:spPr>
+          <a:xfrm>
+            <a:off x="722376" y="292608"/>
+            <a:ext cx="6858000" cy="502920"/>
+          </a:xfrm>
+          <a:prstGeom prst="rect">
+            <a:avLst/>
+          </a:prstGeom>
+          <a:noFill/>
+          <a:ln/>
+        </p:spPr>
+        <p:txBody>
+          <a:bodyPr wrap="square" lIns="0" tIns="0" rIns="0" bIns="0" rtlCol="0" anchor="ctr"/>
+          <a:lstStyle/>
+          <a:p>
+            <a:pPr marL="0" indent="0" algn="l">
+              <a:buNone/>
+            </a:pPr>
+            <a:r>
+              <a:rPr lang="uk-UA" sz="2200" b="1" dirty="0">
+                <a:solidFill>
+                  <a:srgbClr val="0F172A"/>
+                </a:solidFill>
+                <a:latin typeface="Calibri" pitchFamily="34" charset="0"/>
+                <a:ea typeface="Calibri" pitchFamily="34" charset="-122"/>
+                <a:cs typeface="Calibri" pitchFamily="34" charset="-120"/>
+              </a:rPr>
+              <a:t>Висновка</a:t>
+            </a:r>
+            <a:r>
+              <a:rPr lang="en-US" sz="2200" b="1" dirty="0">
+                <a:solidFill>
+                  <a:srgbClr val="0F172A"/>
+                </a:solidFill>
+                <a:latin typeface="Calibri" pitchFamily="34" charset="0"/>
+                <a:ea typeface="Calibri" pitchFamily="34" charset="-122"/>
+                <a:cs typeface="Calibri" pitchFamily="34" charset="-120"/>
+              </a:rPr>
+              <a:t> </a:t>
+            </a:r>
+            <a:r>
+              <a:rPr lang="en-US" sz="2200" b="1" dirty="0" err="1">
+                <a:solidFill>
+                  <a:srgbClr val="0F172A"/>
+                </a:solidFill>
+                <a:latin typeface="Calibri" pitchFamily="34" charset="0"/>
+                <a:ea typeface="Calibri" pitchFamily="34" charset="-122"/>
+                <a:cs typeface="Calibri" pitchFamily="34" charset="-120"/>
+              </a:rPr>
+              <a:t>та</a:t>
+            </a:r>
+            <a:r>
+              <a:rPr lang="en-US" sz="2200" b="1" dirty="0">
+                <a:solidFill>
+                  <a:srgbClr val="0F172A"/>
+                </a:solidFill>
+                <a:latin typeface="Calibri" pitchFamily="34" charset="0"/>
+                <a:ea typeface="Calibri" pitchFamily="34" charset="-122"/>
+                <a:cs typeface="Calibri" pitchFamily="34" charset="-120"/>
+              </a:rPr>
+              <a:t> </a:t>
+            </a:r>
+            <a:r>
+              <a:rPr lang="uk-UA" sz="2200" b="1" dirty="0">
+                <a:solidFill>
+                  <a:srgbClr val="0F172A"/>
+                </a:solidFill>
+                <a:latin typeface="Calibri" pitchFamily="34" charset="0"/>
+                <a:ea typeface="Calibri" pitchFamily="34" charset="-122"/>
+                <a:cs typeface="Calibri" pitchFamily="34" charset="-120"/>
+              </a:rPr>
+              <a:t>результати дослідження</a:t>
+            </a:r>
+            <a:endParaRPr lang="en-US" sz="2200" dirty="0"/>
+          </a:p>
+        </p:txBody>
+      </p:sp>
+      <p:sp>
+        <p:nvSpPr>
+          <p:cNvPr id="7" name="Shape 5"/>
+          <p:cNvSpPr/>
+          <p:nvPr/>
+        </p:nvSpPr>
+        <p:spPr>
+          <a:xfrm>
+            <a:off x="411480" y="960120"/>
+            <a:ext cx="8321040" cy="502920"/>
+          </a:xfrm>
+          <a:prstGeom prst="roundRect">
+            <a:avLst>
+              <a:gd name="adj" fmla="val 10909"/>
+            </a:avLst>
+          </a:prstGeom>
+          <a:solidFill>
+            <a:srgbClr val="F59E0B"/>
+          </a:solidFill>
+          <a:ln w="9525">
+            <a:solidFill>
+              <a:srgbClr val="F59E0B"/>
+            </a:solidFill>
+            <a:prstDash val="solid"/>
+          </a:ln>
+          <a:effectLst>
+            <a:outerShdw blurRad="76200" dist="12700" dir="5400000" algn="bl" rotWithShape="0">
+              <a:srgbClr val="000000">
+                <a:alpha val="7000"/>
+              </a:srgbClr>
+            </a:outerShdw>
+          </a:effectLst>
+        </p:spPr>
+        <p:txBody>
+          <a:bodyPr/>
+          <a:lstStyle/>
+          <a:p>
+            <a:endParaRPr lang="en-US"/>
+          </a:p>
+        </p:txBody>
+      </p:sp>
+      <p:pic>
+        <p:nvPicPr>
+          <p:cNvPr id="8" name="Image 0" descr="preencoded.png"/>
+          <p:cNvPicPr>
+            <a:picLocks noChangeAspect="1"/>
+          </p:cNvPicPr>
+          <p:nvPr/>
+        </p:nvPicPr>
+        <p:blipFill>
+          <a:blip r:embed="rId3"/>
+          <a:stretch>
+            <a:fillRect/>
+          </a:stretch>
+        </p:blipFill>
+        <p:spPr>
+          <a:xfrm>
+            <a:off x="594360" y="1078992"/>
+            <a:ext cx="274320" cy="274320"/>
+          </a:xfrm>
+          <a:prstGeom prst="rect">
+            <a:avLst/>
+          </a:prstGeom>
+        </p:spPr>
+      </p:pic>
+      <p:sp>
+        <p:nvSpPr>
+          <p:cNvPr id="9" name="Text 6"/>
+          <p:cNvSpPr/>
+          <p:nvPr/>
+        </p:nvSpPr>
+        <p:spPr>
+          <a:xfrm>
+            <a:off x="1005840" y="960120"/>
+            <a:ext cx="7635240" cy="502920"/>
+          </a:xfrm>
+          <a:prstGeom prst="rect">
+            <a:avLst/>
+          </a:prstGeom>
+          <a:noFill/>
+          <a:ln/>
+        </p:spPr>
+        <p:txBody>
+          <a:bodyPr wrap="square" lIns="0" tIns="0" rIns="0" bIns="0" rtlCol="0" anchor="ctr"/>
+          <a:lstStyle/>
+          <a:p>
+            <a:pPr marL="0" indent="0" algn="l">
+              <a:buNone/>
+            </a:pPr>
+            <a:r>
+              <a:rPr lang="uk-UA" sz="1100" b="1" dirty="0">
+                <a:solidFill>
+                  <a:srgbClr val="0F172A"/>
+                </a:solidFill>
+                <a:latin typeface="Calibri" pitchFamily="34" charset="0"/>
+                <a:ea typeface="Calibri" pitchFamily="34" charset="-122"/>
+                <a:cs typeface="Calibri" pitchFamily="34" charset="-120"/>
+              </a:rPr>
+              <a:t>О</a:t>
+            </a:r>
+            <a:r>
+              <a:rPr lang="en-US" sz="1100" b="1" dirty="0" err="1">
+                <a:solidFill>
+                  <a:srgbClr val="0F172A"/>
+                </a:solidFill>
+                <a:latin typeface="Calibri" pitchFamily="34" charset="0"/>
+                <a:ea typeface="Calibri" pitchFamily="34" charset="-122"/>
+                <a:cs typeface="Calibri" pitchFamily="34" charset="-120"/>
+              </a:rPr>
+              <a:t>бґрунтовано</a:t>
+            </a:r>
+            <a:r>
+              <a:rPr lang="en-US" sz="1100" b="1" dirty="0">
+                <a:solidFill>
+                  <a:srgbClr val="0F172A"/>
+                </a:solidFill>
+                <a:latin typeface="Calibri" pitchFamily="34" charset="0"/>
+                <a:ea typeface="Calibri" pitchFamily="34" charset="-122"/>
+                <a:cs typeface="Calibri" pitchFamily="34" charset="-120"/>
+              </a:rPr>
+              <a:t> доцільність застосування embedding-моделей для семантичного пошуку у корпоративних базах знань</a:t>
+            </a:r>
+            <a:endParaRPr lang="en-US" sz="1100" dirty="0"/>
+          </a:p>
+        </p:txBody>
+      </p:sp>
+      <p:sp>
+        <p:nvSpPr>
+          <p:cNvPr id="10" name="Shape 7"/>
+          <p:cNvSpPr/>
+          <p:nvPr/>
+        </p:nvSpPr>
+        <p:spPr>
+          <a:xfrm>
+            <a:off x="411480" y="1645920"/>
+            <a:ext cx="4069080" cy="1257300"/>
+          </a:xfrm>
+          <a:prstGeom prst="roundRect">
+            <a:avLst>
+              <a:gd name="adj" fmla="val 4364"/>
+            </a:avLst>
+          </a:prstGeom>
+          <a:solidFill>
+            <a:srgbClr val="FFFFFF"/>
+          </a:solidFill>
+          <a:ln w="15875">
+            <a:solidFill>
+              <a:srgbClr val="F59E0B"/>
+            </a:solidFill>
+            <a:prstDash val="solid"/>
+          </a:ln>
+        </p:spPr>
+        <p:txBody>
+          <a:bodyPr/>
+          <a:lstStyle/>
+          <a:p>
+            <a:endParaRPr lang="en-US"/>
+          </a:p>
+        </p:txBody>
+      </p:sp>
+      <p:sp>
+        <p:nvSpPr>
+          <p:cNvPr id="11" name="Shape 8"/>
+          <p:cNvSpPr/>
+          <p:nvPr/>
+        </p:nvSpPr>
+        <p:spPr>
+          <a:xfrm>
+            <a:off x="411480" y="1645920"/>
+            <a:ext cx="91440" cy="1257300"/>
+          </a:xfrm>
+          <a:prstGeom prst="rect">
+            <a:avLst/>
+          </a:prstGeom>
+          <a:solidFill>
+            <a:srgbClr val="F59E0B"/>
+          </a:solidFill>
+          <a:ln/>
+        </p:spPr>
+        <p:txBody>
+          <a:bodyPr/>
+          <a:lstStyle/>
+          <a:p>
+            <a:endParaRPr lang="en-US"/>
+          </a:p>
+        </p:txBody>
+      </p:sp>
+      <p:sp>
+        <p:nvSpPr>
+          <p:cNvPr id="12" name="Shape 9"/>
+          <p:cNvSpPr/>
+          <p:nvPr/>
+        </p:nvSpPr>
+        <p:spPr>
+          <a:xfrm>
+            <a:off x="640080" y="1810512"/>
+            <a:ext cx="502920" cy="502920"/>
+          </a:xfrm>
+          <a:prstGeom prst="ellipse">
+            <a:avLst/>
+          </a:prstGeom>
+          <a:solidFill>
+            <a:srgbClr val="F59E0B"/>
+          </a:solidFill>
+          <a:ln/>
+        </p:spPr>
+        <p:txBody>
+          <a:bodyPr/>
+          <a:lstStyle/>
+          <a:p>
+            <a:endParaRPr lang="en-US"/>
+          </a:p>
+        </p:txBody>
+      </p:sp>
+      <p:pic>
+        <p:nvPicPr>
+          <p:cNvPr id="13" name="Image 1" descr="preencoded.png"/>
+          <p:cNvPicPr>
+            <a:picLocks noChangeAspect="1"/>
+          </p:cNvPicPr>
+          <p:nvPr/>
+        </p:nvPicPr>
+        <p:blipFill>
+          <a:blip r:embed="rId4"/>
+          <a:stretch>
+            <a:fillRect/>
+          </a:stretch>
+        </p:blipFill>
+        <p:spPr>
+          <a:xfrm>
+            <a:off x="740664" y="1911096"/>
+            <a:ext cx="292608" cy="292608"/>
+          </a:xfrm>
+          <a:prstGeom prst="rect">
+            <a:avLst/>
+          </a:prstGeom>
+        </p:spPr>
+      </p:pic>
+      <p:sp>
+        <p:nvSpPr>
+          <p:cNvPr id="14" name="Text 10"/>
+          <p:cNvSpPr/>
+          <p:nvPr/>
+        </p:nvSpPr>
+        <p:spPr>
+          <a:xfrm>
+            <a:off x="1234440" y="1737360"/>
+            <a:ext cx="3108960" cy="320040"/>
+          </a:xfrm>
+          <a:prstGeom prst="rect">
+            <a:avLst/>
+          </a:prstGeom>
+          <a:noFill/>
+          <a:ln/>
+        </p:spPr>
+        <p:txBody>
+          <a:bodyPr wrap="square" lIns="0" tIns="0" rIns="0" bIns="0" rtlCol="0" anchor="ctr"/>
+          <a:lstStyle/>
+          <a:p>
+            <a:pPr marL="0" indent="0" algn="l">
+              <a:buNone/>
+            </a:pPr>
+            <a:r>
+              <a:rPr lang="en-US" sz="1600" b="1" dirty="0">
+                <a:solidFill>
+                  <a:srgbClr val="F59E0B"/>
+                </a:solidFill>
+                <a:latin typeface="Calibri" pitchFamily="34" charset="0"/>
+                <a:ea typeface="Calibri" pitchFamily="34" charset="-122"/>
+                <a:cs typeface="Calibri" pitchFamily="34" charset="-120"/>
+              </a:rPr>
+              <a:t>BGE-M3</a:t>
+            </a:r>
+            <a:endParaRPr lang="en-US" sz="1600" dirty="0"/>
+          </a:p>
+        </p:txBody>
+      </p:sp>
+      <p:sp>
+        <p:nvSpPr>
+          <p:cNvPr id="15" name="Text 11"/>
+          <p:cNvSpPr/>
+          <p:nvPr/>
+        </p:nvSpPr>
+        <p:spPr>
+          <a:xfrm>
+            <a:off x="1234440" y="2066544"/>
+            <a:ext cx="3108960" cy="228600"/>
+          </a:xfrm>
+          <a:prstGeom prst="rect">
+            <a:avLst/>
+          </a:prstGeom>
+          <a:noFill/>
+          <a:ln/>
+        </p:spPr>
+        <p:txBody>
+          <a:bodyPr wrap="square" lIns="0" tIns="0" rIns="0" bIns="0" rtlCol="0" anchor="ctr"/>
+          <a:lstStyle/>
+          <a:p>
+            <a:pPr marL="0" indent="0" algn="l">
+              <a:buNone/>
+            </a:pPr>
+            <a:r>
+              <a:rPr lang="en-US" sz="1000" b="1" dirty="0">
+                <a:solidFill>
+                  <a:srgbClr val="1E293B"/>
+                </a:solidFill>
+                <a:latin typeface="Calibri" pitchFamily="34" charset="0"/>
+                <a:ea typeface="Calibri" pitchFamily="34" charset="-122"/>
+                <a:cs typeface="Calibri" pitchFamily="34" charset="-120"/>
+              </a:rPr>
+              <a:t>Основна модель для впровадження</a:t>
+            </a:r>
+            <a:endParaRPr lang="en-US" sz="1000" dirty="0"/>
+          </a:p>
+        </p:txBody>
+      </p:sp>
+      <p:sp>
+        <p:nvSpPr>
+          <p:cNvPr id="16" name="Text 12"/>
+          <p:cNvSpPr/>
+          <p:nvPr/>
+        </p:nvSpPr>
+        <p:spPr>
+          <a:xfrm>
+            <a:off x="640080" y="2423160"/>
+            <a:ext cx="3657600" cy="388620"/>
+          </a:xfrm>
+          <a:prstGeom prst="rect">
+            <a:avLst/>
+          </a:prstGeom>
+          <a:noFill/>
+          <a:ln/>
+        </p:spPr>
+        <p:txBody>
+          <a:bodyPr wrap="square" lIns="0" tIns="0" rIns="0" bIns="0" rtlCol="0" anchor="t"/>
+          <a:lstStyle/>
+          <a:p>
+            <a:pPr marL="0" indent="0" algn="l">
+              <a:buNone/>
+            </a:pPr>
+            <a:r>
+              <a:rPr lang="en-US" sz="1000" dirty="0">
+                <a:solidFill>
+                  <a:srgbClr val="475569"/>
+                </a:solidFill>
+                <a:latin typeface="Calibri" pitchFamily="34" charset="0"/>
+                <a:ea typeface="Calibri" pitchFamily="34" charset="-122"/>
+                <a:cs typeface="Calibri" pitchFamily="34" charset="-120"/>
+              </a:rPr>
+              <a:t>Лідер за nDCG@10 у tech (0.672) і medical (0.434), топ-2 у legal</a:t>
+            </a:r>
+            <a:endParaRPr lang="en-US" sz="1000" dirty="0"/>
+          </a:p>
+        </p:txBody>
+      </p:sp>
+      <p:sp>
+        <p:nvSpPr>
+          <p:cNvPr id="17" name="Shape 13"/>
+          <p:cNvSpPr/>
+          <p:nvPr/>
+        </p:nvSpPr>
+        <p:spPr>
+          <a:xfrm>
+            <a:off x="4663440" y="1645920"/>
+            <a:ext cx="4069080" cy="1257300"/>
+          </a:xfrm>
+          <a:prstGeom prst="roundRect">
+            <a:avLst>
+              <a:gd name="adj" fmla="val 4364"/>
+            </a:avLst>
+          </a:prstGeom>
+          <a:solidFill>
+            <a:srgbClr val="FFFFFF"/>
+          </a:solidFill>
+          <a:ln w="15875">
+            <a:solidFill>
+              <a:srgbClr val="0891B2"/>
+            </a:solidFill>
+            <a:prstDash val="solid"/>
+          </a:ln>
+        </p:spPr>
+        <p:txBody>
+          <a:bodyPr/>
+          <a:lstStyle/>
+          <a:p>
+            <a:endParaRPr lang="en-US"/>
+          </a:p>
+        </p:txBody>
+      </p:sp>
+      <p:sp>
+        <p:nvSpPr>
+          <p:cNvPr id="18" name="Shape 14"/>
+          <p:cNvSpPr/>
+          <p:nvPr/>
+        </p:nvSpPr>
+        <p:spPr>
+          <a:xfrm>
+            <a:off x="4663440" y="1645920"/>
+            <a:ext cx="91440" cy="1257300"/>
+          </a:xfrm>
+          <a:prstGeom prst="rect">
+            <a:avLst/>
+          </a:prstGeom>
+          <a:solidFill>
+            <a:srgbClr val="0891B2"/>
+          </a:solidFill>
+          <a:ln/>
+        </p:spPr>
+        <p:txBody>
+          <a:bodyPr/>
+          <a:lstStyle/>
+          <a:p>
+            <a:endParaRPr lang="en-US"/>
+          </a:p>
+        </p:txBody>
+      </p:sp>
+      <p:sp>
+        <p:nvSpPr>
+          <p:cNvPr id="19" name="Shape 15"/>
+          <p:cNvSpPr/>
+          <p:nvPr/>
+        </p:nvSpPr>
+        <p:spPr>
+          <a:xfrm>
+            <a:off x="4892040" y="1810512"/>
+            <a:ext cx="502920" cy="502920"/>
+          </a:xfrm>
+          <a:prstGeom prst="ellipse">
+            <a:avLst/>
+          </a:prstGeom>
+          <a:solidFill>
+            <a:srgbClr val="0891B2"/>
+          </a:solidFill>
+          <a:ln/>
+        </p:spPr>
+        <p:txBody>
+          <a:bodyPr/>
+          <a:lstStyle/>
+          <a:p>
+            <a:endParaRPr lang="en-US"/>
+          </a:p>
+        </p:txBody>
+      </p:sp>
+      <p:pic>
+        <p:nvPicPr>
+          <p:cNvPr id="20" name="Image 2" descr="preencoded.png"/>
+          <p:cNvPicPr>
+            <a:picLocks noChangeAspect="1"/>
+          </p:cNvPicPr>
+          <p:nvPr/>
+        </p:nvPicPr>
+        <p:blipFill>
+          <a:blip r:embed="rId5"/>
+          <a:stretch>
+            <a:fillRect/>
+          </a:stretch>
+        </p:blipFill>
+        <p:spPr>
+          <a:xfrm>
+            <a:off x="4992624" y="1911096"/>
+            <a:ext cx="292608" cy="292608"/>
+          </a:xfrm>
+          <a:prstGeom prst="rect">
+            <a:avLst/>
+          </a:prstGeom>
+        </p:spPr>
+      </p:pic>
+      <p:sp>
+        <p:nvSpPr>
+          <p:cNvPr id="21" name="Text 16"/>
+          <p:cNvSpPr/>
+          <p:nvPr/>
+        </p:nvSpPr>
+        <p:spPr>
+          <a:xfrm>
+            <a:off x="5486400" y="1737360"/>
+            <a:ext cx="3108960" cy="320040"/>
+          </a:xfrm>
+          <a:prstGeom prst="rect">
+            <a:avLst/>
+          </a:prstGeom>
+          <a:noFill/>
+          <a:ln/>
+        </p:spPr>
+        <p:txBody>
+          <a:bodyPr wrap="square" lIns="0" tIns="0" rIns="0" bIns="0" rtlCol="0" anchor="ctr"/>
+          <a:lstStyle/>
+          <a:p>
+            <a:pPr marL="0" indent="0" algn="l">
+              <a:buNone/>
+            </a:pPr>
+            <a:r>
+              <a:rPr lang="en-US" sz="1600" b="1" dirty="0">
+                <a:solidFill>
+                  <a:srgbClr val="0891B2"/>
+                </a:solidFill>
+                <a:latin typeface="Calibri" pitchFamily="34" charset="0"/>
+                <a:ea typeface="Calibri" pitchFamily="34" charset="-122"/>
+                <a:cs typeface="Calibri" pitchFamily="34" charset="-120"/>
+              </a:rPr>
+              <a:t>E5-base</a:t>
+            </a:r>
+            <a:endParaRPr lang="en-US" sz="1600" dirty="0"/>
+          </a:p>
+        </p:txBody>
+      </p:sp>
+      <p:sp>
+        <p:nvSpPr>
+          <p:cNvPr id="22" name="Text 17"/>
+          <p:cNvSpPr/>
+          <p:nvPr/>
+        </p:nvSpPr>
+        <p:spPr>
+          <a:xfrm>
+            <a:off x="5486400" y="2066544"/>
+            <a:ext cx="3108960" cy="228600"/>
+          </a:xfrm>
+          <a:prstGeom prst="rect">
+            <a:avLst/>
+          </a:prstGeom>
+          <a:noFill/>
+          <a:ln/>
+        </p:spPr>
+        <p:txBody>
+          <a:bodyPr wrap="square" lIns="0" tIns="0" rIns="0" bIns="0" rtlCol="0" anchor="ctr"/>
+          <a:lstStyle/>
+          <a:p>
+            <a:pPr marL="0" indent="0" algn="l">
+              <a:buNone/>
+            </a:pPr>
+            <a:r>
+              <a:rPr lang="en-US" sz="1000" b="1" dirty="0">
+                <a:solidFill>
+                  <a:srgbClr val="1E293B"/>
+                </a:solidFill>
+                <a:latin typeface="Calibri" pitchFamily="34" charset="0"/>
+                <a:ea typeface="Calibri" pitchFamily="34" charset="-122"/>
+                <a:cs typeface="Calibri" pitchFamily="34" charset="-120"/>
+              </a:rPr>
+              <a:t>Швидка альтернатива</a:t>
+            </a:r>
+            <a:endParaRPr lang="en-US" sz="1000" dirty="0"/>
+          </a:p>
+        </p:txBody>
+      </p:sp>
+      <p:sp>
+        <p:nvSpPr>
+          <p:cNvPr id="23" name="Text 18"/>
+          <p:cNvSpPr/>
+          <p:nvPr/>
+        </p:nvSpPr>
+        <p:spPr>
+          <a:xfrm>
+            <a:off x="4892040" y="2423160"/>
+            <a:ext cx="3657600" cy="388620"/>
+          </a:xfrm>
+          <a:prstGeom prst="rect">
+            <a:avLst/>
+          </a:prstGeom>
+          <a:noFill/>
+          <a:ln/>
+        </p:spPr>
+        <p:txBody>
+          <a:bodyPr wrap="square" lIns="0" tIns="0" rIns="0" bIns="0" rtlCol="0" anchor="t"/>
+          <a:lstStyle/>
+          <a:p>
+            <a:pPr marL="0" indent="0" algn="l">
+              <a:buNone/>
+            </a:pPr>
+            <a:r>
+              <a:rPr lang="en-US" sz="1000" dirty="0">
+                <a:solidFill>
+                  <a:srgbClr val="475569"/>
+                </a:solidFill>
+                <a:latin typeface="Calibri" pitchFamily="34" charset="0"/>
+                <a:ea typeface="Calibri" pitchFamily="34" charset="-122"/>
+                <a:cs typeface="Calibri" pitchFamily="34" charset="-120"/>
+              </a:rPr>
+              <a:t>Прийнятна якість + ~3× швидше за BGE-M3</a:t>
+            </a:r>
+            <a:endParaRPr lang="en-US" sz="1000" dirty="0"/>
+          </a:p>
+        </p:txBody>
+      </p:sp>
+      <p:sp>
+        <p:nvSpPr>
+          <p:cNvPr id="24" name="Shape 19"/>
+          <p:cNvSpPr/>
+          <p:nvPr/>
+        </p:nvSpPr>
+        <p:spPr>
+          <a:xfrm>
+            <a:off x="411480" y="3040380"/>
+            <a:ext cx="4069080" cy="1257300"/>
+          </a:xfrm>
+          <a:prstGeom prst="roundRect">
+            <a:avLst>
+              <a:gd name="adj" fmla="val 4364"/>
+            </a:avLst>
+          </a:prstGeom>
+          <a:solidFill>
+            <a:srgbClr val="FFFFFF"/>
+          </a:solidFill>
+          <a:ln w="15875">
+            <a:solidFill>
+              <a:srgbClr val="1E40AF"/>
+            </a:solidFill>
+            <a:prstDash val="solid"/>
+          </a:ln>
+        </p:spPr>
+        <p:txBody>
+          <a:bodyPr/>
+          <a:lstStyle/>
+          <a:p>
+            <a:endParaRPr lang="en-US"/>
+          </a:p>
+        </p:txBody>
+      </p:sp>
+      <p:sp>
+        <p:nvSpPr>
+          <p:cNvPr id="25" name="Shape 20"/>
+          <p:cNvSpPr/>
+          <p:nvPr/>
+        </p:nvSpPr>
+        <p:spPr>
+          <a:xfrm>
+            <a:off x="411480" y="3040380"/>
+            <a:ext cx="91440" cy="1257300"/>
+          </a:xfrm>
+          <a:prstGeom prst="rect">
+            <a:avLst/>
+          </a:prstGeom>
+          <a:solidFill>
+            <a:srgbClr val="1E40AF"/>
+          </a:solidFill>
+          <a:ln/>
+        </p:spPr>
+        <p:txBody>
+          <a:bodyPr/>
+          <a:lstStyle/>
+          <a:p>
+            <a:endParaRPr lang="en-US"/>
+          </a:p>
+        </p:txBody>
+      </p:sp>
+      <p:sp>
+        <p:nvSpPr>
+          <p:cNvPr id="26" name="Shape 21"/>
+          <p:cNvSpPr/>
+          <p:nvPr/>
+        </p:nvSpPr>
+        <p:spPr>
+          <a:xfrm>
+            <a:off x="640080" y="3204972"/>
+            <a:ext cx="502920" cy="502920"/>
+          </a:xfrm>
+          <a:prstGeom prst="ellipse">
+            <a:avLst/>
+          </a:prstGeom>
+          <a:solidFill>
+            <a:srgbClr val="1E40AF"/>
+          </a:solidFill>
+          <a:ln/>
+        </p:spPr>
+        <p:txBody>
+          <a:bodyPr/>
+          <a:lstStyle/>
+          <a:p>
+            <a:endParaRPr lang="en-US"/>
+          </a:p>
+        </p:txBody>
+      </p:sp>
+      <p:pic>
+        <p:nvPicPr>
+          <p:cNvPr id="27" name="Image 3" descr="preencoded.png"/>
+          <p:cNvPicPr>
+            <a:picLocks noChangeAspect="1"/>
+          </p:cNvPicPr>
+          <p:nvPr/>
+        </p:nvPicPr>
+        <p:blipFill>
+          <a:blip r:embed="rId6"/>
+          <a:stretch>
+            <a:fillRect/>
+          </a:stretch>
+        </p:blipFill>
+        <p:spPr>
+          <a:xfrm>
+            <a:off x="740664" y="3305556"/>
+            <a:ext cx="292608" cy="292608"/>
+          </a:xfrm>
+          <a:prstGeom prst="rect">
+            <a:avLst/>
+          </a:prstGeom>
+        </p:spPr>
+      </p:pic>
+      <p:sp>
+        <p:nvSpPr>
+          <p:cNvPr id="28" name="Text 22"/>
+          <p:cNvSpPr/>
+          <p:nvPr/>
+        </p:nvSpPr>
+        <p:spPr>
+          <a:xfrm>
+            <a:off x="1234440" y="3131820"/>
+            <a:ext cx="3108960" cy="320040"/>
+          </a:xfrm>
+          <a:prstGeom prst="rect">
+            <a:avLst/>
+          </a:prstGeom>
+          <a:noFill/>
+          <a:ln/>
+        </p:spPr>
+        <p:txBody>
+          <a:bodyPr wrap="square" lIns="0" tIns="0" rIns="0" bIns="0" rtlCol="0" anchor="ctr"/>
+          <a:lstStyle/>
+          <a:p>
+            <a:pPr marL="0" indent="0" algn="l">
+              <a:buNone/>
+            </a:pPr>
+            <a:r>
+              <a:rPr lang="en-US" sz="1600" b="1" dirty="0">
+                <a:solidFill>
+                  <a:srgbClr val="1E40AF"/>
+                </a:solidFill>
+                <a:latin typeface="Calibri" pitchFamily="34" charset="0"/>
+                <a:ea typeface="Calibri" pitchFamily="34" charset="-122"/>
+                <a:cs typeface="Calibri" pitchFamily="34" charset="-120"/>
+              </a:rPr>
+              <a:t>Qwen3</a:t>
+            </a:r>
+            <a:endParaRPr lang="en-US" sz="1600" dirty="0"/>
+          </a:p>
+        </p:txBody>
+      </p:sp>
+      <p:sp>
+        <p:nvSpPr>
+          <p:cNvPr id="29" name="Text 23"/>
+          <p:cNvSpPr/>
+          <p:nvPr/>
+        </p:nvSpPr>
+        <p:spPr>
+          <a:xfrm>
+            <a:off x="1234440" y="3461004"/>
+            <a:ext cx="3108960" cy="228600"/>
+          </a:xfrm>
+          <a:prstGeom prst="rect">
+            <a:avLst/>
+          </a:prstGeom>
+          <a:noFill/>
+          <a:ln/>
+        </p:spPr>
+        <p:txBody>
+          <a:bodyPr wrap="square" lIns="0" tIns="0" rIns="0" bIns="0" rtlCol="0" anchor="ctr"/>
+          <a:lstStyle/>
+          <a:p>
+            <a:pPr marL="0" indent="0" algn="l">
+              <a:buNone/>
+            </a:pPr>
+            <a:r>
+              <a:rPr lang="en-US" sz="1000" b="1" dirty="0">
+                <a:solidFill>
+                  <a:srgbClr val="1E293B"/>
+                </a:solidFill>
+                <a:latin typeface="Calibri" pitchFamily="34" charset="0"/>
+                <a:ea typeface="Calibri" pitchFamily="34" charset="-122"/>
+                <a:cs typeface="Calibri" pitchFamily="34" charset="-120"/>
+              </a:rPr>
+              <a:t>Лідер на юридичному домені</a:t>
+            </a:r>
+            <a:endParaRPr lang="en-US" sz="1000" dirty="0"/>
+          </a:p>
+        </p:txBody>
+      </p:sp>
+      <p:sp>
+        <p:nvSpPr>
+          <p:cNvPr id="30" name="Text 24"/>
+          <p:cNvSpPr/>
+          <p:nvPr/>
+        </p:nvSpPr>
+        <p:spPr>
+          <a:xfrm>
+            <a:off x="640080" y="3817620"/>
+            <a:ext cx="3657600" cy="388620"/>
+          </a:xfrm>
+          <a:prstGeom prst="rect">
+            <a:avLst/>
+          </a:prstGeom>
+          <a:noFill/>
+          <a:ln/>
+        </p:spPr>
+        <p:txBody>
+          <a:bodyPr wrap="square" lIns="0" tIns="0" rIns="0" bIns="0" rtlCol="0" anchor="t"/>
+          <a:lstStyle/>
+          <a:p>
+            <a:pPr marL="0" indent="0" algn="l">
+              <a:buNone/>
+            </a:pPr>
+            <a:r>
+              <a:rPr lang="en-US" sz="1000" dirty="0">
+                <a:solidFill>
+                  <a:srgbClr val="475569"/>
+                </a:solidFill>
+                <a:latin typeface="Calibri" pitchFamily="34" charset="0"/>
+                <a:ea typeface="Calibri" pitchFamily="34" charset="-122"/>
+                <a:cs typeface="Calibri" pitchFamily="34" charset="-120"/>
+              </a:rPr>
+              <a:t>Найвища nDCG@10 на Legal (0.320), ~2× повільніший</a:t>
+            </a:r>
+            <a:endParaRPr lang="en-US" sz="1000" dirty="0"/>
+          </a:p>
+        </p:txBody>
+      </p:sp>
+      <p:sp>
+        <p:nvSpPr>
+          <p:cNvPr id="31" name="Shape 25"/>
+          <p:cNvSpPr/>
+          <p:nvPr/>
+        </p:nvSpPr>
+        <p:spPr>
+          <a:xfrm>
+            <a:off x="4663440" y="3040380"/>
+            <a:ext cx="4069080" cy="1257300"/>
+          </a:xfrm>
+          <a:prstGeom prst="roundRect">
+            <a:avLst>
+              <a:gd name="adj" fmla="val 4364"/>
+            </a:avLst>
+          </a:prstGeom>
+          <a:solidFill>
+            <a:srgbClr val="FFFFFF"/>
+          </a:solidFill>
+          <a:ln w="15875">
+            <a:solidFill>
+              <a:srgbClr val="64748B"/>
+            </a:solidFill>
+            <a:prstDash val="solid"/>
+          </a:ln>
+        </p:spPr>
+        <p:txBody>
+          <a:bodyPr/>
+          <a:lstStyle/>
+          <a:p>
+            <a:endParaRPr lang="en-US"/>
+          </a:p>
+        </p:txBody>
+      </p:sp>
+      <p:sp>
+        <p:nvSpPr>
+          <p:cNvPr id="32" name="Shape 26"/>
+          <p:cNvSpPr/>
+          <p:nvPr/>
+        </p:nvSpPr>
+        <p:spPr>
+          <a:xfrm>
+            <a:off x="4663440" y="3040380"/>
+            <a:ext cx="91440" cy="1257300"/>
+          </a:xfrm>
+          <a:prstGeom prst="rect">
+            <a:avLst/>
+          </a:prstGeom>
+          <a:solidFill>
+            <a:srgbClr val="64748B"/>
+          </a:solidFill>
+          <a:ln/>
+        </p:spPr>
+        <p:txBody>
+          <a:bodyPr/>
+          <a:lstStyle/>
+          <a:p>
+            <a:endParaRPr lang="en-US"/>
+          </a:p>
+        </p:txBody>
+      </p:sp>
+      <p:sp>
+        <p:nvSpPr>
+          <p:cNvPr id="33" name="Shape 27"/>
+          <p:cNvSpPr/>
+          <p:nvPr/>
+        </p:nvSpPr>
+        <p:spPr>
+          <a:xfrm>
+            <a:off x="4892040" y="3204972"/>
+            <a:ext cx="502920" cy="502920"/>
+          </a:xfrm>
+          <a:prstGeom prst="ellipse">
+            <a:avLst/>
+          </a:prstGeom>
+          <a:solidFill>
+            <a:srgbClr val="64748B"/>
+          </a:solidFill>
+          <a:ln/>
+        </p:spPr>
+        <p:txBody>
+          <a:bodyPr/>
+          <a:lstStyle/>
+          <a:p>
+            <a:endParaRPr lang="en-US"/>
+          </a:p>
+        </p:txBody>
+      </p:sp>
+      <p:pic>
+        <p:nvPicPr>
+          <p:cNvPr id="34" name="Image 4" descr="preencoded.png"/>
+          <p:cNvPicPr>
+            <a:picLocks noChangeAspect="1"/>
+          </p:cNvPicPr>
+          <p:nvPr/>
+        </p:nvPicPr>
+        <p:blipFill>
+          <a:blip r:embed="rId7"/>
+          <a:stretch>
+            <a:fillRect/>
+          </a:stretch>
+        </p:blipFill>
+        <p:spPr>
+          <a:xfrm>
+            <a:off x="4992624" y="3305556"/>
+            <a:ext cx="292608" cy="292608"/>
+          </a:xfrm>
+          <a:prstGeom prst="rect">
+            <a:avLst/>
+          </a:prstGeom>
+        </p:spPr>
+      </p:pic>
+      <p:sp>
+        <p:nvSpPr>
+          <p:cNvPr id="35" name="Text 28"/>
+          <p:cNvSpPr/>
+          <p:nvPr/>
+        </p:nvSpPr>
+        <p:spPr>
+          <a:xfrm>
+            <a:off x="5486400" y="3131820"/>
+            <a:ext cx="3108960" cy="320040"/>
+          </a:xfrm>
+          <a:prstGeom prst="rect">
+            <a:avLst/>
+          </a:prstGeom>
+          <a:noFill/>
+          <a:ln/>
+        </p:spPr>
+        <p:txBody>
+          <a:bodyPr wrap="square" lIns="0" tIns="0" rIns="0" bIns="0" rtlCol="0" anchor="ctr"/>
+          <a:lstStyle/>
+          <a:p>
+            <a:pPr marL="0" indent="0" algn="l">
+              <a:buNone/>
+            </a:pPr>
+            <a:r>
+              <a:rPr lang="en-US" sz="1600" b="1" dirty="0">
+                <a:solidFill>
+                  <a:srgbClr val="64748B"/>
+                </a:solidFill>
+                <a:latin typeface="Calibri" pitchFamily="34" charset="0"/>
+                <a:ea typeface="Calibri" pitchFamily="34" charset="-122"/>
+                <a:cs typeface="Calibri" pitchFamily="34" charset="-120"/>
+              </a:rPr>
+              <a:t>BM25</a:t>
+            </a:r>
+            <a:endParaRPr lang="en-US" sz="1600" dirty="0"/>
+          </a:p>
+        </p:txBody>
+      </p:sp>
+      <p:sp>
+        <p:nvSpPr>
+          <p:cNvPr id="36" name="Text 29"/>
+          <p:cNvSpPr/>
+          <p:nvPr/>
+        </p:nvSpPr>
+        <p:spPr>
+          <a:xfrm>
+            <a:off x="5486400" y="3461004"/>
+            <a:ext cx="3108960" cy="228600"/>
+          </a:xfrm>
+          <a:prstGeom prst="rect">
+            <a:avLst/>
+          </a:prstGeom>
+          <a:noFill/>
+          <a:ln/>
+        </p:spPr>
+        <p:txBody>
+          <a:bodyPr wrap="square" lIns="0" tIns="0" rIns="0" bIns="0" rtlCol="0" anchor="ctr"/>
+          <a:lstStyle/>
+          <a:p>
+            <a:pPr marL="0" indent="0" algn="l">
+              <a:buNone/>
+            </a:pPr>
+            <a:r>
+              <a:rPr lang="en-US" sz="1000" b="1" dirty="0">
+                <a:solidFill>
+                  <a:srgbClr val="1E293B"/>
+                </a:solidFill>
+                <a:latin typeface="Calibri" pitchFamily="34" charset="0"/>
+                <a:ea typeface="Calibri" pitchFamily="34" charset="-122"/>
+                <a:cs typeface="Calibri" pitchFamily="34" charset="-120"/>
+              </a:rPr>
+              <a:t>Конкурентний baseline</a:t>
+            </a:r>
+            <a:endParaRPr lang="en-US" sz="1000" dirty="0"/>
+          </a:p>
+        </p:txBody>
+      </p:sp>
+      <p:sp>
+        <p:nvSpPr>
+          <p:cNvPr id="37" name="Text 30"/>
+          <p:cNvSpPr/>
+          <p:nvPr/>
+        </p:nvSpPr>
+        <p:spPr>
+          <a:xfrm>
+            <a:off x="4892040" y="3817620"/>
+            <a:ext cx="3657600" cy="388620"/>
+          </a:xfrm>
+          <a:prstGeom prst="rect">
+            <a:avLst/>
+          </a:prstGeom>
+          <a:noFill/>
+          <a:ln/>
+        </p:spPr>
+        <p:txBody>
+          <a:bodyPr wrap="square" lIns="0" tIns="0" rIns="0" bIns="0" rtlCol="0" anchor="t"/>
+          <a:lstStyle/>
+          <a:p>
+            <a:pPr marL="0" indent="0" algn="l">
+              <a:buNone/>
+            </a:pPr>
+            <a:r>
+              <a:rPr lang="en-US" sz="1000" dirty="0">
+                <a:solidFill>
+                  <a:srgbClr val="475569"/>
+                </a:solidFill>
+                <a:latin typeface="Calibri" pitchFamily="34" charset="0"/>
+                <a:ea typeface="Calibri" pitchFamily="34" charset="-122"/>
+                <a:cs typeface="Calibri" pitchFamily="34" charset="-120"/>
+              </a:rPr>
+              <a:t>Найшвидша (1–3 мс/запит) — у &gt;100× швидше за BGE-M3</a:t>
+            </a:r>
+            <a:endParaRPr lang="en-US" sz="1000" dirty="0"/>
+          </a:p>
+        </p:txBody>
+      </p:sp>
+      <p:pic>
+        <p:nvPicPr>
+          <p:cNvPr id="39" name="Image 5" descr="D:\repos\kb-semantic-search-benchmark\thesis\scripts\_logo_hex.png"/>
+          <p:cNvPicPr>
+            <a:picLocks noChangeAspect="1"/>
+          </p:cNvPicPr>
+          <p:nvPr/>
+        </p:nvPicPr>
+        <p:blipFill>
+          <a:blip r:embed="rId8"/>
+          <a:stretch>
+            <a:fillRect/>
+          </a:stretch>
+        </p:blipFill>
+        <p:spPr>
+          <a:xfrm>
+            <a:off x="411480" y="4686300"/>
+            <a:ext cx="502920" cy="338328"/>
+          </a:xfrm>
+          <a:prstGeom prst="rect">
+            <a:avLst/>
+          </a:prstGeom>
+        </p:spPr>
+      </p:pic>
+      <p:sp>
+        <p:nvSpPr>
+          <p:cNvPr id="40" name="Text 32"/>
+          <p:cNvSpPr/>
+          <p:nvPr/>
+        </p:nvSpPr>
+        <p:spPr>
+          <a:xfrm>
+            <a:off x="7955280" y="4850892"/>
+            <a:ext cx="960120" cy="228600"/>
+          </a:xfrm>
+          <a:prstGeom prst="rect">
+            <a:avLst/>
+          </a:prstGeom>
+          <a:noFill/>
+          <a:ln/>
+        </p:spPr>
+        <p:txBody>
+          <a:bodyPr wrap="square" lIns="0" tIns="0" rIns="0" bIns="0" rtlCol="0" anchor="ctr"/>
+          <a:lstStyle/>
+          <a:p>
+            <a:pPr marL="0" indent="0" algn="r">
+              <a:buNone/>
+            </a:pPr>
+            <a:r>
+              <a:rPr lang="en-US" sz="900" dirty="0">
+                <a:solidFill>
+                  <a:srgbClr val="64748B"/>
+                </a:solidFill>
+                <a:latin typeface="Calibri" pitchFamily="34" charset="0"/>
+                <a:ea typeface="Calibri" pitchFamily="34" charset="-122"/>
+                <a:cs typeface="Calibri" pitchFamily="34" charset="-120"/>
+              </a:rPr>
+              <a:t>1</a:t>
+            </a:r>
+            <a:r>
+              <a:rPr lang="uk-UA" sz="900" dirty="0">
+                <a:solidFill>
+                  <a:srgbClr val="64748B"/>
+                </a:solidFill>
+                <a:latin typeface="Calibri" pitchFamily="34" charset="0"/>
+                <a:ea typeface="Calibri" pitchFamily="34" charset="-122"/>
+                <a:cs typeface="Calibri" pitchFamily="34" charset="-120"/>
+              </a:rPr>
+              <a:t>7</a:t>
+            </a:r>
+            <a:r>
+              <a:rPr lang="en-US" sz="900" dirty="0">
+                <a:solidFill>
+                  <a:srgbClr val="64748B"/>
+                </a:solidFill>
+                <a:latin typeface="Calibri" pitchFamily="34" charset="0"/>
+                <a:ea typeface="Calibri" pitchFamily="34" charset="-122"/>
+                <a:cs typeface="Calibri" pitchFamily="34" charset="-120"/>
+              </a:rPr>
+              <a:t> / 18</a:t>
+            </a:r>
+            <a:endParaRPr lang="en-US" sz="900" dirty="0"/>
+          </a:p>
+        </p:txBody>
+      </p:sp>
+    </p:spTree>
+  </p:cSld>
+  <p:clrMapOvr>
+    <a:masterClrMapping/>
+  </p:clrMapOvr>
+</p:sld>
+</file>
+
+<file path=ppt/slides/slide18.xml><?xml version="1.0" encoding="utf-8"?>
+<p:sld xmlns:a="http://schemas.openxmlformats.org/drawingml/2006/main" xmlns:r="http://schemas.openxmlformats.org/officeDocument/2006/relationships" xmlns:p="http://schemas.openxmlformats.org/presentationml/2006/main">
   <p:cSld name="Slide 17">
     <p:bg>
       <p:bgPr>
@@ -19440,127 +20815,10 @@
                 <a:ea typeface="Calibri" pitchFamily="34" charset="-122"/>
                 <a:cs typeface="Calibri" pitchFamily="34" charset="-120"/>
               </a:rPr>
-              <a:t>17 / 18</a:t>
-            </a:r>
-            <a:endParaRPr lang="en-US" sz="900" dirty="0"/>
-          </a:p>
-        </p:txBody>
-      </p:sp>
-    </p:spTree>
-  </p:cSld>
-  <p:clrMapOvr>
-    <a:masterClrMapping/>
-  </p:clrMapOvr>
-</p:sld>
-</file>
-
-<file path=ppt/slides/slide18.xml><?xml version="1.0" encoding="utf-8"?>
-<p:sld xmlns:a="http://schemas.openxmlformats.org/drawingml/2006/main" xmlns:r="http://schemas.openxmlformats.org/officeDocument/2006/relationships" xmlns:p="http://schemas.openxmlformats.org/presentationml/2006/main">
-  <p:cSld name="Slide 18">
-    <p:bg>
-      <p:bgPr>
-        <a:solidFill>
-          <a:srgbClr val="FFFFFF"/>
-        </a:solidFill>
-        <a:effectLst/>
-      </p:bgPr>
-    </p:bg>
-    <p:spTree>
-      <p:nvGrpSpPr>
-        <p:cNvPr id="1" name=""/>
-        <p:cNvGrpSpPr/>
-        <p:nvPr/>
-      </p:nvGrpSpPr>
-      <p:grpSpPr>
-        <a:xfrm>
-          <a:off x="0" y="0"/>
-          <a:ext cx="0" cy="0"/>
-          <a:chOff x="0" y="0"/>
-          <a:chExt cx="0" cy="0"/>
-        </a:xfrm>
-      </p:grpSpPr>
-      <p:sp>
-        <p:nvSpPr>
-          <p:cNvPr id="2" name="Shape 0"/>
-          <p:cNvSpPr/>
-          <p:nvPr/>
-        </p:nvSpPr>
-        <p:spPr>
-          <a:xfrm>
-            <a:off x="-914400" y="-914400"/>
-            <a:ext cx="3657600" cy="3657600"/>
-          </a:xfrm>
-          <a:prstGeom prst="ellipse">
-            <a:avLst/>
-          </a:prstGeom>
-          <a:solidFill>
-            <a:srgbClr val="EFF6FF"/>
-          </a:solidFill>
-          <a:ln/>
-        </p:spPr>
-        <p:txBody>
-          <a:bodyPr/>
-          <a:lstStyle/>
-          <a:p>
-            <a:endParaRPr lang="en-US"/>
-          </a:p>
-        </p:txBody>
-      </p:sp>
-      <p:sp>
-        <p:nvSpPr>
-          <p:cNvPr id="3" name="Shape 1"/>
-          <p:cNvSpPr/>
-          <p:nvPr/>
-        </p:nvSpPr>
-        <p:spPr>
-          <a:xfrm>
-            <a:off x="7315200" y="3657600"/>
-            <a:ext cx="3200400" cy="3200400"/>
-          </a:xfrm>
-          <a:prstGeom prst="ellipse">
-            <a:avLst/>
-          </a:prstGeom>
-          <a:solidFill>
-            <a:srgbClr val="F59E0B">
-              <a:alpha val="20000"/>
-            </a:srgbClr>
-          </a:solidFill>
-          <a:ln/>
-        </p:spPr>
-        <p:txBody>
-          <a:bodyPr/>
-          <a:lstStyle/>
-          <a:p>
-            <a:endParaRPr lang="en-US"/>
-          </a:p>
-        </p:txBody>
-      </p:sp>
-      <p:sp>
-        <p:nvSpPr>
-          <p:cNvPr id="4" name="Text 2"/>
-          <p:cNvSpPr/>
-          <p:nvPr/>
-        </p:nvSpPr>
-        <p:spPr>
-          <a:xfrm>
-            <a:off x="411480" y="91440"/>
-            <a:ext cx="8321040" cy="182880"/>
-          </a:xfrm>
-          <a:prstGeom prst="rect">
-            <a:avLst/>
-          </a:prstGeom>
-          <a:noFill/>
-          <a:ln/>
-        </p:spPr>
-        <p:txBody>
-          <a:bodyPr wrap="square" lIns="0" tIns="0" rIns="0" bIns="0" rtlCol="0" anchor="ctr"/>
-          <a:lstStyle/>
-          <a:p>
-            <a:pPr marL="0" indent="0" algn="l">
-              <a:buNone/>
-            </a:pPr>
-            <a:r>
-              <a:rPr lang="en-US" sz="850" b="1" kern="0" spc="300" dirty="0">
+              <a:t>1</a:t>
+            </a:r>
+            <a:r>
+              <a:rPr lang="uk-UA" sz="900" dirty="0">
                 <a:solidFill>
                   <a:srgbClr val="64748B"/>
                 </a:solidFill>
@@ -19568,1029 +20826,10 @@
                 <a:ea typeface="Calibri" pitchFamily="34" charset="-122"/>
                 <a:cs typeface="Calibri" pitchFamily="34" charset="-120"/>
               </a:rPr>
-              <a:t>РОЗДІЛ 11 · ПІДСУМКИ</a:t>
-            </a:r>
-            <a:endParaRPr lang="en-US" sz="850" dirty="0"/>
-          </a:p>
-        </p:txBody>
-      </p:sp>
-      <p:sp>
-        <p:nvSpPr>
-          <p:cNvPr id="5" name="Shape 3"/>
-          <p:cNvSpPr/>
-          <p:nvPr/>
-        </p:nvSpPr>
-        <p:spPr>
-          <a:xfrm>
-            <a:off x="411480" y="420624"/>
-            <a:ext cx="201168" cy="201168"/>
-          </a:xfrm>
-          <a:prstGeom prst="ellipse">
-            <a:avLst/>
-          </a:prstGeom>
-          <a:solidFill>
-            <a:srgbClr val="F59E0B"/>
-          </a:solidFill>
-          <a:ln/>
-        </p:spPr>
-        <p:txBody>
-          <a:bodyPr/>
-          <a:lstStyle/>
-          <a:p>
-            <a:endParaRPr lang="en-US"/>
-          </a:p>
-        </p:txBody>
-      </p:sp>
-      <p:sp>
-        <p:nvSpPr>
-          <p:cNvPr id="6" name="Text 4"/>
-          <p:cNvSpPr/>
-          <p:nvPr/>
-        </p:nvSpPr>
-        <p:spPr>
-          <a:xfrm>
-            <a:off x="722376" y="292608"/>
-            <a:ext cx="6858000" cy="502920"/>
-          </a:xfrm>
-          <a:prstGeom prst="rect">
-            <a:avLst/>
-          </a:prstGeom>
-          <a:noFill/>
-          <a:ln/>
-        </p:spPr>
-        <p:txBody>
-          <a:bodyPr wrap="square" lIns="0" tIns="0" rIns="0" bIns="0" rtlCol="0" anchor="ctr"/>
-          <a:lstStyle/>
-          <a:p>
-            <a:pPr marL="0" indent="0" algn="l">
-              <a:buNone/>
-            </a:pPr>
-            <a:r>
-              <a:rPr lang="en-US" sz="2200" b="1" dirty="0">
-                <a:solidFill>
-                  <a:srgbClr val="0F172A"/>
-                </a:solidFill>
-                <a:latin typeface="Calibri" pitchFamily="34" charset="0"/>
-                <a:ea typeface="Calibri" pitchFamily="34" charset="-122"/>
-                <a:cs typeface="Calibri" pitchFamily="34" charset="-120"/>
-              </a:rPr>
-              <a:t>Підсумки та практичні рекомендації</a:t>
-            </a:r>
-            <a:endParaRPr lang="en-US" sz="2200" dirty="0"/>
-          </a:p>
-        </p:txBody>
-      </p:sp>
-      <p:sp>
-        <p:nvSpPr>
-          <p:cNvPr id="7" name="Shape 5"/>
-          <p:cNvSpPr/>
-          <p:nvPr/>
-        </p:nvSpPr>
-        <p:spPr>
-          <a:xfrm>
-            <a:off x="411480" y="960120"/>
-            <a:ext cx="8321040" cy="502920"/>
-          </a:xfrm>
-          <a:prstGeom prst="roundRect">
-            <a:avLst>
-              <a:gd name="adj" fmla="val 10909"/>
-            </a:avLst>
-          </a:prstGeom>
-          <a:solidFill>
-            <a:srgbClr val="F59E0B"/>
-          </a:solidFill>
-          <a:ln w="9525">
-            <a:solidFill>
-              <a:srgbClr val="F59E0B"/>
-            </a:solidFill>
-            <a:prstDash val="solid"/>
-          </a:ln>
-          <a:effectLst>
-            <a:outerShdw blurRad="76200" dist="12700" dir="5400000" algn="bl" rotWithShape="0">
-              <a:srgbClr val="000000">
-                <a:alpha val="7000"/>
-              </a:srgbClr>
-            </a:outerShdw>
-          </a:effectLst>
-        </p:spPr>
-        <p:txBody>
-          <a:bodyPr/>
-          <a:lstStyle/>
-          <a:p>
-            <a:endParaRPr lang="en-US"/>
-          </a:p>
-        </p:txBody>
-      </p:sp>
-      <p:pic>
-        <p:nvPicPr>
-          <p:cNvPr id="8" name="Image 0" descr="preencoded.png"/>
-          <p:cNvPicPr>
-            <a:picLocks noChangeAspect="1"/>
-          </p:cNvPicPr>
-          <p:nvPr/>
-        </p:nvPicPr>
-        <p:blipFill>
-          <a:blip r:embed="rId3"/>
-          <a:stretch>
-            <a:fillRect/>
-          </a:stretch>
-        </p:blipFill>
-        <p:spPr>
-          <a:xfrm>
-            <a:off x="594360" y="1078992"/>
-            <a:ext cx="274320" cy="274320"/>
-          </a:xfrm>
-          <a:prstGeom prst="rect">
-            <a:avLst/>
-          </a:prstGeom>
-        </p:spPr>
-      </p:pic>
-      <p:sp>
-        <p:nvSpPr>
-          <p:cNvPr id="9" name="Text 6"/>
-          <p:cNvSpPr/>
-          <p:nvPr/>
-        </p:nvSpPr>
-        <p:spPr>
-          <a:xfrm>
-            <a:off x="1005840" y="960120"/>
-            <a:ext cx="7635240" cy="502920"/>
-          </a:xfrm>
-          <a:prstGeom prst="rect">
-            <a:avLst/>
-          </a:prstGeom>
-          <a:noFill/>
-          <a:ln/>
-        </p:spPr>
-        <p:txBody>
-          <a:bodyPr wrap="square" lIns="0" tIns="0" rIns="0" bIns="0" rtlCol="0" anchor="ctr"/>
-          <a:lstStyle/>
-          <a:p>
-            <a:pPr marL="0" indent="0" algn="l">
-              <a:buNone/>
-            </a:pPr>
-            <a:r>
-              <a:rPr lang="uk-UA" sz="1100" b="1" dirty="0">
-                <a:solidFill>
-                  <a:srgbClr val="0F172A"/>
-                </a:solidFill>
-                <a:latin typeface="Calibri" pitchFamily="34" charset="0"/>
-                <a:ea typeface="Calibri" pitchFamily="34" charset="-122"/>
-                <a:cs typeface="Calibri" pitchFamily="34" charset="-120"/>
-              </a:rPr>
-              <a:t>О</a:t>
-            </a:r>
-            <a:r>
-              <a:rPr lang="en-US" sz="1100" b="1" dirty="0" err="1">
-                <a:solidFill>
-                  <a:srgbClr val="0F172A"/>
-                </a:solidFill>
-                <a:latin typeface="Calibri" pitchFamily="34" charset="0"/>
-                <a:ea typeface="Calibri" pitchFamily="34" charset="-122"/>
-                <a:cs typeface="Calibri" pitchFamily="34" charset="-120"/>
-              </a:rPr>
-              <a:t>бґрунтовано</a:t>
-            </a:r>
-            <a:r>
-              <a:rPr lang="en-US" sz="1100" b="1" dirty="0">
-                <a:solidFill>
-                  <a:srgbClr val="0F172A"/>
-                </a:solidFill>
-                <a:latin typeface="Calibri" pitchFamily="34" charset="0"/>
-                <a:ea typeface="Calibri" pitchFamily="34" charset="-122"/>
-                <a:cs typeface="Calibri" pitchFamily="34" charset="-120"/>
-              </a:rPr>
-              <a:t> доцільність застосування embedding-моделей для семантичного пошуку у корпоративних базах знань</a:t>
-            </a:r>
-            <a:endParaRPr lang="en-US" sz="1100" dirty="0"/>
-          </a:p>
-        </p:txBody>
-      </p:sp>
-      <p:sp>
-        <p:nvSpPr>
-          <p:cNvPr id="10" name="Shape 7"/>
-          <p:cNvSpPr/>
-          <p:nvPr/>
-        </p:nvSpPr>
-        <p:spPr>
-          <a:xfrm>
-            <a:off x="411480" y="1645920"/>
-            <a:ext cx="4069080" cy="1257300"/>
-          </a:xfrm>
-          <a:prstGeom prst="roundRect">
-            <a:avLst>
-              <a:gd name="adj" fmla="val 4364"/>
-            </a:avLst>
-          </a:prstGeom>
-          <a:solidFill>
-            <a:srgbClr val="FFFFFF"/>
-          </a:solidFill>
-          <a:ln w="15875">
-            <a:solidFill>
-              <a:srgbClr val="F59E0B"/>
-            </a:solidFill>
-            <a:prstDash val="solid"/>
-          </a:ln>
-        </p:spPr>
-        <p:txBody>
-          <a:bodyPr/>
-          <a:lstStyle/>
-          <a:p>
-            <a:endParaRPr lang="en-US"/>
-          </a:p>
-        </p:txBody>
-      </p:sp>
-      <p:sp>
-        <p:nvSpPr>
-          <p:cNvPr id="11" name="Shape 8"/>
-          <p:cNvSpPr/>
-          <p:nvPr/>
-        </p:nvSpPr>
-        <p:spPr>
-          <a:xfrm>
-            <a:off x="411480" y="1645920"/>
-            <a:ext cx="91440" cy="1257300"/>
-          </a:xfrm>
-          <a:prstGeom prst="rect">
-            <a:avLst/>
-          </a:prstGeom>
-          <a:solidFill>
-            <a:srgbClr val="F59E0B"/>
-          </a:solidFill>
-          <a:ln/>
-        </p:spPr>
-        <p:txBody>
-          <a:bodyPr/>
-          <a:lstStyle/>
-          <a:p>
-            <a:endParaRPr lang="en-US"/>
-          </a:p>
-        </p:txBody>
-      </p:sp>
-      <p:sp>
-        <p:nvSpPr>
-          <p:cNvPr id="12" name="Shape 9"/>
-          <p:cNvSpPr/>
-          <p:nvPr/>
-        </p:nvSpPr>
-        <p:spPr>
-          <a:xfrm>
-            <a:off x="640080" y="1810512"/>
-            <a:ext cx="502920" cy="502920"/>
-          </a:xfrm>
-          <a:prstGeom prst="ellipse">
-            <a:avLst/>
-          </a:prstGeom>
-          <a:solidFill>
-            <a:srgbClr val="F59E0B"/>
-          </a:solidFill>
-          <a:ln/>
-        </p:spPr>
-        <p:txBody>
-          <a:bodyPr/>
-          <a:lstStyle/>
-          <a:p>
-            <a:endParaRPr lang="en-US"/>
-          </a:p>
-        </p:txBody>
-      </p:sp>
-      <p:pic>
-        <p:nvPicPr>
-          <p:cNvPr id="13" name="Image 1" descr="preencoded.png"/>
-          <p:cNvPicPr>
-            <a:picLocks noChangeAspect="1"/>
-          </p:cNvPicPr>
-          <p:nvPr/>
-        </p:nvPicPr>
-        <p:blipFill>
-          <a:blip r:embed="rId4"/>
-          <a:stretch>
-            <a:fillRect/>
-          </a:stretch>
-        </p:blipFill>
-        <p:spPr>
-          <a:xfrm>
-            <a:off x="740664" y="1911096"/>
-            <a:ext cx="292608" cy="292608"/>
-          </a:xfrm>
-          <a:prstGeom prst="rect">
-            <a:avLst/>
-          </a:prstGeom>
-        </p:spPr>
-      </p:pic>
-      <p:sp>
-        <p:nvSpPr>
-          <p:cNvPr id="14" name="Text 10"/>
-          <p:cNvSpPr/>
-          <p:nvPr/>
-        </p:nvSpPr>
-        <p:spPr>
-          <a:xfrm>
-            <a:off x="1234440" y="1737360"/>
-            <a:ext cx="3108960" cy="320040"/>
-          </a:xfrm>
-          <a:prstGeom prst="rect">
-            <a:avLst/>
-          </a:prstGeom>
-          <a:noFill/>
-          <a:ln/>
-        </p:spPr>
-        <p:txBody>
-          <a:bodyPr wrap="square" lIns="0" tIns="0" rIns="0" bIns="0" rtlCol="0" anchor="ctr"/>
-          <a:lstStyle/>
-          <a:p>
-            <a:pPr marL="0" indent="0" algn="l">
-              <a:buNone/>
-            </a:pPr>
-            <a:r>
-              <a:rPr lang="en-US" sz="1600" b="1" dirty="0">
-                <a:solidFill>
-                  <a:srgbClr val="F59E0B"/>
-                </a:solidFill>
-                <a:latin typeface="Calibri" pitchFamily="34" charset="0"/>
-                <a:ea typeface="Calibri" pitchFamily="34" charset="-122"/>
-                <a:cs typeface="Calibri" pitchFamily="34" charset="-120"/>
-              </a:rPr>
-              <a:t>BGE-M3</a:t>
-            </a:r>
-            <a:endParaRPr lang="en-US" sz="1600" dirty="0"/>
-          </a:p>
-        </p:txBody>
-      </p:sp>
-      <p:sp>
-        <p:nvSpPr>
-          <p:cNvPr id="15" name="Text 11"/>
-          <p:cNvSpPr/>
-          <p:nvPr/>
-        </p:nvSpPr>
-        <p:spPr>
-          <a:xfrm>
-            <a:off x="1234440" y="2066544"/>
-            <a:ext cx="3108960" cy="228600"/>
-          </a:xfrm>
-          <a:prstGeom prst="rect">
-            <a:avLst/>
-          </a:prstGeom>
-          <a:noFill/>
-          <a:ln/>
-        </p:spPr>
-        <p:txBody>
-          <a:bodyPr wrap="square" lIns="0" tIns="0" rIns="0" bIns="0" rtlCol="0" anchor="ctr"/>
-          <a:lstStyle/>
-          <a:p>
-            <a:pPr marL="0" indent="0" algn="l">
-              <a:buNone/>
-            </a:pPr>
-            <a:r>
-              <a:rPr lang="en-US" sz="1000" b="1" dirty="0">
-                <a:solidFill>
-                  <a:srgbClr val="1E293B"/>
-                </a:solidFill>
-                <a:latin typeface="Calibri" pitchFamily="34" charset="0"/>
-                <a:ea typeface="Calibri" pitchFamily="34" charset="-122"/>
-                <a:cs typeface="Calibri" pitchFamily="34" charset="-120"/>
-              </a:rPr>
-              <a:t>Основна модель для впровадження</a:t>
-            </a:r>
-            <a:endParaRPr lang="en-US" sz="1000" dirty="0"/>
-          </a:p>
-        </p:txBody>
-      </p:sp>
-      <p:sp>
-        <p:nvSpPr>
-          <p:cNvPr id="16" name="Text 12"/>
-          <p:cNvSpPr/>
-          <p:nvPr/>
-        </p:nvSpPr>
-        <p:spPr>
-          <a:xfrm>
-            <a:off x="640080" y="2423160"/>
-            <a:ext cx="3657600" cy="388620"/>
-          </a:xfrm>
-          <a:prstGeom prst="rect">
-            <a:avLst/>
-          </a:prstGeom>
-          <a:noFill/>
-          <a:ln/>
-        </p:spPr>
-        <p:txBody>
-          <a:bodyPr wrap="square" lIns="0" tIns="0" rIns="0" bIns="0" rtlCol="0" anchor="t"/>
-          <a:lstStyle/>
-          <a:p>
-            <a:pPr marL="0" indent="0" algn="l">
-              <a:buNone/>
-            </a:pPr>
-            <a:r>
-              <a:rPr lang="en-US" sz="1000" dirty="0">
-                <a:solidFill>
-                  <a:srgbClr val="475569"/>
-                </a:solidFill>
-                <a:latin typeface="Calibri" pitchFamily="34" charset="0"/>
-                <a:ea typeface="Calibri" pitchFamily="34" charset="-122"/>
-                <a:cs typeface="Calibri" pitchFamily="34" charset="-120"/>
-              </a:rPr>
-              <a:t>Найкраща якість, стабільність у різних доменах</a:t>
-            </a:r>
-            <a:endParaRPr lang="en-US" sz="1000" dirty="0"/>
-          </a:p>
-        </p:txBody>
-      </p:sp>
-      <p:sp>
-        <p:nvSpPr>
-          <p:cNvPr id="17" name="Shape 13"/>
-          <p:cNvSpPr/>
-          <p:nvPr/>
-        </p:nvSpPr>
-        <p:spPr>
-          <a:xfrm>
-            <a:off x="4663440" y="1645920"/>
-            <a:ext cx="4069080" cy="1257300"/>
-          </a:xfrm>
-          <a:prstGeom prst="roundRect">
-            <a:avLst>
-              <a:gd name="adj" fmla="val 4364"/>
-            </a:avLst>
-          </a:prstGeom>
-          <a:solidFill>
-            <a:srgbClr val="FFFFFF"/>
-          </a:solidFill>
-          <a:ln w="15875">
-            <a:solidFill>
-              <a:srgbClr val="0891B2"/>
-            </a:solidFill>
-            <a:prstDash val="solid"/>
-          </a:ln>
-        </p:spPr>
-        <p:txBody>
-          <a:bodyPr/>
-          <a:lstStyle/>
-          <a:p>
-            <a:endParaRPr lang="en-US"/>
-          </a:p>
-        </p:txBody>
-      </p:sp>
-      <p:sp>
-        <p:nvSpPr>
-          <p:cNvPr id="18" name="Shape 14"/>
-          <p:cNvSpPr/>
-          <p:nvPr/>
-        </p:nvSpPr>
-        <p:spPr>
-          <a:xfrm>
-            <a:off x="4663440" y="1645920"/>
-            <a:ext cx="91440" cy="1257300"/>
-          </a:xfrm>
-          <a:prstGeom prst="rect">
-            <a:avLst/>
-          </a:prstGeom>
-          <a:solidFill>
-            <a:srgbClr val="0891B2"/>
-          </a:solidFill>
-          <a:ln/>
-        </p:spPr>
-        <p:txBody>
-          <a:bodyPr/>
-          <a:lstStyle/>
-          <a:p>
-            <a:endParaRPr lang="en-US"/>
-          </a:p>
-        </p:txBody>
-      </p:sp>
-      <p:sp>
-        <p:nvSpPr>
-          <p:cNvPr id="19" name="Shape 15"/>
-          <p:cNvSpPr/>
-          <p:nvPr/>
-        </p:nvSpPr>
-        <p:spPr>
-          <a:xfrm>
-            <a:off x="4892040" y="1810512"/>
-            <a:ext cx="502920" cy="502920"/>
-          </a:xfrm>
-          <a:prstGeom prst="ellipse">
-            <a:avLst/>
-          </a:prstGeom>
-          <a:solidFill>
-            <a:srgbClr val="0891B2"/>
-          </a:solidFill>
-          <a:ln/>
-        </p:spPr>
-        <p:txBody>
-          <a:bodyPr/>
-          <a:lstStyle/>
-          <a:p>
-            <a:endParaRPr lang="en-US"/>
-          </a:p>
-        </p:txBody>
-      </p:sp>
-      <p:pic>
-        <p:nvPicPr>
-          <p:cNvPr id="20" name="Image 2" descr="preencoded.png"/>
-          <p:cNvPicPr>
-            <a:picLocks noChangeAspect="1"/>
-          </p:cNvPicPr>
-          <p:nvPr/>
-        </p:nvPicPr>
-        <p:blipFill>
-          <a:blip r:embed="rId5"/>
-          <a:stretch>
-            <a:fillRect/>
-          </a:stretch>
-        </p:blipFill>
-        <p:spPr>
-          <a:xfrm>
-            <a:off x="4992624" y="1911096"/>
-            <a:ext cx="292608" cy="292608"/>
-          </a:xfrm>
-          <a:prstGeom prst="rect">
-            <a:avLst/>
-          </a:prstGeom>
-        </p:spPr>
-      </p:pic>
-      <p:sp>
-        <p:nvSpPr>
-          <p:cNvPr id="21" name="Text 16"/>
-          <p:cNvSpPr/>
-          <p:nvPr/>
-        </p:nvSpPr>
-        <p:spPr>
-          <a:xfrm>
-            <a:off x="5486400" y="1737360"/>
-            <a:ext cx="3108960" cy="320040"/>
-          </a:xfrm>
-          <a:prstGeom prst="rect">
-            <a:avLst/>
-          </a:prstGeom>
-          <a:noFill/>
-          <a:ln/>
-        </p:spPr>
-        <p:txBody>
-          <a:bodyPr wrap="square" lIns="0" tIns="0" rIns="0" bIns="0" rtlCol="0" anchor="ctr"/>
-          <a:lstStyle/>
-          <a:p>
-            <a:pPr marL="0" indent="0" algn="l">
-              <a:buNone/>
-            </a:pPr>
-            <a:r>
-              <a:rPr lang="en-US" sz="1600" b="1" dirty="0">
-                <a:solidFill>
-                  <a:srgbClr val="0891B2"/>
-                </a:solidFill>
-                <a:latin typeface="Calibri" pitchFamily="34" charset="0"/>
-                <a:ea typeface="Calibri" pitchFamily="34" charset="-122"/>
-                <a:cs typeface="Calibri" pitchFamily="34" charset="-120"/>
-              </a:rPr>
-              <a:t>E5-base</a:t>
-            </a:r>
-            <a:endParaRPr lang="en-US" sz="1600" dirty="0"/>
-          </a:p>
-        </p:txBody>
-      </p:sp>
-      <p:sp>
-        <p:nvSpPr>
-          <p:cNvPr id="22" name="Text 17"/>
-          <p:cNvSpPr/>
-          <p:nvPr/>
-        </p:nvSpPr>
-        <p:spPr>
-          <a:xfrm>
-            <a:off x="5486400" y="2066544"/>
-            <a:ext cx="3108960" cy="228600"/>
-          </a:xfrm>
-          <a:prstGeom prst="rect">
-            <a:avLst/>
-          </a:prstGeom>
-          <a:noFill/>
-          <a:ln/>
-        </p:spPr>
-        <p:txBody>
-          <a:bodyPr wrap="square" lIns="0" tIns="0" rIns="0" bIns="0" rtlCol="0" anchor="ctr"/>
-          <a:lstStyle/>
-          <a:p>
-            <a:pPr marL="0" indent="0" algn="l">
-              <a:buNone/>
-            </a:pPr>
-            <a:r>
-              <a:rPr lang="en-US" sz="1000" b="1" dirty="0">
-                <a:solidFill>
-                  <a:srgbClr val="1E293B"/>
-                </a:solidFill>
-                <a:latin typeface="Calibri" pitchFamily="34" charset="0"/>
-                <a:ea typeface="Calibri" pitchFamily="34" charset="-122"/>
-                <a:cs typeface="Calibri" pitchFamily="34" charset="-120"/>
-              </a:rPr>
-              <a:t>Швидка альтернатива</a:t>
-            </a:r>
-            <a:endParaRPr lang="en-US" sz="1000" dirty="0"/>
-          </a:p>
-        </p:txBody>
-      </p:sp>
-      <p:sp>
-        <p:nvSpPr>
-          <p:cNvPr id="23" name="Text 18"/>
-          <p:cNvSpPr/>
-          <p:nvPr/>
-        </p:nvSpPr>
-        <p:spPr>
-          <a:xfrm>
-            <a:off x="4892040" y="2423160"/>
-            <a:ext cx="3657600" cy="388620"/>
-          </a:xfrm>
-          <a:prstGeom prst="rect">
-            <a:avLst/>
-          </a:prstGeom>
-          <a:noFill/>
-          <a:ln/>
-        </p:spPr>
-        <p:txBody>
-          <a:bodyPr wrap="square" lIns="0" tIns="0" rIns="0" bIns="0" rtlCol="0" anchor="t"/>
-          <a:lstStyle/>
-          <a:p>
-            <a:pPr marL="0" indent="0" algn="l">
-              <a:buNone/>
-            </a:pPr>
-            <a:r>
-              <a:rPr lang="en-US" sz="1000" dirty="0">
-                <a:solidFill>
-                  <a:srgbClr val="475569"/>
-                </a:solidFill>
-                <a:latin typeface="Calibri" pitchFamily="34" charset="0"/>
-                <a:ea typeface="Calibri" pitchFamily="34" charset="-122"/>
-                <a:cs typeface="Calibri" pitchFamily="34" charset="-120"/>
-              </a:rPr>
-              <a:t>Прийнятна якість + ~3× швидше за BGE-M3</a:t>
-            </a:r>
-            <a:endParaRPr lang="en-US" sz="1000" dirty="0"/>
-          </a:p>
-        </p:txBody>
-      </p:sp>
-      <p:sp>
-        <p:nvSpPr>
-          <p:cNvPr id="24" name="Shape 19"/>
-          <p:cNvSpPr/>
-          <p:nvPr/>
-        </p:nvSpPr>
-        <p:spPr>
-          <a:xfrm>
-            <a:off x="411480" y="3040380"/>
-            <a:ext cx="4069080" cy="1257300"/>
-          </a:xfrm>
-          <a:prstGeom prst="roundRect">
-            <a:avLst>
-              <a:gd name="adj" fmla="val 4364"/>
-            </a:avLst>
-          </a:prstGeom>
-          <a:solidFill>
-            <a:srgbClr val="FFFFFF"/>
-          </a:solidFill>
-          <a:ln w="15875">
-            <a:solidFill>
-              <a:srgbClr val="1E40AF"/>
-            </a:solidFill>
-            <a:prstDash val="solid"/>
-          </a:ln>
-        </p:spPr>
-        <p:txBody>
-          <a:bodyPr/>
-          <a:lstStyle/>
-          <a:p>
-            <a:endParaRPr lang="en-US"/>
-          </a:p>
-        </p:txBody>
-      </p:sp>
-      <p:sp>
-        <p:nvSpPr>
-          <p:cNvPr id="25" name="Shape 20"/>
-          <p:cNvSpPr/>
-          <p:nvPr/>
-        </p:nvSpPr>
-        <p:spPr>
-          <a:xfrm>
-            <a:off x="411480" y="3040380"/>
-            <a:ext cx="91440" cy="1257300"/>
-          </a:xfrm>
-          <a:prstGeom prst="rect">
-            <a:avLst/>
-          </a:prstGeom>
-          <a:solidFill>
-            <a:srgbClr val="1E40AF"/>
-          </a:solidFill>
-          <a:ln/>
-        </p:spPr>
-        <p:txBody>
-          <a:bodyPr/>
-          <a:lstStyle/>
-          <a:p>
-            <a:endParaRPr lang="en-US"/>
-          </a:p>
-        </p:txBody>
-      </p:sp>
-      <p:sp>
-        <p:nvSpPr>
-          <p:cNvPr id="26" name="Shape 21"/>
-          <p:cNvSpPr/>
-          <p:nvPr/>
-        </p:nvSpPr>
-        <p:spPr>
-          <a:xfrm>
-            <a:off x="640080" y="3204972"/>
-            <a:ext cx="502920" cy="502920"/>
-          </a:xfrm>
-          <a:prstGeom prst="ellipse">
-            <a:avLst/>
-          </a:prstGeom>
-          <a:solidFill>
-            <a:srgbClr val="1E40AF"/>
-          </a:solidFill>
-          <a:ln/>
-        </p:spPr>
-        <p:txBody>
-          <a:bodyPr/>
-          <a:lstStyle/>
-          <a:p>
-            <a:endParaRPr lang="en-US"/>
-          </a:p>
-        </p:txBody>
-      </p:sp>
-      <p:pic>
-        <p:nvPicPr>
-          <p:cNvPr id="27" name="Image 3" descr="preencoded.png"/>
-          <p:cNvPicPr>
-            <a:picLocks noChangeAspect="1"/>
-          </p:cNvPicPr>
-          <p:nvPr/>
-        </p:nvPicPr>
-        <p:blipFill>
-          <a:blip r:embed="rId6"/>
-          <a:stretch>
-            <a:fillRect/>
-          </a:stretch>
-        </p:blipFill>
-        <p:spPr>
-          <a:xfrm>
-            <a:off x="740664" y="3305556"/>
-            <a:ext cx="292608" cy="292608"/>
-          </a:xfrm>
-          <a:prstGeom prst="rect">
-            <a:avLst/>
-          </a:prstGeom>
-        </p:spPr>
-      </p:pic>
-      <p:sp>
-        <p:nvSpPr>
-          <p:cNvPr id="28" name="Text 22"/>
-          <p:cNvSpPr/>
-          <p:nvPr/>
-        </p:nvSpPr>
-        <p:spPr>
-          <a:xfrm>
-            <a:off x="1234440" y="3131820"/>
-            <a:ext cx="3108960" cy="320040"/>
-          </a:xfrm>
-          <a:prstGeom prst="rect">
-            <a:avLst/>
-          </a:prstGeom>
-          <a:noFill/>
-          <a:ln/>
-        </p:spPr>
-        <p:txBody>
-          <a:bodyPr wrap="square" lIns="0" tIns="0" rIns="0" bIns="0" rtlCol="0" anchor="ctr"/>
-          <a:lstStyle/>
-          <a:p>
-            <a:pPr marL="0" indent="0" algn="l">
-              <a:buNone/>
-            </a:pPr>
-            <a:r>
-              <a:rPr lang="en-US" sz="1600" b="1" dirty="0">
-                <a:solidFill>
-                  <a:srgbClr val="1E40AF"/>
-                </a:solidFill>
-                <a:latin typeface="Calibri" pitchFamily="34" charset="0"/>
-                <a:ea typeface="Calibri" pitchFamily="34" charset="-122"/>
-                <a:cs typeface="Calibri" pitchFamily="34" charset="-120"/>
-              </a:rPr>
-              <a:t>Qwen3</a:t>
-            </a:r>
-            <a:endParaRPr lang="en-US" sz="1600" dirty="0"/>
-          </a:p>
-        </p:txBody>
-      </p:sp>
-      <p:sp>
-        <p:nvSpPr>
-          <p:cNvPr id="29" name="Text 23"/>
-          <p:cNvSpPr/>
-          <p:nvPr/>
-        </p:nvSpPr>
-        <p:spPr>
-          <a:xfrm>
-            <a:off x="1234440" y="3461004"/>
-            <a:ext cx="3108960" cy="228600"/>
-          </a:xfrm>
-          <a:prstGeom prst="rect">
-            <a:avLst/>
-          </a:prstGeom>
-          <a:noFill/>
-          <a:ln/>
-        </p:spPr>
-        <p:txBody>
-          <a:bodyPr wrap="square" lIns="0" tIns="0" rIns="0" bIns="0" rtlCol="0" anchor="ctr"/>
-          <a:lstStyle/>
-          <a:p>
-            <a:pPr marL="0" indent="0" algn="l">
-              <a:buNone/>
-            </a:pPr>
-            <a:r>
-              <a:rPr lang="en-US" sz="1000" b="1" dirty="0">
-                <a:solidFill>
-                  <a:srgbClr val="1E293B"/>
-                </a:solidFill>
-                <a:latin typeface="Calibri" pitchFamily="34" charset="0"/>
-                <a:ea typeface="Calibri" pitchFamily="34" charset="-122"/>
-                <a:cs typeface="Calibri" pitchFamily="34" charset="-120"/>
-              </a:rPr>
-              <a:t>Лідер на юридичному домені</a:t>
-            </a:r>
-            <a:endParaRPr lang="en-US" sz="1000" dirty="0"/>
-          </a:p>
-        </p:txBody>
-      </p:sp>
-      <p:sp>
-        <p:nvSpPr>
-          <p:cNvPr id="30" name="Text 24"/>
-          <p:cNvSpPr/>
-          <p:nvPr/>
-        </p:nvSpPr>
-        <p:spPr>
-          <a:xfrm>
-            <a:off x="640080" y="3817620"/>
-            <a:ext cx="3657600" cy="388620"/>
-          </a:xfrm>
-          <a:prstGeom prst="rect">
-            <a:avLst/>
-          </a:prstGeom>
-          <a:noFill/>
-          <a:ln/>
-        </p:spPr>
-        <p:txBody>
-          <a:bodyPr wrap="square" lIns="0" tIns="0" rIns="0" bIns="0" rtlCol="0" anchor="t"/>
-          <a:lstStyle/>
-          <a:p>
-            <a:pPr marL="0" indent="0" algn="l">
-              <a:buNone/>
-            </a:pPr>
-            <a:r>
-              <a:rPr lang="en-US" sz="1000" dirty="0">
-                <a:solidFill>
-                  <a:srgbClr val="475569"/>
-                </a:solidFill>
-                <a:latin typeface="Calibri" pitchFamily="34" charset="0"/>
-                <a:ea typeface="Calibri" pitchFamily="34" charset="-122"/>
-                <a:cs typeface="Calibri" pitchFamily="34" charset="-120"/>
-              </a:rPr>
-              <a:t>Найвища nDCG@10 на Legal (0.320), ~2× повільніший</a:t>
-            </a:r>
-            <a:endParaRPr lang="en-US" sz="1000" dirty="0"/>
-          </a:p>
-        </p:txBody>
-      </p:sp>
-      <p:sp>
-        <p:nvSpPr>
-          <p:cNvPr id="31" name="Shape 25"/>
-          <p:cNvSpPr/>
-          <p:nvPr/>
-        </p:nvSpPr>
-        <p:spPr>
-          <a:xfrm>
-            <a:off x="4663440" y="3040380"/>
-            <a:ext cx="4069080" cy="1257300"/>
-          </a:xfrm>
-          <a:prstGeom prst="roundRect">
-            <a:avLst>
-              <a:gd name="adj" fmla="val 4364"/>
-            </a:avLst>
-          </a:prstGeom>
-          <a:solidFill>
-            <a:srgbClr val="FFFFFF"/>
-          </a:solidFill>
-          <a:ln w="15875">
-            <a:solidFill>
-              <a:srgbClr val="64748B"/>
-            </a:solidFill>
-            <a:prstDash val="solid"/>
-          </a:ln>
-        </p:spPr>
-        <p:txBody>
-          <a:bodyPr/>
-          <a:lstStyle/>
-          <a:p>
-            <a:endParaRPr lang="en-US"/>
-          </a:p>
-        </p:txBody>
-      </p:sp>
-      <p:sp>
-        <p:nvSpPr>
-          <p:cNvPr id="32" name="Shape 26"/>
-          <p:cNvSpPr/>
-          <p:nvPr/>
-        </p:nvSpPr>
-        <p:spPr>
-          <a:xfrm>
-            <a:off x="4663440" y="3040380"/>
-            <a:ext cx="91440" cy="1257300"/>
-          </a:xfrm>
-          <a:prstGeom prst="rect">
-            <a:avLst/>
-          </a:prstGeom>
-          <a:solidFill>
-            <a:srgbClr val="64748B"/>
-          </a:solidFill>
-          <a:ln/>
-        </p:spPr>
-        <p:txBody>
-          <a:bodyPr/>
-          <a:lstStyle/>
-          <a:p>
-            <a:endParaRPr lang="en-US"/>
-          </a:p>
-        </p:txBody>
-      </p:sp>
-      <p:sp>
-        <p:nvSpPr>
-          <p:cNvPr id="33" name="Shape 27"/>
-          <p:cNvSpPr/>
-          <p:nvPr/>
-        </p:nvSpPr>
-        <p:spPr>
-          <a:xfrm>
-            <a:off x="4892040" y="3204972"/>
-            <a:ext cx="502920" cy="502920"/>
-          </a:xfrm>
-          <a:prstGeom prst="ellipse">
-            <a:avLst/>
-          </a:prstGeom>
-          <a:solidFill>
-            <a:srgbClr val="64748B"/>
-          </a:solidFill>
-          <a:ln/>
-        </p:spPr>
-        <p:txBody>
-          <a:bodyPr/>
-          <a:lstStyle/>
-          <a:p>
-            <a:endParaRPr lang="en-US"/>
-          </a:p>
-        </p:txBody>
-      </p:sp>
-      <p:pic>
-        <p:nvPicPr>
-          <p:cNvPr id="34" name="Image 4" descr="preencoded.png"/>
-          <p:cNvPicPr>
-            <a:picLocks noChangeAspect="1"/>
-          </p:cNvPicPr>
-          <p:nvPr/>
-        </p:nvPicPr>
-        <p:blipFill>
-          <a:blip r:embed="rId7"/>
-          <a:stretch>
-            <a:fillRect/>
-          </a:stretch>
-        </p:blipFill>
-        <p:spPr>
-          <a:xfrm>
-            <a:off x="4992624" y="3305556"/>
-            <a:ext cx="292608" cy="292608"/>
-          </a:xfrm>
-          <a:prstGeom prst="rect">
-            <a:avLst/>
-          </a:prstGeom>
-        </p:spPr>
-      </p:pic>
-      <p:sp>
-        <p:nvSpPr>
-          <p:cNvPr id="35" name="Text 28"/>
-          <p:cNvSpPr/>
-          <p:nvPr/>
-        </p:nvSpPr>
-        <p:spPr>
-          <a:xfrm>
-            <a:off x="5486400" y="3131820"/>
-            <a:ext cx="3108960" cy="320040"/>
-          </a:xfrm>
-          <a:prstGeom prst="rect">
-            <a:avLst/>
-          </a:prstGeom>
-          <a:noFill/>
-          <a:ln/>
-        </p:spPr>
-        <p:txBody>
-          <a:bodyPr wrap="square" lIns="0" tIns="0" rIns="0" bIns="0" rtlCol="0" anchor="ctr"/>
-          <a:lstStyle/>
-          <a:p>
-            <a:pPr marL="0" indent="0" algn="l">
-              <a:buNone/>
-            </a:pPr>
-            <a:r>
-              <a:rPr lang="en-US" sz="1600" b="1" dirty="0">
+              <a:t>8</a:t>
+            </a:r>
+            <a:r>
+              <a:rPr lang="en-US" sz="900" dirty="0">
                 <a:solidFill>
                   <a:srgbClr val="64748B"/>
                 </a:solidFill>
@@ -20598,187 +20837,7 @@
                 <a:ea typeface="Calibri" pitchFamily="34" charset="-122"/>
                 <a:cs typeface="Calibri" pitchFamily="34" charset="-120"/>
               </a:rPr>
-              <a:t>BM25</a:t>
-            </a:r>
-            <a:endParaRPr lang="en-US" sz="1600" dirty="0"/>
-          </a:p>
-        </p:txBody>
-      </p:sp>
-      <p:sp>
-        <p:nvSpPr>
-          <p:cNvPr id="36" name="Text 29"/>
-          <p:cNvSpPr/>
-          <p:nvPr/>
-        </p:nvSpPr>
-        <p:spPr>
-          <a:xfrm>
-            <a:off x="5486400" y="3461004"/>
-            <a:ext cx="3108960" cy="228600"/>
-          </a:xfrm>
-          <a:prstGeom prst="rect">
-            <a:avLst/>
-          </a:prstGeom>
-          <a:noFill/>
-          <a:ln/>
-        </p:spPr>
-        <p:txBody>
-          <a:bodyPr wrap="square" lIns="0" tIns="0" rIns="0" bIns="0" rtlCol="0" anchor="ctr"/>
-          <a:lstStyle/>
-          <a:p>
-            <a:pPr marL="0" indent="0" algn="l">
-              <a:buNone/>
-            </a:pPr>
-            <a:r>
-              <a:rPr lang="en-US" sz="1000" b="1" dirty="0">
-                <a:solidFill>
-                  <a:srgbClr val="1E293B"/>
-                </a:solidFill>
-                <a:latin typeface="Calibri" pitchFamily="34" charset="0"/>
-                <a:ea typeface="Calibri" pitchFamily="34" charset="-122"/>
-                <a:cs typeface="Calibri" pitchFamily="34" charset="-120"/>
-              </a:rPr>
-              <a:t>Конкурентний baseline</a:t>
-            </a:r>
-            <a:endParaRPr lang="en-US" sz="1000" dirty="0"/>
-          </a:p>
-        </p:txBody>
-      </p:sp>
-      <p:sp>
-        <p:nvSpPr>
-          <p:cNvPr id="37" name="Text 30"/>
-          <p:cNvSpPr/>
-          <p:nvPr/>
-        </p:nvSpPr>
-        <p:spPr>
-          <a:xfrm>
-            <a:off x="4892040" y="3817620"/>
-            <a:ext cx="3657600" cy="388620"/>
-          </a:xfrm>
-          <a:prstGeom prst="rect">
-            <a:avLst/>
-          </a:prstGeom>
-          <a:noFill/>
-          <a:ln/>
-        </p:spPr>
-        <p:txBody>
-          <a:bodyPr wrap="square" lIns="0" tIns="0" rIns="0" bIns="0" rtlCol="0" anchor="t"/>
-          <a:lstStyle/>
-          <a:p>
-            <a:pPr marL="0" indent="0" algn="l">
-              <a:buNone/>
-            </a:pPr>
-            <a:r>
-              <a:rPr lang="en-US" sz="1000" dirty="0">
-                <a:solidFill>
-                  <a:srgbClr val="475569"/>
-                </a:solidFill>
-                <a:latin typeface="Calibri" pitchFamily="34" charset="0"/>
-                <a:ea typeface="Calibri" pitchFamily="34" charset="-122"/>
-                <a:cs typeface="Calibri" pitchFamily="34" charset="-120"/>
-              </a:rPr>
-              <a:t>Залишається сильним у певних доменах</a:t>
-            </a:r>
-            <a:endParaRPr lang="en-US" sz="1000" dirty="0"/>
-          </a:p>
-        </p:txBody>
-      </p:sp>
-      <p:sp>
-        <p:nvSpPr>
-          <p:cNvPr id="38" name="Text 31"/>
-          <p:cNvSpPr/>
-          <p:nvPr/>
-        </p:nvSpPr>
-        <p:spPr>
-          <a:xfrm>
-            <a:off x="0" y="4366260"/>
-            <a:ext cx="9144000" cy="502920"/>
-          </a:xfrm>
-          <a:prstGeom prst="rect">
-            <a:avLst/>
-          </a:prstGeom>
-          <a:noFill/>
-          <a:ln/>
-        </p:spPr>
-        <p:txBody>
-          <a:bodyPr wrap="square" lIns="0" tIns="0" rIns="0" bIns="0" rtlCol="0" anchor="ctr"/>
-          <a:lstStyle/>
-          <a:p>
-            <a:pPr marL="0" indent="0" algn="ctr">
-              <a:buNone/>
-            </a:pPr>
-            <a:r>
-              <a:rPr lang="en-US" sz="2400" b="1" i="1" dirty="0">
-                <a:solidFill>
-                  <a:srgbClr val="D97706"/>
-                </a:solidFill>
-                <a:latin typeface="Cambria" pitchFamily="34" charset="0"/>
-                <a:ea typeface="Cambria" pitchFamily="34" charset="-122"/>
-                <a:cs typeface="Cambria" pitchFamily="34" charset="-120"/>
-              </a:rPr>
-              <a:t>Дякую за увагу!</a:t>
-            </a:r>
-            <a:endParaRPr lang="en-US" sz="2400" dirty="0"/>
-          </a:p>
-        </p:txBody>
-      </p:sp>
-      <p:pic>
-        <p:nvPicPr>
-          <p:cNvPr id="39" name="Image 5" descr="D:\repos\kb-semantic-search-benchmark\thesis\scripts\_logo_hex.png"/>
-          <p:cNvPicPr>
-            <a:picLocks noChangeAspect="1"/>
-          </p:cNvPicPr>
-          <p:nvPr/>
-        </p:nvPicPr>
-        <p:blipFill>
-          <a:blip r:embed="rId8"/>
-          <a:stretch>
-            <a:fillRect/>
-          </a:stretch>
-        </p:blipFill>
-        <p:spPr>
-          <a:xfrm>
-            <a:off x="411480" y="4686300"/>
-            <a:ext cx="502920" cy="338328"/>
-          </a:xfrm>
-          <a:prstGeom prst="rect">
-            <a:avLst/>
-          </a:prstGeom>
-        </p:spPr>
-      </p:pic>
-      <p:sp>
-        <p:nvSpPr>
-          <p:cNvPr id="40" name="Text 32"/>
-          <p:cNvSpPr/>
-          <p:nvPr/>
-        </p:nvSpPr>
-        <p:spPr>
-          <a:xfrm>
-            <a:off x="7955280" y="4850892"/>
-            <a:ext cx="960120" cy="228600"/>
-          </a:xfrm>
-          <a:prstGeom prst="rect">
-            <a:avLst/>
-          </a:prstGeom>
-          <a:noFill/>
-          <a:ln/>
-        </p:spPr>
-        <p:txBody>
-          <a:bodyPr wrap="square" lIns="0" tIns="0" rIns="0" bIns="0" rtlCol="0" anchor="ctr"/>
-          <a:lstStyle/>
-          <a:p>
-            <a:pPr marL="0" indent="0" algn="r">
-              <a:buNone/>
-            </a:pPr>
-            <a:r>
-              <a:rPr lang="en-US" sz="900" dirty="0">
-                <a:solidFill>
-                  <a:srgbClr val="64748B"/>
-                </a:solidFill>
-                <a:latin typeface="Calibri" pitchFamily="34" charset="0"/>
-                <a:ea typeface="Calibri" pitchFamily="34" charset="-122"/>
-                <a:cs typeface="Calibri" pitchFamily="34" charset="-120"/>
-              </a:rPr>
-              <a:t>18 / 18</a:t>
+              <a:t> / 18</a:t>
             </a:r>
             <a:endParaRPr lang="en-US" sz="900" dirty="0"/>
           </a:p>

</xml_diff>

<commit_message>
Distribute slide intervals over full 10-min budget
Previously the intervals summed to 7:41 — built on tight 2.3 wps
academic pace, leaving ~2:19 unused buffer. Now allocate per-slide
duration proportionally to word count so the total hits exactly 10:00.

Result: every slide gets ~30% more breathing room. Implicit pace
becomes ~1.9 words/sec — comfortable defense rate, with room for
pauses, slide transitions, and natural rhythm.

Each ⏱ marker on every slide is updated. New extremes:
- Slide 12 (shortest): 0:17 of breathing time
- Slide 11 (longest): 0:46

Co-Authored-By: Claude Opus 4.7 (1M context) <noreply@anthropic.com>
</commit_message>
<xml_diff>
--- a/thesis/2026_М_ПІ_ІПЗм-24-1_Нестеренко_В_В.pptx
+++ b/thesis/2026_М_ПІ_ІПЗм-24-1_Нестеренко_В_В.pptx
@@ -5367,7 +5367,7 @@
           <a:lstStyle/>
           <a:p>
             <a:r>
-              <a:t>⏱ 0:00 – 0:19  ·  слайд 1/18</a:t>
+              <a:t>⏱ 0:00 – 0:25  ·  слайд 1/18</a:t>
             </a:r>
             <a:endParaRPr lang="en-US" dirty="0"/>
           </a:p>
@@ -5459,7 +5459,7 @@
           <a:lstStyle/>
           <a:p>
             <a:r>
-              <a:t>⏱ 3:51 – 4:03  ·  слайд 10/18</a:t>
+              <a:t>⏱ 5:00 – 5:16  ·  слайд 10/18</a:t>
             </a:r>
             <a:endParaRPr lang="en-US" dirty="0"/>
           </a:p>
@@ -5551,7 +5551,7 @@
           <a:lstStyle/>
           <a:p>
             <a:r>
-              <a:t>⏱ 4:03 – 4:38  ·  слайд 11/18</a:t>
+              <a:t>⏱ 5:16 – 6:02  ·  слайд 11/18</a:t>
             </a:r>
             <a:endParaRPr lang="en-US" dirty="0"/>
           </a:p>
@@ -5658,7 +5658,7 @@
           <a:lstStyle/>
           <a:p>
             <a:r>
-              <a:t>⏱ 4:38 – 4:51  ·  слайд 12/18</a:t>
+              <a:t>⏱ 6:02 – 6:19  ·  слайд 12/18</a:t>
             </a:r>
             <a:endParaRPr lang="en-US" dirty="0"/>
           </a:p>
@@ -5750,13 +5750,11 @@
           <a:lstStyle/>
           <a:p>
             <a:r>
-              <a:t>⏱ 4:51 – 5:23  ·  слайд 13/18</a:t>
+              <a:t>⏱ 6:19 – 7:00  ·  слайд 13/18</a:t>
             </a:r>
             <a:endParaRPr lang="en-US" dirty="0"/>
           </a:p>
-          <a:p>
-            <a:endParaRPr lang="en-US" dirty="0"/>
-          </a:p>
+          <a:p/>
           <a:p>
             <a:r>
               <a:t>Головні результати. У таблиці — середнє nDCG@10 по трьох доменах. Перше — BGE-M3 з 0.4708. Друге — Qwen3 з 0.4385. Третє — E5-base з 0.4199. Четверте — BM25 з 0.3319. Останнє — nomic з 0.2128, навіть нижче BM25.</a:t>
@@ -5855,7 +5853,7 @@
           <a:lstStyle/>
           <a:p>
             <a:r>
-              <a:t>⏱ 5:23 – 5:40  ·  слайд 14/18</a:t>
+              <a:t>⏱ 7:00 – 7:23  ·  слайд 14/18</a:t>
             </a:r>
             <a:endParaRPr lang="en-US" dirty="0"/>
           </a:p>
@@ -5947,7 +5945,7 @@
           <a:lstStyle/>
           <a:p>
             <a:r>
-              <a:t>⏱ 5:40 – 6:07  ·  слайд 15/18</a:t>
+              <a:t>⏱ 7:23 – 7:58  ·  слайд 15/18</a:t>
             </a:r>
             <a:endParaRPr lang="en-US" dirty="0"/>
           </a:p>
@@ -6039,7 +6037,7 @@
           <a:lstStyle/>
           <a:p>
             <a:r>
-              <a:t>⏱ 6:07 – 6:42  ·  слайд 16/18</a:t>
+              <a:t>⏱ 7:58 – 8:43  ·  слайд 16/18</a:t>
             </a:r>
             <a:endParaRPr lang="en-US" dirty="0"/>
           </a:p>
@@ -6151,7 +6149,7 @@
           <a:lstStyle/>
           <a:p>
             <a:r>
-              <a:t>⏱ 7:03 – 7:41  ·  слайд 18/18</a:t>
+              <a:t>⏱ 8:43 – 9:32  ·  слайд 17/18</a:t>
             </a:r>
             <a:endParaRPr lang="en-US" dirty="0"/>
           </a:p>
@@ -6273,7 +6271,7 @@
           <a:lstStyle/>
           <a:p>
             <a:r>
-              <a:t>⏱ 6:42 – 7:03  ·  слайд 17/18</a:t>
+              <a:t>⏱ 9:32 – 10:00  ·  слайд 18/18</a:t>
             </a:r>
             <a:endParaRPr lang="en-US" dirty="0"/>
           </a:p>
@@ -6365,13 +6363,11 @@
           <a:lstStyle/>
           <a:p>
             <a:r>
-              <a:t>⏱ 0:19 – 0:57  ·  слайд 2/18</a:t>
+              <a:t>⏱ 0:25 – 1:14  ·  слайд 2/18</a:t>
             </a:r>
             <a:endParaRPr lang="en-US" dirty="0"/>
           </a:p>
-          <a:p>
-            <a:endParaRPr lang="en-US" dirty="0"/>
-          </a:p>
+          <a:p/>
           <a:p>
             <a:r>
               <a:t>Обсяги корпоративної текстової інформації стрімко зростають, а традиційний лексичний пошук погано працює з синонімією, перефразуванням і мультимовним контентом. Сучасні embedding-моделі дозволяють шукати за змістом, а не за збігом слів.</a:t>
@@ -6475,7 +6471,7 @@
           <a:lstStyle/>
           <a:p>
             <a:r>
-              <a:t>⏱ 0:57 – 1:14  ·  слайд 3/18</a:t>
+              <a:t>⏱ 1:14 – 1:37  ·  слайд 3/18</a:t>
             </a:r>
             <a:endParaRPr lang="en-US" dirty="0"/>
           </a:p>
@@ -6567,13 +6563,11 @@
           <a:lstStyle/>
           <a:p>
             <a:r>
-              <a:t>⏱ 1:14 – 1:40  ·  слайд 4/18</a:t>
+              <a:t>⏱ 1:37 – 2:10  ·  слайд 4/18</a:t>
             </a:r>
             <a:endParaRPr lang="en-US" dirty="0"/>
           </a:p>
-          <a:p>
-            <a:endParaRPr lang="en-US" dirty="0"/>
-          </a:p>
+          <a:p/>
           <a:p>
             <a:r>
               <a:t>Постановка задачі: просто застосувати embedding-модель недостатньо — треба обґрунтовано обрати ту, що забезпечує баланс між якістю пошуку, швидкодією, ресурсами, мовною підтримкою та типом колекції.</a:t>
@@ -6667,7 +6661,7 @@
           <a:lstStyle/>
           <a:p>
             <a:r>
-              <a:t>⏱ 1:40 – 2:08  ·  слайд 5/18</a:t>
+              <a:t>⏱ 2:10 – 2:46  ·  слайд 5/18</a:t>
             </a:r>
             <a:endParaRPr lang="en-US" dirty="0"/>
           </a:p>
@@ -6759,13 +6753,11 @@
           <a:lstStyle/>
           <a:p>
             <a:r>
-              <a:t>⏱ 2:08 – 2:31  ·  слайд 6/18</a:t>
+              <a:t>⏱ 2:46 – 3:17  ·  слайд 6/18</a:t>
             </a:r>
             <a:endParaRPr lang="en-US" dirty="0"/>
           </a:p>
-          <a:p>
-            <a:endParaRPr lang="en-US" dirty="0"/>
-          </a:p>
+          <a:p/>
           <a:p>
             <a:r>
               <a:t>Оцінювання базується на чотирьох стандартних метриках retrieval-якості: nDCG@10 — якість ранжування; MRR@10 — позиція першого релевантного; Recall@10 — повнота; Precision@10 — точність. Окремо вимірюється швидкодія в мілісекундах.</a:t>
@@ -6859,7 +6851,7 @@
           <a:lstStyle/>
           <a:p>
             <a:r>
-              <a:t>⏱ 2:31 – 2:54  ·  слайд 7/18</a:t>
+              <a:t>⏱ 3:17 – 3:47  ·  слайд 7/18</a:t>
             </a:r>
             <a:endParaRPr lang="en-US" dirty="0"/>
           </a:p>
@@ -6951,7 +6943,7 @@
           <a:lstStyle/>
           <a:p>
             <a:r>
-              <a:t>⏱ 2:54 – 3:23  ·  слайд 8/18</a:t>
+              <a:t>⏱ 3:47 – 4:24  ·  слайд 8/18</a:t>
             </a:r>
             <a:endParaRPr lang="en-US" dirty="0"/>
           </a:p>
@@ -7043,13 +7035,11 @@
           <a:lstStyle/>
           <a:p>
             <a:r>
-              <a:t>⏱ 3:23 – 3:51  ·  слайд 9/18</a:t>
+              <a:t>⏱ 4:24 – 5:00  ·  слайд 9/18</a:t>
             </a:r>
             <a:endParaRPr lang="en-US" dirty="0"/>
           </a:p>
-          <a:p>
-            <a:endParaRPr lang="en-US" dirty="0"/>
-          </a:p>
+          <a:p/>
           <a:p>
             <a:r>
               <a:t>Архітектура у вигляді pipeline. На вході — PDF, DOCX, TXT або Markdown. Документи розбиваються на чанки ~600 слів з перекриттям. Далі чанк перетворюється на вектор однією з чотирьох embedding-моделей, L2-нормалізується та індексується у FAISS — точний IndexFlatIP, що для нормалізованих векторів еквівалентне косинусній мірі. Запит проходить ту саму обробку — повертаються топ-K найрелевантніших чанків. Усе обгорнуто у Flask. Основні модулі: build_index, evaluate_benchmark, embedding_models, app.</a:t>

</xml_diff>

<commit_message>
Add bridging transitions between slide notes
Each note now opens with a short bridging phrase that links it to
what was said on the previous slide. Without these, the deck reads
like 18 independent paragraphs; with them, it flows as one talk.

Examples:
- Slide 4 («Постановка задачі»): «Виявлена прогалина веде до
  постановки задачі.»
- Slide 6 («Методологія»): «Як порівнюватимемо ці п'ять моделей?»
- Slide 8 («МКВ»): «Окремих метрик недостатньо — потрібно об'єднати
  їх в одне число.»
- Slide 13 («Результати»): «Що дав запуск benchmark на 300 запитах?»
- Slide 15 («Парето»): «Переходимо до інтегральної оцінки.»

Also relocated the closing «Дякую за увагу! Готовий відповісти на
запитання.» from slide 17 (Підсумки) to slide 18 (Апробація) — after
the slide reorder, апробація is the actual final slide.

Time intervals refreshed: total still 10:00, implicit reading pace
rose from 1.90 to 1.95 wps — still comfortable.

Co-Authored-By: Claude Opus 4.7 (1M context) <noreply@anthropic.com>
</commit_message>
<xml_diff>
--- a/thesis/2026_М_ПІ_ІПЗм-24-1_Нестеренко_В_В.pptx
+++ b/thesis/2026_М_ПІ_ІПЗм-24-1_Нестеренко_В_В.pptx
@@ -5367,7 +5367,7 @@
           <a:lstStyle/>
           <a:p>
             <a:r>
-              <a:t>⏱ 0:00 – 0:25  ·  слайд 1/18</a:t>
+              <a:t>⏱ 0:00 – 0:23  ·  слайд 1/18</a:t>
             </a:r>
             <a:endParaRPr lang="en-US" dirty="0"/>
           </a:p>
@@ -5459,13 +5459,13 @@
           <a:lstStyle/>
           <a:p>
             <a:r>
-              <a:t>⏱ 5:02 – 5:17  ·  слайд 10/18</a:t>
+              <a:t>⏱ 5:01 – 5:19  ·  слайд 10/18</a:t>
             </a:r>
             <a:endParaRPr lang="en-US" dirty="0"/>
           </a:p>
           <a:p>
             <a:r>
-              <a:t>Програмне забезпечення: Python 3.11, sentence-transformers, transformers від Hugging Face, PyTorch у CPU-режимі, FAISS і rank_bm25 для retrieval, Flask для веб-частини, NumPy і scikit-learn для аналізу, бутстреп-CI власної реалізації.</a:t>
+              <a:t>Технологічний стек, на якому це побудовано. Програмне забезпечення: Python 3.11, sentence-transformers, transformers від Hugging Face, PyTorch у CPU-режимі, FAISS і rank_bm25 для retrieval, Flask для веб-частини, NumPy і scikit-learn для аналізу, бутстреп-CI власної реалізації.</a:t>
             </a:r>
           </a:p>
         </p:txBody>
@@ -5551,13 +5551,13 @@
           <a:lstStyle/>
           <a:p>
             <a:r>
-              <a:t>⏱ 5:17 – 6:03  ·  слайд 11/18</a:t>
+              <a:t>⏱ 5:19 – 6:04  ·  слайд 11/18</a:t>
             </a:r>
             <a:endParaRPr lang="en-US" dirty="0"/>
           </a:p>
           <a:p>
             <a:r>
-              <a:t>Власноруч сформовано україномовний benchmark з трьох предметних доменів. Усього — 32 документи, 300 запитів. Якорі релевантності — qrels — сформовано вручну.</a:t>
+              <a:t>На якому датасеті випробували методологію? Власноруч сформовано україномовний benchmark з трьох предметних доменів. Усього — 32 документи, 300 запитів. Якорі релевантності — qrels — сформовано вручну.</a:t>
             </a:r>
           </a:p>
           <a:p>
@@ -5658,7 +5658,7 @@
           <a:lstStyle/>
           <a:p>
             <a:r>
-              <a:t>⏱ 6:03 – 6:20  ·  слайд 12/18</a:t>
+              <a:t>⏱ 6:04 – 6:20  ·  слайд 12/18</a:t>
             </a:r>
             <a:endParaRPr lang="en-US" dirty="0"/>
           </a:p>
@@ -5750,14 +5750,14 @@
           <a:lstStyle/>
           <a:p>
             <a:r>
-              <a:t>⏱ 6:20 – 7:01  ·  слайд 13/18</a:t>
+              <a:t>⏱ 6:20 – 7:02  ·  слайд 13/18</a:t>
             </a:r>
             <a:endParaRPr lang="en-US" dirty="0"/>
           </a:p>
           <a:p/>
           <a:p>
             <a:r>
-              <a:t>Головні результати. У таблиці — середнє nDCG@10 по трьох доменах. Перше — BGE-M3 з 0.4708. Друге — Qwen3 з 0.4385. Третє — E5-base з 0.4199. Четверте — BM25 з 0.3319. Останнє — nomic з 0.2128, навіть нижче BM25.</a:t>
+              <a:t>Що дав запуск benchmark на 300 запитах? Головні результати. У таблиці — середнє nDCG@10 по трьох доменах. Перше — BGE-M3 з 0.4708. Друге — Qwen3 з 0.4385. Третє — E5-base з 0.4199. Четверте — BM25 з 0.3319. Останнє — nomic з 0.2128, навіть нижче BM25.</a:t>
             </a:r>
           </a:p>
           <a:p>
@@ -5853,13 +5853,13 @@
           <a:lstStyle/>
           <a:p>
             <a:r>
-              <a:t>⏱ 7:01 – 7:24  ·  слайд 14/18</a:t>
+              <a:t>⏱ 7:02 – 7:26  ·  слайд 14/18</a:t>
             </a:r>
             <a:endParaRPr lang="en-US" dirty="0"/>
           </a:p>
           <a:p>
             <a:r>
-              <a:t>Деталізовані метрики у розрізі трьох доменів — nDCG, MRR, Recall, Precision. Лідерство BGE-M3 послідовне за всіма чотирма метриками — це підтверджує робастність результату. На юридичному домені усі моделі показують нижчі значення — він складніший через формальний стиль і вузькоспеціалізовану термінологію.</a:t>
+              <a:t>За окремими доменами картина така. Деталізовані метрики у розрізі трьох доменів — nDCG, MRR, Recall, Precision. Лідерство BGE-M3 послідовне за всіма чотирма метриками — це підтверджує робастність результату. На юридичному домені усі моделі показують нижчі значення — він складніший через формальний стиль і вузькоспеціалізовану термінологію.</a:t>
             </a:r>
           </a:p>
         </p:txBody>
@@ -5945,13 +5945,13 @@
           <a:lstStyle/>
           <a:p>
             <a:r>
-              <a:t>⏱ 7:24 – 8:00  ·  слайд 15/18</a:t>
+              <a:t>⏱ 7:26 – 8:01  ·  слайд 15/18</a:t>
             </a:r>
             <a:endParaRPr lang="en-US" dirty="0"/>
           </a:p>
           <a:p>
             <a:r>
-              <a:t>Результати багатокритеріального вибору. Парето-оптимальна множина — BGE-M3, E5-base та BM25: три з п'яти моделей не домінуються жодною. BGE-M3 — лідер за nDCG, MRR, Recall на технічному і медичному доменах. E5-base — швидка альтернатива: 70 мілісекунд проти 228 у BGE-M3, тобто у три рази швидше. Qwen3 — лідер на юридичному (nDCG 0.320), але удвічі повільніший. Nomic — найслабші результати, в окремих доменах поступається навіть BM25.</a:t>
+              <a:t>Переходимо до інтегральної оцінки. Результати багатокритеріального вибору. Парето-оптимальна множина — BGE-M3, E5-base та BM25: три з п'яти моделей не домінуються жодною. BGE-M3 — лідер за nDCG, MRR, Recall на технічному і медичному доменах. E5-base — швидка альтернатива: 70 мілісекунд проти 228 у BGE-M3, тобто у три рази швидше. Qwen3 — лідер на юридичному (nDCG 0.320), але удвічі повільніший. Nomic — найслабші результати, в окремих доменах поступається навіть BM25.</a:t>
             </a:r>
           </a:p>
         </p:txBody>
@@ -6037,13 +6037,13 @@
           <a:lstStyle/>
           <a:p>
             <a:r>
-              <a:t>⏱ 8:00 – 8:44  ·  слайд 16/18</a:t>
+              <a:t>⏱ 8:01 – 8:46  ·  слайд 16/18</a:t>
             </a:r>
             <a:endParaRPr lang="en-US" dirty="0"/>
           </a:p>
           <a:p>
             <a:r>
-              <a:t>Компроміс якості та швидкодії на технічному домені. По осі X — час відповіді, по осі Y — nDCG@10. Парето-фронт виділено пунктиром.</a:t>
+              <a:t>Той самий аналіз — у вигляді графіка. Компроміс якості та швидкодії на технічному домені. По осі X — час відповіді, по осі Y — nDCG@10. Парето-фронт виділено пунктиром.</a:t>
             </a:r>
           </a:p>
           <a:p>
@@ -6149,7 +6149,7 @@
           <a:lstStyle/>
           <a:p>
             <a:r>
-              <a:t>⏱ 8:44 – 9:32  ·  слайд 17/18</a:t>
+              <a:t>⏱ 8:46 – 9:28  ·  слайд 17/18</a:t>
             </a:r>
             <a:endParaRPr lang="en-US" dirty="0"/>
           </a:p>
@@ -6181,11 +6181,6 @@
           <a:p>
             <a:r>
               <a:t>Усі задачі, поставлені в роботі, виконано. Мета досягнута.</a:t>
-            </a:r>
-          </a:p>
-          <a:p>
-            <a:r>
-              <a:t>Дякую за увагу! Готовий відповісти на запитання.</a:t>
             </a:r>
           </a:p>
         </p:txBody>
@@ -6271,13 +6266,18 @@
           <a:lstStyle/>
           <a:p>
             <a:r>
-              <a:t>⏱ 9:32 – 10:00  ·  слайд 18/18</a:t>
+              <a:t>⏱ 9:28 – 10:00  ·  слайд 18/18</a:t>
             </a:r>
             <a:endParaRPr lang="en-US" dirty="0"/>
           </a:p>
           <a:p>
             <a:r>
-              <a:t>Апробація: опубліковано дві наукові праці у співавторстві з науковим керівником. Перша — стаття на 2-й конференції «Innovative Research in Science and Economy» з benchmark-методологією. Друга — тези на 30-му форумі «Радіоелектроніка та молодь у XXI столітті» в ХНУРЕ про підвищення якості retrieval. Загалом — два виступи на міжнародних конференціях.</a:t>
+              <a:t>Окремо — про апробацію результатів роботи. Апробація: опубліковано дві наукові праці у співавторстві з науковим керівником. Перша — стаття на 2-й конференції «Innovative Research in Science and Economy» з benchmark-методологією. Друга — тези на 30-му форумі «Радіоелектроніка та молодь у XXI столітті» в ХНУРЕ про підвищення якості retrieval. Загалом — два виступи на міжнародних конференціях.</a:t>
+            </a:r>
+          </a:p>
+          <a:p>
+            <a:r>
+              <a:t>Дякую за увагу! Готовий відповісти на запитання.</a:t>
             </a:r>
           </a:p>
         </p:txBody>
@@ -6363,14 +6363,14 @@
           <a:lstStyle/>
           <a:p>
             <a:r>
-              <a:t>⏱ 0:25 – 1:16  ·  слайд 2/18</a:t>
+              <a:t>⏱ 0:23 – 1:12  ·  слайд 2/18</a:t>
             </a:r>
             <a:endParaRPr lang="en-US" dirty="0"/>
           </a:p>
           <a:p/>
           <a:p>
             <a:r>
-              <a:t>Обсяги корпоративної текстової інформації стрімко зростають, а традиційний лексичний пошук погано працює з синонімією, перефразуванням і мультимовним контентом. Сучасні embedding-моделі дозволяють шукати за змістом, а не за збігом слів.</a:t>
+              <a:t>Розпочнемо з актуальності. Обсяги корпоративної текстової інформації стрімко зростають, а традиційний лексичний пошук погано працює з синонімією, перефразуванням і мультимовним контентом. Сучасні embedding-моделі дозволяють шукати за змістом, а не за збігом слів.</a:t>
             </a:r>
           </a:p>
           <a:p>
@@ -6471,13 +6471,13 @@
           <a:lstStyle/>
           <a:p>
             <a:r>
-              <a:t>⏱ 1:16 – 1:39  ·  слайд 3/18</a:t>
+              <a:t>⏱ 1:12 – 1:37  ·  слайд 3/18</a:t>
             </a:r>
             <a:endParaRPr lang="en-US" dirty="0"/>
           </a:p>
           <a:p>
             <a:r>
-              <a:t>Огляд літератури охоплює період 2013–2025 — від статистичних подань Word2Vec через контекстний BERT і Sentence-BERT, до сучасних мультимовних моделей: E5, BGE-M3, nomic та Qwen3-Embedding. Усього опрацьовано 29 джерел. Виявлено ключову дослідницьку прогалину: відсутність порівняльних досліджень embedding-моделей саме на україномовних доменно-специфічних колекціях.</a:t>
+              <a:t>Які підходи вже досліджено в літературі? Огляд літератури охоплює період 2013–2025 — від статистичних подань Word2Vec через контекстний BERT і Sentence-BERT, до сучасних мультимовних моделей: E5, BGE-M3, nomic та Qwen3-Embedding. Усього опрацьовано 29 джерел. Виявлено ключову дослідницьку прогалину: відсутність порівняльних досліджень embedding-моделей саме на україномовних доменно-специфічних колекціях.</a:t>
             </a:r>
           </a:p>
         </p:txBody>
@@ -6563,14 +6563,14 @@
           <a:lstStyle/>
           <a:p>
             <a:r>
-              <a:t>⏱ 1:39 – 2:12  ·  слайд 4/18</a:t>
+              <a:t>⏱ 1:37 – 2:11  ·  слайд 4/18</a:t>
             </a:r>
             <a:endParaRPr lang="en-US" dirty="0"/>
           </a:p>
           <a:p/>
           <a:p>
             <a:r>
-              <a:t>Постановка задачі: просто застосувати embedding-модель недостатньо — треба обґрунтовано обрати ту, що забезпечує баланс між якістю пошуку, швидкодією, ресурсами, мовною підтримкою та типом колекції.</a:t>
+              <a:t>Виявлена прогалина веде до постановки задачі. Постановка задачі: просто застосувати embedding-модель недостатньо — треба обґрунтовано обрати ту, що забезпечує баланс між якістю пошуку, швидкодією, ресурсами, мовною підтримкою та типом колекції.</a:t>
             </a:r>
           </a:p>
           <a:p>
@@ -6661,13 +6661,13 @@
           <a:lstStyle/>
           <a:p>
             <a:r>
-              <a:t>⏱ 2:12 – 2:49  ·  слайд 5/18</a:t>
+              <a:t>⏱ 2:11 – 2:47  ·  слайд 5/18</a:t>
             </a:r>
             <a:endParaRPr lang="en-US" dirty="0"/>
           </a:p>
           <a:p>
             <a:r>
-              <a:t>Для дослідження обрано чотири моделі різних архітектур. BGE-M3 від BAAI — 568 мільйонів параметрів, контекст 8192 токенів, мультифункціональна (dense, sparse, multi-vector). E5-base від intfloat — 278 мільйонів параметрів, контекст 512, з обов'язковими префіксами query та passage. Nomic-embed v1.5 — найменша, 137 мільйонів, з технікою Matryoshka. Qwen3-Embedding-0.6B від Alibaba — 596 мільйонів, контекст 32 тисячі токенів, єдина побудована на декодерній LLM-архітектурі. Як лексичну baseline використано BM25.</a:t>
+              <a:t>Розглянемо, які саме моделі дослідимо. Для дослідження обрано чотири моделі різних архітектур. BGE-M3 від BAAI — 568 мільйонів параметрів, контекст 8192 токенів, мультифункціональна (dense, sparse, multi-vector). E5-base від intfloat — 278 мільйонів параметрів, контекст 512, з обов'язковими префіксами query та passage. Nomic-embed v1.5 — найменша, 137 мільйонів, з технікою Matryoshka. Qwen3-Embedding-0.6B від Alibaba — 596 мільйонів, контекст 32 тисячі токенів, єдина побудована на декодерній LLM-архітектурі. Як лексичну baseline використано BM25.</a:t>
             </a:r>
           </a:p>
         </p:txBody>
@@ -6753,14 +6753,14 @@
           <a:lstStyle/>
           <a:p>
             <a:r>
-              <a:t>⏱ 2:49 – 3:19  ·  слайд 6/18</a:t>
+              <a:t>⏱ 2:47 – 3:18  ·  слайд 6/18</a:t>
             </a:r>
             <a:endParaRPr lang="en-US" dirty="0"/>
           </a:p>
           <a:p/>
           <a:p>
             <a:r>
-              <a:t>Оцінювання базується на чотирьох метриках retrieval-якості: nDCG@10 — якість ранжування; MRR@10 — позиція першого релевантного; Recall@10 — повнота; Precision@10 — точність. Окремо вимірюється швидкодія в мілісекундах.</a:t>
+              <a:t>Як порівнюватимемо ці п'ять моделей? Оцінювання базується на чотирьох метриках retrieval-якості: nDCG@10 — якість ранжування; MRR@10 — позиція першого релевантного; Recall@10 — повнота; Precision@10 — точність. Окремо вимірюється швидкодія в мілісекундах.</a:t>
             </a:r>
           </a:p>
           <a:p>
@@ -6851,7 +6851,7 @@
           <a:lstStyle/>
           <a:p>
             <a:r>
-              <a:t>⏱ 3:19 – 3:49  ·  слайд 7/18</a:t>
+              <a:t>⏱ 3:18 – 3:46  ·  слайд 7/18</a:t>
             </a:r>
             <a:endParaRPr lang="en-US" dirty="0"/>
           </a:p>
@@ -6943,13 +6943,13 @@
           <a:lstStyle/>
           <a:p>
             <a:r>
-              <a:t>⏱ 3:49 – 4:26  ·  слайд 8/18</a:t>
+              <a:t>⏱ 3:46 – 4:26  ·  слайд 8/18</a:t>
             </a:r>
             <a:endParaRPr lang="en-US" dirty="0"/>
           </a:p>
           <a:p>
             <a:r>
-              <a:t>Багатокритеріальний вибір реалізовано у три кроки. Перший — Парето-домінування: відсіюємо альтернативи, які гірші за іншу одразу за всіма критеріями. Другий — нормалізація: приведення всіх критеріїв до спільної шкали від 0 до 1 з урахуванням напряму оптимізації. Третій — лінійна адитивна згортка: інтегральна оцінка U — це сума добутків ваг на нормалізовані значення; сума ваг дорівнює одиниці. Ваги задає користувач залежно від пріоритетів — якість, швидкодія, ресурси.</a:t>
+              <a:t>Окремих метрик недостатньо — потрібно об'єднати їх в одне число. Багатокритеріальний вибір реалізовано у три кроки. Перший — Парето-домінування: відсіюємо альтернативи, які гірші за іншу одразу за всіма критеріями. Другий — нормалізація: приведення всіх критеріїв до спільної шкали від 0 до 1 з урахуванням напряму оптимізації. Третій — лінійна адитивна згортка: інтегральна оцінка U — це сума добутків ваг на нормалізовані значення; сума ваг дорівнює одиниці. Ваги задає користувач залежно від пріоритетів — якість, швидкодія, ресурси.</a:t>
             </a:r>
           </a:p>
         </p:txBody>
@@ -7035,14 +7035,14 @@
           <a:lstStyle/>
           <a:p>
             <a:r>
-              <a:t>⏱ 4:26 – 5:02  ·  слайд 9/18</a:t>
+              <a:t>⏱ 4:26 – 5:01  ·  слайд 9/18</a:t>
             </a:r>
             <a:endParaRPr lang="en-US" dirty="0"/>
           </a:p>
           <a:p/>
           <a:p>
             <a:r>
-              <a:t>Архітектура у вигляді pipeline. На вході — PDF, DOCX, TXT або Markdown. Документи розбиваються на чанки ~600 слів з перекриттям. Далі чанк перетворюється на вектор однією з чотирьох embedding-моделей, L2-нормалізується та індексується у FAISS — точний IndexFlatIP, що для нормалізованих векторів еквівалентне косинусній мірі. Запит проходить ту саму обробку — повертаються топ-K найрелевантніших чанків. Усе обгорнуто у Flask. Основні модулі: build_index, evaluate_benchmark, embedding_models, app.</a:t>
+              <a:t>Як це реалізовано архітектурно? Архітектура у вигляді pipeline. На вході — PDF, DOCX, TXT або Markdown. Документи розбиваються на чанки ~600 слів з перекриттям. Далі чанк перетворюється на вектор однією з чотирьох embedding-моделей, L2-нормалізується та індексується у FAISS — точний IndexFlatIP, що для нормалізованих векторів еквівалентне косинусній мірі. Запит проходить ту саму обробку — повертаються топ-K найрелевантніших чанків. Усе обгорнуто у Flask. Основні модулі: build_index, evaluate_benchmark, embedding_models, app.</a:t>
             </a:r>
           </a:p>
         </p:txBody>

</xml_diff>

<commit_message>
Remove «Дякую за увагу» from slide 18 — student prefers ad-lib
User decided the closing line is better left unwritten and said live
on the day. Reverted the slide 18 append from the previous commit and
updated add_slide_transitions.py to no longer add it.

Time intervals refreshed (slide 18 shrinks by ~5s, redistributed).

Co-Authored-By: Claude Opus 4.7 (1M context) <noreply@anthropic.com>
</commit_message>
<xml_diff>
--- a/thesis/2026_М_ПІ_ІПЗм-24-1_Нестеренко_В_В.pptx
+++ b/thesis/2026_М_ПІ_ІПЗм-24-1_Нестеренко_В_В.pptx
@@ -5459,7 +5459,7 @@
           <a:lstStyle/>
           <a:p>
             <a:r>
-              <a:t>⏱ 5:01 – 5:19  ·  слайд 10/18</a:t>
+              <a:t>⏱ 5:03 – 5:21  ·  слайд 10/18</a:t>
             </a:r>
             <a:endParaRPr lang="en-US" dirty="0"/>
           </a:p>
@@ -5551,7 +5551,7 @@
           <a:lstStyle/>
           <a:p>
             <a:r>
-              <a:t>⏱ 5:19 – 6:04  ·  слайд 11/18</a:t>
+              <a:t>⏱ 5:21 – 6:06  ·  слайд 11/18</a:t>
             </a:r>
             <a:endParaRPr lang="en-US" dirty="0"/>
           </a:p>
@@ -5658,7 +5658,7 @@
           <a:lstStyle/>
           <a:p>
             <a:r>
-              <a:t>⏱ 6:04 – 6:20  ·  слайд 12/18</a:t>
+              <a:t>⏱ 6:06 – 6:22  ·  слайд 12/18</a:t>
             </a:r>
             <a:endParaRPr lang="en-US" dirty="0"/>
           </a:p>
@@ -5750,7 +5750,7 @@
           <a:lstStyle/>
           <a:p>
             <a:r>
-              <a:t>⏱ 6:20 – 7:02  ·  слайд 13/18</a:t>
+              <a:t>⏱ 6:22 – 7:05  ·  слайд 13/18</a:t>
             </a:r>
             <a:endParaRPr lang="en-US" dirty="0"/>
           </a:p>
@@ -5853,7 +5853,7 @@
           <a:lstStyle/>
           <a:p>
             <a:r>
-              <a:t>⏱ 7:02 – 7:26  ·  слайд 14/18</a:t>
+              <a:t>⏱ 7:05 – 7:28  ·  слайд 14/18</a:t>
             </a:r>
             <a:endParaRPr lang="en-US" dirty="0"/>
           </a:p>
@@ -5945,7 +5945,7 @@
           <a:lstStyle/>
           <a:p>
             <a:r>
-              <a:t>⏱ 7:26 – 8:01  ·  слайд 15/18</a:t>
+              <a:t>⏱ 7:28 – 8:04  ·  слайд 15/18</a:t>
             </a:r>
             <a:endParaRPr lang="en-US" dirty="0"/>
           </a:p>
@@ -6037,7 +6037,7 @@
           <a:lstStyle/>
           <a:p>
             <a:r>
-              <a:t>⏱ 8:01 – 8:46  ·  слайд 16/18</a:t>
+              <a:t>⏱ 8:04 – 8:49  ·  слайд 16/18</a:t>
             </a:r>
             <a:endParaRPr lang="en-US" dirty="0"/>
           </a:p>
@@ -6149,7 +6149,7 @@
           <a:lstStyle/>
           <a:p>
             <a:r>
-              <a:t>⏱ 8:46 – 9:28  ·  слайд 17/18</a:t>
+              <a:t>⏱ 8:49 – 9:31  ·  слайд 17/18</a:t>
             </a:r>
             <a:endParaRPr lang="en-US" dirty="0"/>
           </a:p>
@@ -6266,18 +6266,13 @@
           <a:lstStyle/>
           <a:p>
             <a:r>
-              <a:t>⏱ 9:28 – 10:00  ·  слайд 18/18</a:t>
+              <a:t>⏱ 9:31 – 10:00  ·  слайд 18/18</a:t>
             </a:r>
             <a:endParaRPr lang="en-US" dirty="0"/>
           </a:p>
           <a:p>
             <a:r>
               <a:t>Окремо — про апробацію результатів роботи. Апробація: опубліковано дві наукові праці у співавторстві з науковим керівником. Перша — стаття на 2-й конференції «Innovative Research in Science and Economy» з benchmark-методологією. Друга — тези на 30-му форумі «Радіоелектроніка та молодь у XXI столітті» в ХНУРЕ про підвищення якості retrieval. Загалом — два виступи на міжнародних конференціях.</a:t>
-            </a:r>
-          </a:p>
-          <a:p>
-            <a:r>
-              <a:t>Дякую за увагу! Готовий відповісти на запитання.</a:t>
             </a:r>
           </a:p>
         </p:txBody>
@@ -6363,7 +6358,7 @@
           <a:lstStyle/>
           <a:p>
             <a:r>
-              <a:t>⏱ 0:23 – 1:12  ·  слайд 2/18</a:t>
+              <a:t>⏱ 0:23 – 1:13  ·  слайд 2/18</a:t>
             </a:r>
             <a:endParaRPr lang="en-US" dirty="0"/>
           </a:p>
@@ -6471,7 +6466,7 @@
           <a:lstStyle/>
           <a:p>
             <a:r>
-              <a:t>⏱ 1:12 – 1:37  ·  слайд 3/18</a:t>
+              <a:t>⏱ 1:13 – 1:37  ·  слайд 3/18</a:t>
             </a:r>
             <a:endParaRPr lang="en-US" dirty="0"/>
           </a:p>
@@ -6563,7 +6558,7 @@
           <a:lstStyle/>
           <a:p>
             <a:r>
-              <a:t>⏱ 1:37 – 2:11  ·  слайд 4/18</a:t>
+              <a:t>⏱ 1:37 – 2:12  ·  слайд 4/18</a:t>
             </a:r>
             <a:endParaRPr lang="en-US" dirty="0"/>
           </a:p>
@@ -6661,7 +6656,7 @@
           <a:lstStyle/>
           <a:p>
             <a:r>
-              <a:t>⏱ 2:11 – 2:47  ·  слайд 5/18</a:t>
+              <a:t>⏱ 2:12 – 2:48  ·  слайд 5/18</a:t>
             </a:r>
             <a:endParaRPr lang="en-US" dirty="0"/>
           </a:p>
@@ -6753,7 +6748,7 @@
           <a:lstStyle/>
           <a:p>
             <a:r>
-              <a:t>⏱ 2:47 – 3:18  ·  слайд 6/18</a:t>
+              <a:t>⏱ 2:48 – 3:19  ·  слайд 6/18</a:t>
             </a:r>
             <a:endParaRPr lang="en-US" dirty="0"/>
           </a:p>
@@ -6851,7 +6846,7 @@
           <a:lstStyle/>
           <a:p>
             <a:r>
-              <a:t>⏱ 3:18 – 3:46  ·  слайд 7/18</a:t>
+              <a:t>⏱ 3:19 – 3:47  ·  слайд 7/18</a:t>
             </a:r>
             <a:endParaRPr lang="en-US" dirty="0"/>
           </a:p>
@@ -6943,7 +6938,7 @@
           <a:lstStyle/>
           <a:p>
             <a:r>
-              <a:t>⏱ 3:46 – 4:26  ·  слайд 8/18</a:t>
+              <a:t>⏱ 3:47 – 4:27  ·  слайд 8/18</a:t>
             </a:r>
             <a:endParaRPr lang="en-US" dirty="0"/>
           </a:p>
@@ -7035,7 +7030,7 @@
           <a:lstStyle/>
           <a:p>
             <a:r>
-              <a:t>⏱ 4:26 – 5:01  ·  слайд 9/18</a:t>
+              <a:t>⏱ 4:27 – 5:03  ·  слайд 9/18</a:t>
             </a:r>
             <a:endParaRPr lang="en-US" dirty="0"/>
           </a:p>

</xml_diff>

<commit_message>
Fix slide 13 deletion — drop relationship in addition to slide list
Previous commit only removed the slide from the slide list but left
the relationship to the slide part dangling. PowerPoint detected this
as «found a problem with content» on open and asked to repair.

Proper fix: also call prs.part.drop_rel(rId) so the relationship is
gone too. Verified by reopening the saved file — now opens cleanly.

Co-Authored-By: Claude Opus 4.7 (1M context) <noreply@anthropic.com>
</commit_message>
<xml_diff>
--- a/thesis/2026_М_ПІ_ІПЗм-24-1_Нестеренко_В_В.pptx
+++ b/thesis/2026_М_ПІ_ІПЗм-24-1_Нестеренко_В_В.pptx
@@ -1964,680 +1964,6 @@
             <a:defRPr sz="800">
               <a:solidFill>
                 <a:srgbClr val="475569"/>
-              </a:solidFill>
-              <a:latin typeface="Calibri"/>
-              <a:cs typeface="Calibri"/>
-            </a:defRPr>
-          </a:pPr>
-          <a:endParaRPr lang="en-US"/>
-        </a:p>
-      </c:txPr>
-    </c:legend>
-    <c:plotVisOnly val="1"/>
-    <c:dispBlanksAs val="span"/>
-    <c:showDLblsOverMax val="1"/>
-  </c:chart>
-  <c:spPr>
-    <a:solidFill>
-      <a:srgbClr val="F8FAFC"/>
-    </a:solidFill>
-    <a:ln>
-      <a:noFill/>
-    </a:ln>
-    <a:effectLst/>
-  </c:spPr>
-  <c:externalData r:id="rId1">
-    <c:autoUpdate val="0"/>
-  </c:externalData>
-</c:chartSpace>
-</file>
-
-<file path=ppt/charts/chart4.xml><?xml version="1.0" encoding="utf-8"?>
-<c:chartSpace xmlns:c="http://schemas.openxmlformats.org/drawingml/2006/chart" xmlns:a="http://schemas.openxmlformats.org/drawingml/2006/main" xmlns:r="http://schemas.openxmlformats.org/officeDocument/2006/relationships" xmlns:c16r2="http://schemas.microsoft.com/office/drawing/2015/06/chart">
-  <c:date1904 val="0"/>
-  <c:lang val="en-US"/>
-  <c:roundedCorners val="1"/>
-  <c:style val="2"/>
-  <c:chart>
-    <c:autoTitleDeleted val="1"/>
-    <c:plotArea>
-      <c:layout/>
-      <c:barChart>
-        <c:barDir val="col"/>
-        <c:grouping val="clustered"/>
-        <c:varyColors val="0"/>
-        <c:ser>
-          <c:idx val="0"/>
-          <c:order val="0"/>
-          <c:tx>
-            <c:strRef>
-              <c:f>Sheet1!$B$1</c:f>
-              <c:strCache>
-                <c:ptCount val="1"/>
-                <c:pt idx="0">
-                  <c:v>BGE-M3</c:v>
-                </c:pt>
-              </c:strCache>
-            </c:strRef>
-          </c:tx>
-          <c:spPr>
-            <a:solidFill>
-              <a:srgbClr val="F59E0B"/>
-            </a:solidFill>
-            <a:effectLst/>
-          </c:spPr>
-          <c:invertIfNegative val="0"/>
-          <c:dLbls>
-            <c:numFmt formatCode="0.000" sourceLinked="0"/>
-            <c:spPr>
-              <a:noFill/>
-              <a:ln>
-                <a:noFill/>
-              </a:ln>
-              <a:effectLst/>
-            </c:spPr>
-            <c:txPr>
-              <a:bodyPr/>
-              <a:lstStyle/>
-              <a:p>
-                <a:pPr>
-                  <a:defRPr sz="800" b="0" i="0" u="none" strike="noStrike">
-                    <a:solidFill>
-                      <a:srgbClr val="1E293B"/>
-                    </a:solidFill>
-                    <a:latin typeface="Calibri"/>
-                  </a:defRPr>
-                </a:pPr>
-                <a:endParaRPr lang="en-US"/>
-              </a:p>
-            </c:txPr>
-            <c:showLegendKey val="0"/>
-            <c:showVal val="1"/>
-            <c:showCatName val="0"/>
-            <c:showSerName val="0"/>
-            <c:showPercent val="0"/>
-            <c:showBubbleSize val="0"/>
-            <c:showLeaderLines val="0"/>
-            <c:extLst>
-              <c:ext xmlns:c15="http://schemas.microsoft.com/office/drawing/2012/chart" uri="{CE6537A1-D6FC-4f65-9D91-7224C49458BB}">
-                <c15:showLeaderLines val="0"/>
-              </c:ext>
-            </c:extLst>
-          </c:dLbls>
-          <c:cat>
-            <c:strRef>
-              <c:f>Sheet1!$A$2:$A$4</c:f>
-              <c:strCache>
-                <c:ptCount val="3"/>
-                <c:pt idx="0">
-                  <c:v>Технічний</c:v>
-                </c:pt>
-                <c:pt idx="1">
-                  <c:v>Юридичний</c:v>
-                </c:pt>
-                <c:pt idx="2">
-                  <c:v>Медичний</c:v>
-                </c:pt>
-              </c:strCache>
-            </c:strRef>
-          </c:cat>
-          <c:val>
-            <c:numRef>
-              <c:f>Sheet1!$B$2:$B$4</c:f>
-              <c:numCache>
-                <c:formatCode>General</c:formatCode>
-                <c:ptCount val="3"/>
-                <c:pt idx="0">
-                  <c:v>0.67220000000000002</c:v>
-                </c:pt>
-                <c:pt idx="1">
-                  <c:v>0.30649999999999999</c:v>
-                </c:pt>
-                <c:pt idx="2">
-                  <c:v>0.43390000000000001</c:v>
-                </c:pt>
-              </c:numCache>
-            </c:numRef>
-          </c:val>
-          <c:extLst>
-            <c:ext xmlns:c16="http://schemas.microsoft.com/office/drawing/2014/chart" uri="{C3380CC4-5D6E-409C-BE32-E72D297353CC}">
-              <c16:uniqueId val="{00000000-2943-4127-A631-8D360886C949}"/>
-            </c:ext>
-          </c:extLst>
-        </c:ser>
-        <c:ser>
-          <c:idx val="1"/>
-          <c:order val="1"/>
-          <c:tx>
-            <c:strRef>
-              <c:f>Sheet1!$C$1</c:f>
-              <c:strCache>
-                <c:ptCount val="1"/>
-                <c:pt idx="0">
-                  <c:v>Qwen3</c:v>
-                </c:pt>
-              </c:strCache>
-            </c:strRef>
-          </c:tx>
-          <c:spPr>
-            <a:solidFill>
-              <a:srgbClr val="1E40AF"/>
-            </a:solidFill>
-            <a:effectLst/>
-          </c:spPr>
-          <c:invertIfNegative val="0"/>
-          <c:dLbls>
-            <c:numFmt formatCode="0.000" sourceLinked="0"/>
-            <c:spPr>
-              <a:noFill/>
-              <a:ln>
-                <a:noFill/>
-              </a:ln>
-              <a:effectLst/>
-            </c:spPr>
-            <c:txPr>
-              <a:bodyPr/>
-              <a:lstStyle/>
-              <a:p>
-                <a:pPr>
-                  <a:defRPr sz="800" b="0" i="0" u="none" strike="noStrike">
-                    <a:solidFill>
-                      <a:srgbClr val="1E293B"/>
-                    </a:solidFill>
-                    <a:latin typeface="Calibri"/>
-                  </a:defRPr>
-                </a:pPr>
-                <a:endParaRPr lang="en-US"/>
-              </a:p>
-            </c:txPr>
-            <c:showLegendKey val="0"/>
-            <c:showVal val="1"/>
-            <c:showCatName val="0"/>
-            <c:showSerName val="0"/>
-            <c:showPercent val="0"/>
-            <c:showBubbleSize val="0"/>
-            <c:showLeaderLines val="0"/>
-            <c:extLst>
-              <c:ext xmlns:c15="http://schemas.microsoft.com/office/drawing/2012/chart" uri="{CE6537A1-D6FC-4f65-9D91-7224C49458BB}">
-                <c15:showLeaderLines val="0"/>
-              </c:ext>
-            </c:extLst>
-          </c:dLbls>
-          <c:cat>
-            <c:strRef>
-              <c:f>Sheet1!$A$2:$A$4</c:f>
-              <c:strCache>
-                <c:ptCount val="3"/>
-                <c:pt idx="0">
-                  <c:v>Технічний</c:v>
-                </c:pt>
-                <c:pt idx="1">
-                  <c:v>Юридичний</c:v>
-                </c:pt>
-                <c:pt idx="2">
-                  <c:v>Медичний</c:v>
-                </c:pt>
-              </c:strCache>
-            </c:strRef>
-          </c:cat>
-          <c:val>
-            <c:numRef>
-              <c:f>Sheet1!$C$2:$C$4</c:f>
-              <c:numCache>
-                <c:formatCode>General</c:formatCode>
-                <c:ptCount val="3"/>
-                <c:pt idx="0">
-                  <c:v>0.63249999999999995</c:v>
-                </c:pt>
-                <c:pt idx="1">
-                  <c:v>0.31990000000000002</c:v>
-                </c:pt>
-                <c:pt idx="2">
-                  <c:v>0.3629</c:v>
-                </c:pt>
-              </c:numCache>
-            </c:numRef>
-          </c:val>
-          <c:extLst>
-            <c:ext xmlns:c16="http://schemas.microsoft.com/office/drawing/2014/chart" uri="{C3380CC4-5D6E-409C-BE32-E72D297353CC}">
-              <c16:uniqueId val="{00000001-2943-4127-A631-8D360886C949}"/>
-            </c:ext>
-          </c:extLst>
-        </c:ser>
-        <c:ser>
-          <c:idx val="2"/>
-          <c:order val="2"/>
-          <c:tx>
-            <c:strRef>
-              <c:f>Sheet1!$D$1</c:f>
-              <c:strCache>
-                <c:ptCount val="1"/>
-                <c:pt idx="0">
-                  <c:v>E5-base</c:v>
-                </c:pt>
-              </c:strCache>
-            </c:strRef>
-          </c:tx>
-          <c:spPr>
-            <a:solidFill>
-              <a:srgbClr val="0891B2"/>
-            </a:solidFill>
-            <a:effectLst/>
-          </c:spPr>
-          <c:invertIfNegative val="0"/>
-          <c:dLbls>
-            <c:numFmt formatCode="0.000" sourceLinked="0"/>
-            <c:spPr>
-              <a:noFill/>
-              <a:ln>
-                <a:noFill/>
-              </a:ln>
-              <a:effectLst/>
-            </c:spPr>
-            <c:txPr>
-              <a:bodyPr/>
-              <a:lstStyle/>
-              <a:p>
-                <a:pPr>
-                  <a:defRPr sz="800" b="0" i="0" u="none" strike="noStrike">
-                    <a:solidFill>
-                      <a:srgbClr val="1E293B"/>
-                    </a:solidFill>
-                    <a:latin typeface="Calibri"/>
-                  </a:defRPr>
-                </a:pPr>
-                <a:endParaRPr lang="en-US"/>
-              </a:p>
-            </c:txPr>
-            <c:showLegendKey val="0"/>
-            <c:showVal val="1"/>
-            <c:showCatName val="0"/>
-            <c:showSerName val="0"/>
-            <c:showPercent val="0"/>
-            <c:showBubbleSize val="0"/>
-            <c:showLeaderLines val="0"/>
-            <c:extLst>
-              <c:ext xmlns:c15="http://schemas.microsoft.com/office/drawing/2012/chart" uri="{CE6537A1-D6FC-4f65-9D91-7224C49458BB}">
-                <c15:showLeaderLines val="0"/>
-              </c:ext>
-            </c:extLst>
-          </c:dLbls>
-          <c:cat>
-            <c:strRef>
-              <c:f>Sheet1!$A$2:$A$4</c:f>
-              <c:strCache>
-                <c:ptCount val="3"/>
-                <c:pt idx="0">
-                  <c:v>Технічний</c:v>
-                </c:pt>
-                <c:pt idx="1">
-                  <c:v>Юридичний</c:v>
-                </c:pt>
-                <c:pt idx="2">
-                  <c:v>Медичний</c:v>
-                </c:pt>
-              </c:strCache>
-            </c:strRef>
-          </c:cat>
-          <c:val>
-            <c:numRef>
-              <c:f>Sheet1!$D$2:$D$4</c:f>
-              <c:numCache>
-                <c:formatCode>General</c:formatCode>
-                <c:ptCount val="3"/>
-                <c:pt idx="0">
-                  <c:v>0.61209999999999998</c:v>
-                </c:pt>
-                <c:pt idx="1">
-                  <c:v>0.25669999999999998</c:v>
-                </c:pt>
-                <c:pt idx="2">
-                  <c:v>0.39090000000000003</c:v>
-                </c:pt>
-              </c:numCache>
-            </c:numRef>
-          </c:val>
-          <c:extLst>
-            <c:ext xmlns:c16="http://schemas.microsoft.com/office/drawing/2014/chart" uri="{C3380CC4-5D6E-409C-BE32-E72D297353CC}">
-              <c16:uniqueId val="{00000002-2943-4127-A631-8D360886C949}"/>
-            </c:ext>
-          </c:extLst>
-        </c:ser>
-        <c:ser>
-          <c:idx val="3"/>
-          <c:order val="3"/>
-          <c:tx>
-            <c:strRef>
-              <c:f>Sheet1!$E$1</c:f>
-              <c:strCache>
-                <c:ptCount val="1"/>
-                <c:pt idx="0">
-                  <c:v>BM25</c:v>
-                </c:pt>
-              </c:strCache>
-            </c:strRef>
-          </c:tx>
-          <c:spPr>
-            <a:solidFill>
-              <a:srgbClr val="64748B"/>
-            </a:solidFill>
-            <a:effectLst/>
-          </c:spPr>
-          <c:invertIfNegative val="0"/>
-          <c:dLbls>
-            <c:numFmt formatCode="0.000" sourceLinked="0"/>
-            <c:spPr>
-              <a:noFill/>
-              <a:ln>
-                <a:noFill/>
-              </a:ln>
-              <a:effectLst/>
-            </c:spPr>
-            <c:txPr>
-              <a:bodyPr/>
-              <a:lstStyle/>
-              <a:p>
-                <a:pPr>
-                  <a:defRPr sz="800" b="0" i="0" u="none" strike="noStrike">
-                    <a:solidFill>
-                      <a:srgbClr val="1E293B"/>
-                    </a:solidFill>
-                    <a:latin typeface="Calibri"/>
-                  </a:defRPr>
-                </a:pPr>
-                <a:endParaRPr lang="en-US"/>
-              </a:p>
-            </c:txPr>
-            <c:showLegendKey val="0"/>
-            <c:showVal val="1"/>
-            <c:showCatName val="0"/>
-            <c:showSerName val="0"/>
-            <c:showPercent val="0"/>
-            <c:showBubbleSize val="0"/>
-            <c:showLeaderLines val="0"/>
-            <c:extLst>
-              <c:ext xmlns:c15="http://schemas.microsoft.com/office/drawing/2012/chart" uri="{CE6537A1-D6FC-4f65-9D91-7224C49458BB}">
-                <c15:showLeaderLines val="0"/>
-              </c:ext>
-            </c:extLst>
-          </c:dLbls>
-          <c:cat>
-            <c:strRef>
-              <c:f>Sheet1!$A$2:$A$4</c:f>
-              <c:strCache>
-                <c:ptCount val="3"/>
-                <c:pt idx="0">
-                  <c:v>Технічний</c:v>
-                </c:pt>
-                <c:pt idx="1">
-                  <c:v>Юридичний</c:v>
-                </c:pt>
-                <c:pt idx="2">
-                  <c:v>Медичний</c:v>
-                </c:pt>
-              </c:strCache>
-            </c:strRef>
-          </c:cat>
-          <c:val>
-            <c:numRef>
-              <c:f>Sheet1!$E$2:$E$4</c:f>
-              <c:numCache>
-                <c:formatCode>General</c:formatCode>
-                <c:ptCount val="3"/>
-                <c:pt idx="0">
-                  <c:v>0.48609999999999998</c:v>
-                </c:pt>
-                <c:pt idx="1">
-                  <c:v>0.1875</c:v>
-                </c:pt>
-                <c:pt idx="2">
-                  <c:v>0.32219999999999999</c:v>
-                </c:pt>
-              </c:numCache>
-            </c:numRef>
-          </c:val>
-          <c:extLst>
-            <c:ext xmlns:c16="http://schemas.microsoft.com/office/drawing/2014/chart" uri="{C3380CC4-5D6E-409C-BE32-E72D297353CC}">
-              <c16:uniqueId val="{00000003-2943-4127-A631-8D360886C949}"/>
-            </c:ext>
-          </c:extLst>
-        </c:ser>
-        <c:ser>
-          <c:idx val="4"/>
-          <c:order val="4"/>
-          <c:tx>
-            <c:strRef>
-              <c:f>Sheet1!$F$1</c:f>
-              <c:strCache>
-                <c:ptCount val="1"/>
-                <c:pt idx="0">
-                  <c:v>nomic</c:v>
-                </c:pt>
-              </c:strCache>
-            </c:strRef>
-          </c:tx>
-          <c:spPr>
-            <a:solidFill>
-              <a:srgbClr val="7C3AED"/>
-            </a:solidFill>
-            <a:effectLst/>
-          </c:spPr>
-          <c:invertIfNegative val="0"/>
-          <c:dLbls>
-            <c:numFmt formatCode="0.000" sourceLinked="0"/>
-            <c:spPr>
-              <a:noFill/>
-              <a:ln>
-                <a:noFill/>
-              </a:ln>
-              <a:effectLst/>
-            </c:spPr>
-            <c:txPr>
-              <a:bodyPr/>
-              <a:lstStyle/>
-              <a:p>
-                <a:pPr>
-                  <a:defRPr sz="800" b="0" i="0" u="none" strike="noStrike">
-                    <a:solidFill>
-                      <a:srgbClr val="1E293B"/>
-                    </a:solidFill>
-                    <a:latin typeface="Calibri"/>
-                  </a:defRPr>
-                </a:pPr>
-                <a:endParaRPr lang="en-US"/>
-              </a:p>
-            </c:txPr>
-            <c:showLegendKey val="0"/>
-            <c:showVal val="1"/>
-            <c:showCatName val="0"/>
-            <c:showSerName val="0"/>
-            <c:showPercent val="0"/>
-            <c:showBubbleSize val="0"/>
-            <c:showLeaderLines val="0"/>
-            <c:extLst>
-              <c:ext xmlns:c15="http://schemas.microsoft.com/office/drawing/2012/chart" uri="{CE6537A1-D6FC-4f65-9D91-7224C49458BB}">
-                <c15:showLeaderLines val="0"/>
-              </c:ext>
-            </c:extLst>
-          </c:dLbls>
-          <c:cat>
-            <c:strRef>
-              <c:f>Sheet1!$A$2:$A$4</c:f>
-              <c:strCache>
-                <c:ptCount val="3"/>
-                <c:pt idx="0">
-                  <c:v>Технічний</c:v>
-                </c:pt>
-                <c:pt idx="1">
-                  <c:v>Юридичний</c:v>
-                </c:pt>
-                <c:pt idx="2">
-                  <c:v>Медичний</c:v>
-                </c:pt>
-              </c:strCache>
-            </c:strRef>
-          </c:cat>
-          <c:val>
-            <c:numRef>
-              <c:f>Sheet1!$F$2:$F$4</c:f>
-              <c:numCache>
-                <c:formatCode>General</c:formatCode>
-                <c:ptCount val="3"/>
-                <c:pt idx="0">
-                  <c:v>0.3765</c:v>
-                </c:pt>
-                <c:pt idx="1">
-                  <c:v>9.5100000000000004E-2</c:v>
-                </c:pt>
-                <c:pt idx="2">
-                  <c:v>0.1668</c:v>
-                </c:pt>
-              </c:numCache>
-            </c:numRef>
-          </c:val>
-          <c:extLst>
-            <c:ext xmlns:c16="http://schemas.microsoft.com/office/drawing/2014/chart" uri="{C3380CC4-5D6E-409C-BE32-E72D297353CC}">
-              <c16:uniqueId val="{00000004-2943-4127-A631-8D360886C949}"/>
-            </c:ext>
-          </c:extLst>
-        </c:ser>
-        <c:dLbls>
-          <c:showLegendKey val="0"/>
-          <c:showVal val="1"/>
-          <c:showCatName val="0"/>
-          <c:showSerName val="0"/>
-          <c:showPercent val="0"/>
-          <c:showBubbleSize val="0"/>
-        </c:dLbls>
-        <c:gapWidth val="150"/>
-        <c:axId val="2094734554"/>
-        <c:axId val="2094734552"/>
-      </c:barChart>
-      <c:catAx>
-        <c:axId val="2094734554"/>
-        <c:scaling>
-          <c:orientation val="minMax"/>
-        </c:scaling>
-        <c:delete val="0"/>
-        <c:axPos val="b"/>
-        <c:numFmt formatCode="General" sourceLinked="1"/>
-        <c:majorTickMark val="out"/>
-        <c:minorTickMark val="none"/>
-        <c:tickLblPos val="low"/>
-        <c:spPr>
-          <a:ln w="12700" cap="flat">
-            <a:solidFill>
-              <a:srgbClr val="888888"/>
-            </a:solidFill>
-            <a:prstDash val="solid"/>
-            <a:round/>
-          </a:ln>
-        </c:spPr>
-        <c:txPr>
-          <a:bodyPr/>
-          <a:lstStyle/>
-          <a:p>
-            <a:pPr>
-              <a:defRPr sz="1000" b="0" i="0" u="none" strike="noStrike">
-                <a:solidFill>
-                  <a:srgbClr val="1E293B"/>
-                </a:solidFill>
-                <a:latin typeface="Calibri"/>
-              </a:defRPr>
-            </a:pPr>
-            <a:endParaRPr lang="en-US"/>
-          </a:p>
-        </c:txPr>
-        <c:crossAx val="2094734552"/>
-        <c:crosses val="autoZero"/>
-        <c:auto val="1"/>
-        <c:lblAlgn val="ctr"/>
-        <c:lblOffset val="100"/>
-        <c:noMultiLvlLbl val="1"/>
-      </c:catAx>
-      <c:valAx>
-        <c:axId val="2094734552"/>
-        <c:scaling>
-          <c:orientation val="minMax"/>
-          <c:max val="0.75"/>
-          <c:min val="0"/>
-        </c:scaling>
-        <c:delete val="0"/>
-        <c:axPos val="l"/>
-        <c:majorGridlines>
-          <c:spPr>
-            <a:ln w="6350" cap="flat">
-              <a:solidFill>
-                <a:srgbClr val="E2E8F0"/>
-              </a:solidFill>
-              <a:prstDash val="solid"/>
-              <a:round/>
-            </a:ln>
-          </c:spPr>
-        </c:majorGridlines>
-        <c:numFmt formatCode="General" sourceLinked="0"/>
-        <c:majorTickMark val="out"/>
-        <c:minorTickMark val="none"/>
-        <c:tickLblPos val="nextTo"/>
-        <c:spPr>
-          <a:ln w="12700" cap="flat">
-            <a:solidFill>
-              <a:srgbClr val="888888"/>
-            </a:solidFill>
-            <a:prstDash val="solid"/>
-            <a:round/>
-          </a:ln>
-        </c:spPr>
-        <c:txPr>
-          <a:bodyPr/>
-          <a:lstStyle/>
-          <a:p>
-            <a:pPr>
-              <a:defRPr sz="900" b="0" i="0" u="none" strike="noStrike">
-                <a:solidFill>
-                  <a:srgbClr val="475569"/>
-                </a:solidFill>
-                <a:latin typeface="Calibri"/>
-              </a:defRPr>
-            </a:pPr>
-            <a:endParaRPr lang="en-US"/>
-          </a:p>
-        </c:txPr>
-        <c:crossAx val="2094734554"/>
-        <c:crosses val="autoZero"/>
-        <c:crossBetween val="between"/>
-      </c:valAx>
-      <c:spPr>
-        <a:solidFill>
-          <a:srgbClr val="F8FAFC"/>
-        </a:solidFill>
-        <a:ln>
-          <a:noFill/>
-        </a:ln>
-        <a:effectLst/>
-      </c:spPr>
-    </c:plotArea>
-    <c:legend>
-      <c:legendPos val="b"/>
-      <c:layout>
-        <c:manualLayout>
-          <c:xMode val="edge"/>
-          <c:yMode val="edge"/>
-          <c:x val="0.22877350372187083"/>
-          <c:y val="0.92613188976377958"/>
-          <c:w val="0.54245299255625834"/>
-          <c:h val="7.3868110236220474E-2"/>
-        </c:manualLayout>
-      </c:layout>
-      <c:overlay val="0"/>
-      <c:txPr>
-        <a:bodyPr/>
-        <a:lstStyle/>
-        <a:p>
-          <a:pPr>
-            <a:defRPr sz="1000">
-              <a:solidFill>
-                <a:srgbClr val="1E293B"/>
               </a:solidFill>
               <a:latin typeface="Calibri"/>
               <a:cs typeface="Calibri"/>
@@ -5704,111 +5030,6 @@
 </p:notes>
 </file>
 
-<file path=ppt/notesSlides/notesSlide13.xml><?xml version="1.0" encoding="utf-8"?>
-<p:notes xmlns:a="http://schemas.openxmlformats.org/drawingml/2006/main" xmlns:r="http://schemas.openxmlformats.org/officeDocument/2006/relationships" xmlns:p="http://schemas.openxmlformats.org/presentationml/2006/main">
-  <p:cSld>
-    <p:spTree>
-      <p:nvGrpSpPr>
-        <p:cNvPr id="1" name=""/>
-        <p:cNvGrpSpPr/>
-        <p:nvPr/>
-      </p:nvGrpSpPr>
-      <p:grpSpPr>
-        <a:xfrm>
-          <a:off x="0" y="0"/>
-          <a:ext cx="0" cy="0"/>
-          <a:chOff x="0" y="0"/>
-          <a:chExt cx="0" cy="0"/>
-        </a:xfrm>
-      </p:grpSpPr>
-      <p:sp>
-        <p:nvSpPr>
-          <p:cNvPr id="2" name="Slide Image Placeholder 1"/>
-          <p:cNvSpPr>
-            <a:spLocks noGrp="1" noRot="1" noChangeAspect="1"/>
-          </p:cNvSpPr>
-          <p:nvPr>
-            <p:ph type="sldImg"/>
-          </p:nvPr>
-        </p:nvSpPr>
-        <p:spPr/>
-      </p:sp>
-      <p:sp>
-        <p:nvSpPr>
-          <p:cNvPr id="3" name="Notes Placeholder 2"/>
-          <p:cNvSpPr>
-            <a:spLocks noGrp="1"/>
-          </p:cNvSpPr>
-          <p:nvPr>
-            <p:ph type="body" idx="1"/>
-          </p:nvPr>
-        </p:nvSpPr>
-        <p:spPr/>
-        <p:txBody>
-          <a:bodyPr/>
-          <a:lstStyle/>
-          <a:p>
-            <a:r>
-              <a:t>⏱ 6:15 – 6:59  ·  слайд 13/18</a:t>
-            </a:r>
-            <a:endParaRPr lang="en-US" dirty="0"/>
-          </a:p>
-          <a:p>
-            <a:endParaRPr lang="en-US" dirty="0"/>
-          </a:p>
-          <a:p>
-            <a:r>
-              <a:t>Що дав запуск benchmark на 300 запитах? Головні результати. У таблиці — середнє nDCG@10 по трьох доменах. Перше — BGE-M3 з 0.4708. Друге — Qwen3 з 0.4385. Третє — E5-base з 0.4199. Четверте — BM25 з 0.3319. Останнє — nomic з 0.2128, навіть нижче BM25.</a:t>
-            </a:r>
-          </a:p>
-          <a:p>
-            <a:r>
-              <a:t>Ключовий висновок: три з чотирьох embedding-моделей перевершують BM25.</a:t>
-            </a:r>
-          </a:p>
-          <a:p>
-            <a:r>
-              <a:t>Статистична значущість підтверджена бутстрепом (2000 вибірок). На технічному домені 95% CI для BGE-M3 — 0.606–0.737, для BM25 — 0.431–0.541. Інтервали не перетинаються — перевага семантичного пошуку статистично значуща.</a:t>
-            </a:r>
-          </a:p>
-        </p:txBody>
-      </p:sp>
-      <p:sp>
-        <p:nvSpPr>
-          <p:cNvPr id="4" name="Slide Number Placeholder 3"/>
-          <p:cNvSpPr>
-            <a:spLocks noGrp="1"/>
-          </p:cNvSpPr>
-          <p:nvPr>
-            <p:ph type="sldNum" sz="quarter" idx="10"/>
-          </p:nvPr>
-        </p:nvSpPr>
-        <p:spPr/>
-        <p:txBody>
-          <a:bodyPr/>
-          <a:lstStyle/>
-          <a:p>
-            <a:fld id="{F7021451-1387-4CA6-816F-3879F97B5CBC}" type="slidenum">
-              <a:rPr lang="en-US"/>
-              <a:t>13</a:t>
-            </a:fld>
-            <a:endParaRPr lang="en-US"/>
-          </a:p>
-        </p:txBody>
-      </p:sp>
-    </p:spTree>
-    <p:extLst>
-      <p:ext uri="{BB962C8B-B14F-4D97-AF65-F5344CB8AC3E}">
-        <p14:creationId xmlns:p14="http://schemas.microsoft.com/office/powerpoint/2010/main" val="1024086991"/>
-      </p:ext>
-    </p:extLst>
-  </p:cSld>
-  <p:clrMapOvr>
-    <a:masterClrMapping/>
-  </p:clrMapOvr>
-</p:notes>
-</file>
-
 <file path=ppt/notesSlides/notesSlide14.xml><?xml version="1.0" encoding="utf-8"?>
 <p:notes xmlns:a="http://schemas.openxmlformats.org/drawingml/2006/main" xmlns:r="http://schemas.openxmlformats.org/officeDocument/2006/relationships" xmlns:p="http://schemas.openxmlformats.org/presentationml/2006/main">
   <p:cSld>
@@ -14346,591 +13567,6 @@
 </p:sld>
 </file>
 
-<file path=ppt/slides/slide13.xml><?xml version="1.0" encoding="utf-8"?>
-<p:sld xmlns:a="http://schemas.openxmlformats.org/drawingml/2006/main" xmlns:r="http://schemas.openxmlformats.org/officeDocument/2006/relationships" xmlns:p="http://schemas.openxmlformats.org/presentationml/2006/main">
-  <p:cSld name="Slide 14">
-    <p:bg>
-      <p:bgPr>
-        <a:solidFill>
-          <a:srgbClr val="FFFFFF"/>
-        </a:solidFill>
-        <a:effectLst/>
-      </p:bgPr>
-    </p:bg>
-    <p:spTree>
-      <p:nvGrpSpPr>
-        <p:cNvPr id="1" name=""/>
-        <p:cNvGrpSpPr/>
-        <p:nvPr/>
-      </p:nvGrpSpPr>
-      <p:grpSpPr>
-        <a:xfrm>
-          <a:off x="0" y="0"/>
-          <a:ext cx="0" cy="0"/>
-          <a:chOff x="0" y="0"/>
-          <a:chExt cx="0" cy="0"/>
-        </a:xfrm>
-      </p:grpSpPr>
-      <p:sp>
-        <p:nvSpPr>
-          <p:cNvPr id="2" name="Text 0"/>
-          <p:cNvSpPr/>
-          <p:nvPr/>
-        </p:nvSpPr>
-        <p:spPr>
-          <a:xfrm>
-            <a:off x="411480" y="91440"/>
-            <a:ext cx="8321040" cy="182880"/>
-          </a:xfrm>
-          <a:prstGeom prst="rect">
-            <a:avLst/>
-          </a:prstGeom>
-          <a:noFill/>
-          <a:ln/>
-        </p:spPr>
-        <p:txBody>
-          <a:bodyPr wrap="square" lIns="0" tIns="0" rIns="0" bIns="0" rtlCol="0" anchor="ctr"/>
-          <a:lstStyle/>
-          <a:p>
-            <a:pPr marL="0" indent="0" algn="l">
-              <a:buNone/>
-            </a:pPr>
-            <a:r>
-              <a:rPr lang="en-US" sz="850" b="1" kern="0" spc="300" dirty="0">
-                <a:solidFill>
-                  <a:srgbClr val="64748B"/>
-                </a:solidFill>
-                <a:latin typeface="Calibri" pitchFamily="34" charset="0"/>
-                <a:ea typeface="Calibri" pitchFamily="34" charset="-122"/>
-                <a:cs typeface="Calibri" pitchFamily="34" charset="-120"/>
-              </a:rPr>
-              <a:t>РОЗДІЛ 8 · РЕЗУЛЬТАТИ ЕКСПЕРИМЕНТУ</a:t>
-            </a:r>
-            <a:endParaRPr lang="en-US" sz="850" dirty="0"/>
-          </a:p>
-        </p:txBody>
-      </p:sp>
-      <p:sp>
-        <p:nvSpPr>
-          <p:cNvPr id="3" name="Shape 1"/>
-          <p:cNvSpPr/>
-          <p:nvPr/>
-        </p:nvSpPr>
-        <p:spPr>
-          <a:xfrm>
-            <a:off x="411480" y="420624"/>
-            <a:ext cx="201168" cy="201168"/>
-          </a:xfrm>
-          <a:prstGeom prst="ellipse">
-            <a:avLst/>
-          </a:prstGeom>
-          <a:solidFill>
-            <a:srgbClr val="F59E0B"/>
-          </a:solidFill>
-          <a:ln/>
-        </p:spPr>
-        <p:txBody>
-          <a:bodyPr/>
-          <a:lstStyle/>
-          <a:p>
-            <a:endParaRPr lang="en-US"/>
-          </a:p>
-        </p:txBody>
-      </p:sp>
-      <p:sp>
-        <p:nvSpPr>
-          <p:cNvPr id="4" name="Text 2"/>
-          <p:cNvSpPr/>
-          <p:nvPr/>
-        </p:nvSpPr>
-        <p:spPr>
-          <a:xfrm>
-            <a:off x="722376" y="292608"/>
-            <a:ext cx="6858000" cy="502920"/>
-          </a:xfrm>
-          <a:prstGeom prst="rect">
-            <a:avLst/>
-          </a:prstGeom>
-          <a:noFill/>
-          <a:ln/>
-        </p:spPr>
-        <p:txBody>
-          <a:bodyPr wrap="square" lIns="0" tIns="0" rIns="0" bIns="0" rtlCol="0" anchor="ctr"/>
-          <a:lstStyle/>
-          <a:p>
-            <a:pPr marL="0" indent="0" algn="l">
-              <a:buNone/>
-            </a:pPr>
-            <a:r>
-              <a:rPr lang="en-US" sz="2200" b="1" dirty="0">
-                <a:solidFill>
-                  <a:srgbClr val="0F172A"/>
-                </a:solidFill>
-                <a:latin typeface="Calibri" pitchFamily="34" charset="0"/>
-                <a:ea typeface="Calibri" pitchFamily="34" charset="-122"/>
-                <a:cs typeface="Calibri" pitchFamily="34" charset="-120"/>
-              </a:rPr>
-              <a:t>Деталізовані метрики за доменами</a:t>
-            </a:r>
-            <a:endParaRPr lang="en-US" sz="2200" dirty="0"/>
-          </a:p>
-        </p:txBody>
-      </p:sp>
-      <p:sp>
-        <p:nvSpPr>
-          <p:cNvPr id="5" name="Shape 3"/>
-          <p:cNvSpPr/>
-          <p:nvPr/>
-        </p:nvSpPr>
-        <p:spPr>
-          <a:xfrm>
-            <a:off x="411480" y="960120"/>
-            <a:ext cx="4078224" cy="1815084"/>
-          </a:xfrm>
-          <a:prstGeom prst="roundRect">
-            <a:avLst>
-              <a:gd name="adj" fmla="val 3023"/>
-            </a:avLst>
-          </a:prstGeom>
-          <a:solidFill>
-            <a:srgbClr val="F8FAFC"/>
-          </a:solidFill>
-          <a:ln w="9525">
-            <a:solidFill>
-              <a:srgbClr val="E2E8F0"/>
-            </a:solidFill>
-            <a:prstDash val="solid"/>
-          </a:ln>
-          <a:effectLst>
-            <a:outerShdw blurRad="76200" dist="12700" dir="5400000" algn="bl" rotWithShape="0">
-              <a:srgbClr val="000000">
-                <a:alpha val="7000"/>
-              </a:srgbClr>
-            </a:outerShdw>
-          </a:effectLst>
-        </p:spPr>
-        <p:txBody>
-          <a:bodyPr/>
-          <a:lstStyle/>
-          <a:p>
-            <a:endParaRPr lang="en-US"/>
-          </a:p>
-        </p:txBody>
-      </p:sp>
-      <p:sp>
-        <p:nvSpPr>
-          <p:cNvPr id="6" name="Text 4"/>
-          <p:cNvSpPr/>
-          <p:nvPr/>
-        </p:nvSpPr>
-        <p:spPr>
-          <a:xfrm>
-            <a:off x="594360" y="1033272"/>
-            <a:ext cx="3712464" cy="228600"/>
-          </a:xfrm>
-          <a:prstGeom prst="rect">
-            <a:avLst/>
-          </a:prstGeom>
-          <a:noFill/>
-          <a:ln/>
-        </p:spPr>
-        <p:txBody>
-          <a:bodyPr wrap="square" lIns="0" tIns="0" rIns="0" bIns="0" rtlCol="0" anchor="ctr"/>
-          <a:lstStyle/>
-          <a:p>
-            <a:pPr marL="0" indent="0" algn="l">
-              <a:buNone/>
-            </a:pPr>
-            <a:r>
-              <a:rPr lang="en-US" sz="1100" b="1" kern="0" spc="150" dirty="0">
-                <a:solidFill>
-                  <a:srgbClr val="1E293B"/>
-                </a:solidFill>
-                <a:latin typeface="Calibri" pitchFamily="34" charset="0"/>
-                <a:ea typeface="Calibri" pitchFamily="34" charset="-122"/>
-                <a:cs typeface="Calibri" pitchFamily="34" charset="-120"/>
-              </a:rPr>
-              <a:t>nDCG@10</a:t>
-            </a:r>
-            <a:endParaRPr lang="en-US" sz="1100" dirty="0"/>
-          </a:p>
-        </p:txBody>
-      </p:sp>
-      <p:graphicFrame>
-        <p:nvGraphicFramePr>
-          <p:cNvPr id="7" name="Chart 0"/>
-          <p:cNvGraphicFramePr/>
-          <p:nvPr/>
-        </p:nvGraphicFramePr>
-        <p:xfrm>
-          <a:off x="502920" y="1271016"/>
-          <a:ext cx="3895344" cy="1403604"/>
-        </p:xfrm>
-        <a:graphic>
-          <a:graphicData uri="http://schemas.openxmlformats.org/drawingml/2006/chart">
-            <c:chart xmlns:c="http://schemas.openxmlformats.org/drawingml/2006/chart" xmlns:r="http://schemas.openxmlformats.org/officeDocument/2006/relationships" r:id="rId3"/>
-          </a:graphicData>
-        </a:graphic>
-      </p:graphicFrame>
-      <p:sp>
-        <p:nvSpPr>
-          <p:cNvPr id="8" name="Shape 5"/>
-          <p:cNvSpPr/>
-          <p:nvPr/>
-        </p:nvSpPr>
-        <p:spPr>
-          <a:xfrm>
-            <a:off x="4654296" y="960120"/>
-            <a:ext cx="4078224" cy="1815084"/>
-          </a:xfrm>
-          <a:prstGeom prst="roundRect">
-            <a:avLst>
-              <a:gd name="adj" fmla="val 3023"/>
-            </a:avLst>
-          </a:prstGeom>
-          <a:solidFill>
-            <a:srgbClr val="F8FAFC"/>
-          </a:solidFill>
-          <a:ln w="9525">
-            <a:solidFill>
-              <a:srgbClr val="E2E8F0"/>
-            </a:solidFill>
-            <a:prstDash val="solid"/>
-          </a:ln>
-          <a:effectLst>
-            <a:outerShdw blurRad="76200" dist="12700" dir="5400000" algn="bl" rotWithShape="0">
-              <a:srgbClr val="000000">
-                <a:alpha val="7000"/>
-              </a:srgbClr>
-            </a:outerShdw>
-          </a:effectLst>
-        </p:spPr>
-        <p:txBody>
-          <a:bodyPr/>
-          <a:lstStyle/>
-          <a:p>
-            <a:endParaRPr lang="en-US"/>
-          </a:p>
-        </p:txBody>
-      </p:sp>
-      <p:sp>
-        <p:nvSpPr>
-          <p:cNvPr id="9" name="Text 6"/>
-          <p:cNvSpPr/>
-          <p:nvPr/>
-        </p:nvSpPr>
-        <p:spPr>
-          <a:xfrm>
-            <a:off x="4837176" y="1033272"/>
-            <a:ext cx="3712464" cy="228600"/>
-          </a:xfrm>
-          <a:prstGeom prst="rect">
-            <a:avLst/>
-          </a:prstGeom>
-          <a:noFill/>
-          <a:ln/>
-        </p:spPr>
-        <p:txBody>
-          <a:bodyPr wrap="square" lIns="0" tIns="0" rIns="0" bIns="0" rtlCol="0" anchor="ctr"/>
-          <a:lstStyle/>
-          <a:p>
-            <a:pPr marL="0" indent="0" algn="l">
-              <a:buNone/>
-            </a:pPr>
-            <a:r>
-              <a:rPr lang="en-US" sz="1100" b="1" kern="0" spc="150" dirty="0">
-                <a:solidFill>
-                  <a:srgbClr val="1E293B"/>
-                </a:solidFill>
-                <a:latin typeface="Calibri" pitchFamily="34" charset="0"/>
-                <a:ea typeface="Calibri" pitchFamily="34" charset="-122"/>
-                <a:cs typeface="Calibri" pitchFamily="34" charset="-120"/>
-              </a:rPr>
-              <a:t>MRR@10</a:t>
-            </a:r>
-            <a:endParaRPr lang="en-US" sz="1100" dirty="0"/>
-          </a:p>
-        </p:txBody>
-      </p:sp>
-      <p:graphicFrame>
-        <p:nvGraphicFramePr>
-          <p:cNvPr id="10" name="Chart 1"/>
-          <p:cNvGraphicFramePr/>
-          <p:nvPr/>
-        </p:nvGraphicFramePr>
-        <p:xfrm>
-          <a:off x="4745736" y="1271016"/>
-          <a:ext cx="3895344" cy="1403604"/>
-        </p:xfrm>
-        <a:graphic>
-          <a:graphicData uri="http://schemas.openxmlformats.org/drawingml/2006/chart">
-            <c:chart xmlns:c="http://schemas.openxmlformats.org/drawingml/2006/chart" xmlns:r="http://schemas.openxmlformats.org/officeDocument/2006/relationships" r:id="rId4"/>
-          </a:graphicData>
-        </a:graphic>
-      </p:graphicFrame>
-      <p:sp>
-        <p:nvSpPr>
-          <p:cNvPr id="11" name="Shape 7"/>
-          <p:cNvSpPr/>
-          <p:nvPr/>
-        </p:nvSpPr>
-        <p:spPr>
-          <a:xfrm>
-            <a:off x="411480" y="2939796"/>
-            <a:ext cx="4078224" cy="1815084"/>
-          </a:xfrm>
-          <a:prstGeom prst="roundRect">
-            <a:avLst>
-              <a:gd name="adj" fmla="val 3023"/>
-            </a:avLst>
-          </a:prstGeom>
-          <a:solidFill>
-            <a:srgbClr val="F8FAFC"/>
-          </a:solidFill>
-          <a:ln w="9525">
-            <a:solidFill>
-              <a:srgbClr val="E2E8F0"/>
-            </a:solidFill>
-            <a:prstDash val="solid"/>
-          </a:ln>
-          <a:effectLst>
-            <a:outerShdw blurRad="76200" dist="12700" dir="5400000" algn="bl" rotWithShape="0">
-              <a:srgbClr val="000000">
-                <a:alpha val="7000"/>
-              </a:srgbClr>
-            </a:outerShdw>
-          </a:effectLst>
-        </p:spPr>
-        <p:txBody>
-          <a:bodyPr/>
-          <a:lstStyle/>
-          <a:p>
-            <a:endParaRPr lang="en-US"/>
-          </a:p>
-        </p:txBody>
-      </p:sp>
-      <p:sp>
-        <p:nvSpPr>
-          <p:cNvPr id="12" name="Text 8"/>
-          <p:cNvSpPr/>
-          <p:nvPr/>
-        </p:nvSpPr>
-        <p:spPr>
-          <a:xfrm>
-            <a:off x="594360" y="3012948"/>
-            <a:ext cx="3712464" cy="228600"/>
-          </a:xfrm>
-          <a:prstGeom prst="rect">
-            <a:avLst/>
-          </a:prstGeom>
-          <a:noFill/>
-          <a:ln/>
-        </p:spPr>
-        <p:txBody>
-          <a:bodyPr wrap="square" lIns="0" tIns="0" rIns="0" bIns="0" rtlCol="0" anchor="ctr"/>
-          <a:lstStyle/>
-          <a:p>
-            <a:pPr marL="0" indent="0" algn="l">
-              <a:buNone/>
-            </a:pPr>
-            <a:r>
-              <a:rPr lang="en-US" sz="1100" b="1" kern="0" spc="150" dirty="0">
-                <a:solidFill>
-                  <a:srgbClr val="1E293B"/>
-                </a:solidFill>
-                <a:latin typeface="Calibri" pitchFamily="34" charset="0"/>
-                <a:ea typeface="Calibri" pitchFamily="34" charset="-122"/>
-                <a:cs typeface="Calibri" pitchFamily="34" charset="-120"/>
-              </a:rPr>
-              <a:t>Recall@10</a:t>
-            </a:r>
-            <a:endParaRPr lang="en-US" sz="1100" dirty="0"/>
-          </a:p>
-        </p:txBody>
-      </p:sp>
-      <p:graphicFrame>
-        <p:nvGraphicFramePr>
-          <p:cNvPr id="13" name="Chart 2"/>
-          <p:cNvGraphicFramePr/>
-          <p:nvPr/>
-        </p:nvGraphicFramePr>
-        <p:xfrm>
-          <a:off x="502920" y="3250692"/>
-          <a:ext cx="3895344" cy="1403604"/>
-        </p:xfrm>
-        <a:graphic>
-          <a:graphicData uri="http://schemas.openxmlformats.org/drawingml/2006/chart">
-            <c:chart xmlns:c="http://schemas.openxmlformats.org/drawingml/2006/chart" xmlns:r="http://schemas.openxmlformats.org/officeDocument/2006/relationships" r:id="rId5"/>
-          </a:graphicData>
-        </a:graphic>
-      </p:graphicFrame>
-      <p:sp>
-        <p:nvSpPr>
-          <p:cNvPr id="14" name="Shape 9"/>
-          <p:cNvSpPr/>
-          <p:nvPr/>
-        </p:nvSpPr>
-        <p:spPr>
-          <a:xfrm>
-            <a:off x="4654296" y="2939796"/>
-            <a:ext cx="4078224" cy="1815084"/>
-          </a:xfrm>
-          <a:prstGeom prst="roundRect">
-            <a:avLst>
-              <a:gd name="adj" fmla="val 3023"/>
-            </a:avLst>
-          </a:prstGeom>
-          <a:solidFill>
-            <a:srgbClr val="F8FAFC"/>
-          </a:solidFill>
-          <a:ln w="9525">
-            <a:solidFill>
-              <a:srgbClr val="E2E8F0"/>
-            </a:solidFill>
-            <a:prstDash val="solid"/>
-          </a:ln>
-          <a:effectLst>
-            <a:outerShdw blurRad="76200" dist="12700" dir="5400000" algn="bl" rotWithShape="0">
-              <a:srgbClr val="000000">
-                <a:alpha val="7000"/>
-              </a:srgbClr>
-            </a:outerShdw>
-          </a:effectLst>
-        </p:spPr>
-        <p:txBody>
-          <a:bodyPr/>
-          <a:lstStyle/>
-          <a:p>
-            <a:endParaRPr lang="en-US"/>
-          </a:p>
-        </p:txBody>
-      </p:sp>
-      <p:sp>
-        <p:nvSpPr>
-          <p:cNvPr id="15" name="Text 10"/>
-          <p:cNvSpPr/>
-          <p:nvPr/>
-        </p:nvSpPr>
-        <p:spPr>
-          <a:xfrm>
-            <a:off x="4837176" y="3012948"/>
-            <a:ext cx="3712464" cy="228600"/>
-          </a:xfrm>
-          <a:prstGeom prst="rect">
-            <a:avLst/>
-          </a:prstGeom>
-          <a:noFill/>
-          <a:ln/>
-        </p:spPr>
-        <p:txBody>
-          <a:bodyPr wrap="square" lIns="0" tIns="0" rIns="0" bIns="0" rtlCol="0" anchor="ctr"/>
-          <a:lstStyle/>
-          <a:p>
-            <a:pPr marL="0" indent="0" algn="l">
-              <a:buNone/>
-            </a:pPr>
-            <a:r>
-              <a:rPr lang="en-US" sz="1100" b="1" kern="0" spc="150" dirty="0">
-                <a:solidFill>
-                  <a:srgbClr val="1E293B"/>
-                </a:solidFill>
-                <a:latin typeface="Calibri" pitchFamily="34" charset="0"/>
-                <a:ea typeface="Calibri" pitchFamily="34" charset="-122"/>
-                <a:cs typeface="Calibri" pitchFamily="34" charset="-120"/>
-              </a:rPr>
-              <a:t>P@10</a:t>
-            </a:r>
-            <a:endParaRPr lang="en-US" sz="1100" dirty="0"/>
-          </a:p>
-        </p:txBody>
-      </p:sp>
-      <p:graphicFrame>
-        <p:nvGraphicFramePr>
-          <p:cNvPr id="16" name="Chart 3"/>
-          <p:cNvGraphicFramePr/>
-          <p:nvPr/>
-        </p:nvGraphicFramePr>
-        <p:xfrm>
-          <a:off x="4745736" y="3250692"/>
-          <a:ext cx="3895344" cy="1403604"/>
-        </p:xfrm>
-        <a:graphic>
-          <a:graphicData uri="http://schemas.openxmlformats.org/drawingml/2006/chart">
-            <c:chart xmlns:c="http://schemas.openxmlformats.org/drawingml/2006/chart" xmlns:r="http://schemas.openxmlformats.org/officeDocument/2006/relationships" r:id="rId6"/>
-          </a:graphicData>
-        </a:graphic>
-      </p:graphicFrame>
-      <p:pic>
-        <p:nvPicPr>
-          <p:cNvPr id="17" name="Image 0" descr="D:\repos\kb-semantic-search-benchmark\thesis\scripts\_logo_hex.png"/>
-          <p:cNvPicPr>
-            <a:picLocks noChangeAspect="1"/>
-          </p:cNvPicPr>
-          <p:nvPr/>
-        </p:nvPicPr>
-        <p:blipFill>
-          <a:blip r:embed="rId7"/>
-          <a:stretch>
-            <a:fillRect/>
-          </a:stretch>
-        </p:blipFill>
-        <p:spPr>
-          <a:xfrm>
-            <a:off x="411480" y="4686300"/>
-            <a:ext cx="502920" cy="338328"/>
-          </a:xfrm>
-          <a:prstGeom prst="rect">
-            <a:avLst/>
-          </a:prstGeom>
-        </p:spPr>
-      </p:pic>
-      <p:sp>
-        <p:nvSpPr>
-          <p:cNvPr id="18" name="Text 11"/>
-          <p:cNvSpPr/>
-          <p:nvPr/>
-        </p:nvSpPr>
-        <p:spPr>
-          <a:xfrm>
-            <a:off x="7955280" y="4850892"/>
-            <a:ext cx="960120" cy="228600"/>
-          </a:xfrm>
-          <a:prstGeom prst="rect">
-            <a:avLst/>
-          </a:prstGeom>
-          <a:noFill/>
-          <a:ln/>
-        </p:spPr>
-        <p:txBody>
-          <a:bodyPr wrap="square" lIns="0" tIns="0" rIns="0" bIns="0" rtlCol="0" anchor="ctr"/>
-          <a:lstStyle/>
-          <a:p>
-            <a:pPr marL="0" indent="0" algn="r">
-              <a:buNone/>
-            </a:pPr>
-            <a:r>
-              <a:rPr lang="en-US" sz="900" dirty="0">
-                <a:solidFill>
-                  <a:srgbClr val="64748B"/>
-                </a:solidFill>
-                <a:latin typeface="Calibri" pitchFamily="34" charset="0"/>
-                <a:ea typeface="Calibri" pitchFamily="34" charset="-122"/>
-                <a:cs typeface="Calibri" pitchFamily="34" charset="-120"/>
-              </a:rPr>
-              <a:t>13 / 17</a:t>
-            </a:r>
-            <a:endParaRPr lang="en-US" sz="900" dirty="0"/>
-          </a:p>
-        </p:txBody>
-      </p:sp>
-    </p:spTree>
-  </p:cSld>
-  <p:clrMapOvr>
-    <a:masterClrMapping/>
-  </p:clrMapOvr>
-</p:sld>
-</file>
-
 <file path=ppt/slides/slide14.xml><?xml version="1.0" encoding="utf-8"?>
 <p:sld xmlns:a="http://schemas.openxmlformats.org/drawingml/2006/main" xmlns:r="http://schemas.openxmlformats.org/officeDocument/2006/relationships" xmlns:p="http://schemas.openxmlformats.org/presentationml/2006/main">
   <p:cSld name="Slide 15">
@@ -24577,7 +23213,7 @@
               <a:buNone/>
             </a:pPr>
             <a:r>
-              <a:rPr lang="uk-UA" sz="2200" b="1" dirty="0">
+              <a:rPr lang="en-US" sz="2200" b="1" dirty="0">
                 <a:solidFill>
                   <a:srgbClr val="0F172A"/>
                 </a:solidFill>
@@ -24585,18 +23221,7 @@
                 <a:ea typeface="Calibri" pitchFamily="34" charset="-122"/>
                 <a:cs typeface="Calibri" pitchFamily="34" charset="-120"/>
               </a:rPr>
-              <a:t>Обрані</a:t>
-            </a:r>
-            <a:r>
-              <a:rPr lang="en-US" sz="2200" b="1" dirty="0">
-                <a:solidFill>
-                  <a:srgbClr val="0F172A"/>
-                </a:solidFill>
-                <a:latin typeface="Calibri" pitchFamily="34" charset="0"/>
-                <a:ea typeface="Calibri" pitchFamily="34" charset="-122"/>
-                <a:cs typeface="Calibri" pitchFamily="34" charset="-120"/>
-              </a:rPr>
-              <a:t> моделі векторних ембеддінгів</a:t>
+              <a:t>Сучасні моделі векторних ембеддінгів</a:t>
             </a:r>
             <a:endParaRPr lang="en-US" sz="2200" dirty="0"/>
           </a:p>

</xml_diff>

<commit_message>
Reframe slide 16 conclusion — focus on model choice, not BM25 contest
User flagged that «Embedding-моделі статистично значуще переважають
BM25...» reframes the work as a semantic-vs-lexical contest when the
actual theme is choosing the best embedding model. BM25 is a baseline,
not the centerpiece.

Slide 16 (Підсумки) headline:
- WAS: «Embedding-моделі статистично значуще переважають BM25 для
  україномовного семантичного пошуку»
- NOW: «Обґрунтовано рекомендації щодо вибору embedding-моделі для
  україномовного семантичного пошуку у корпоративних базах знань
  методом багатокритеріального аналізу»

Notes mirrored. Also: «BM25 — конкурентний baseline» → «BM25 —
конкурентний опорний метод» (drop English «baseline»).

Added Q0.15 to committee_qa.md — «Чому BM25 опорна модель»:
1. Standard in IR literature
2. Reference point for «is embedding worth it?»
3. Pareto-extremum at speed end

Co-Authored-By: Claude Opus 4.7 (1M context) <noreply@anthropic.com>
</commit_message>
<xml_diff>
--- a/thesis/2026_М_ПІ_ІПЗм-24-1_Нестеренко_В_В.pptx
+++ b/thesis/2026_М_ПІ_ІПЗм-24-1_Нестеренко_В_В.pptx
@@ -5,7 +5,7 @@
     <p:sldMasterId id="2147483648" r:id="rId1"/>
   </p:sldMasterIdLst>
   <p:notesMasterIdLst>
-    <p:notesMasterId r:id="rId20"/>
+    <p:notesMasterId r:id="rId19"/>
   </p:notesMasterIdLst>
   <p:sldIdLst>
     <p:sldId id="256" r:id="rId2"/>
@@ -20,11 +20,11 @@
     <p:sldId id="265" r:id="rId11"/>
     <p:sldId id="266" r:id="rId12"/>
     <p:sldId id="267" r:id="rId13"/>
-    <p:sldId id="269" r:id="rId15"/>
-    <p:sldId id="270" r:id="rId16"/>
-    <p:sldId id="271" r:id="rId17"/>
-    <p:sldId id="274" r:id="rId18"/>
-    <p:sldId id="272" r:id="rId19"/>
+    <p:sldId id="269" r:id="rId14"/>
+    <p:sldId id="270" r:id="rId15"/>
+    <p:sldId id="271" r:id="rId16"/>
+    <p:sldId id="274" r:id="rId17"/>
+    <p:sldId id="272" r:id="rId18"/>
   </p:sldIdLst>
   <p:sldSz cx="9144000" cy="5143500" type="screen16x9"/>
   <p:notesSz cx="5143500" cy="9144000"/>
@@ -659,329 +659,6 @@
 </c:chartSpace>
 </file>
 
-<file path=ppt/charts/chart10.xml><?xml version="1.0" encoding="utf-8"?>
-<c:chartSpace xmlns:c="http://schemas.openxmlformats.org/drawingml/2006/chart" xmlns:a="http://schemas.openxmlformats.org/drawingml/2006/main" xmlns:r="http://schemas.openxmlformats.org/officeDocument/2006/relationships" xmlns:c16r2="http://schemas.microsoft.com/office/drawing/2015/06/chart">
-  <c:date1904 val="0"/>
-  <c:lang val="en-US"/>
-  <c:roundedCorners val="1"/>
-  <c:style val="2"/>
-  <c:chart>
-    <c:autoTitleDeleted val="1"/>
-    <c:plotArea>
-      <c:layout/>
-      <c:scatterChart>
-        <c:scatterStyle val="lineMarker"/>
-        <c:varyColors val="0"/>
-        <c:ser>
-          <c:idx val="0"/>
-          <c:order val="0"/>
-          <c:tx>
-            <c:strRef>
-              <c:f>Sheet1!$B$1</c:f>
-              <c:strCache>
-                <c:ptCount val="1"/>
-                <c:pt idx="0">
-                  <c:v>nDCG@10</c:v>
-                </c:pt>
-              </c:strCache>
-            </c:strRef>
-          </c:tx>
-          <c:spPr>
-            <a:ln>
-              <a:noFill/>
-            </a:ln>
-            <a:effectLst/>
-          </c:spPr>
-          <c:marker>
-            <c:symbol val="circle"/>
-            <c:size val="14"/>
-            <c:spPr>
-              <a:solidFill>
-                <a:srgbClr val="1E40AF"/>
-              </a:solidFill>
-              <a:ln w="9525" cap="flat">
-                <a:solidFill>
-                  <a:srgbClr val="1E40AF"/>
-                </a:solidFill>
-                <a:prstDash val="solid"/>
-                <a:round/>
-              </a:ln>
-              <a:effectLst/>
-            </c:spPr>
-          </c:marker>
-          <c:xVal>
-            <c:numRef>
-              <c:f>Sheet1!$A$2:$A$6</c:f>
-              <c:numCache>
-                <c:formatCode>General</c:formatCode>
-                <c:ptCount val="5"/>
-                <c:pt idx="0">
-                  <c:v>0.4</c:v>
-                </c:pt>
-                <c:pt idx="1">
-                  <c:v>70.900000000000006</c:v>
-                </c:pt>
-                <c:pt idx="2">
-                  <c:v>124.8</c:v>
-                </c:pt>
-                <c:pt idx="3">
-                  <c:v>222.5</c:v>
-                </c:pt>
-                <c:pt idx="4">
-                  <c:v>463.4</c:v>
-                </c:pt>
-              </c:numCache>
-            </c:numRef>
-          </c:xVal>
-          <c:yVal>
-            <c:numRef>
-              <c:f>Sheet1!$B$2:$B$6</c:f>
-              <c:numCache>
-                <c:formatCode>General</c:formatCode>
-                <c:ptCount val="5"/>
-                <c:pt idx="0">
-                  <c:v>0.48609999999999998</c:v>
-                </c:pt>
-                <c:pt idx="1">
-                  <c:v>0.61209999999999998</c:v>
-                </c:pt>
-                <c:pt idx="2">
-                  <c:v>0.3765</c:v>
-                </c:pt>
-                <c:pt idx="3">
-                  <c:v>0.67220000000000002</c:v>
-                </c:pt>
-                <c:pt idx="4">
-                  <c:v>0.63249999999999995</c:v>
-                </c:pt>
-              </c:numCache>
-            </c:numRef>
-          </c:yVal>
-          <c:smooth val="0"/>
-          <c:extLst>
-            <c:ext xmlns:c16="http://schemas.microsoft.com/office/drawing/2014/chart" uri="{C3380CC4-5D6E-409C-BE32-E72D297353CC}">
-              <c16:uniqueId val="{00000000-2F12-4E1E-8CBB-62E4699DEDB3}"/>
-            </c:ext>
-          </c:extLst>
-        </c:ser>
-        <c:dLbls>
-          <c:showLegendKey val="0"/>
-          <c:showVal val="0"/>
-          <c:showCatName val="0"/>
-          <c:showSerName val="0"/>
-          <c:showPercent val="0"/>
-          <c:showBubbleSize val="0"/>
-        </c:dLbls>
-        <c:axId val="2094734554"/>
-        <c:axId val="2094734552"/>
-      </c:scatterChart>
-      <c:valAx>
-        <c:axId val="2094734554"/>
-        <c:scaling>
-          <c:orientation val="minMax"/>
-          <c:max val="500"/>
-          <c:min val="0"/>
-        </c:scaling>
-        <c:delete val="0"/>
-        <c:axPos val="b"/>
-        <c:majorGridlines>
-          <c:spPr>
-            <a:ln w="6350" cap="flat">
-              <a:solidFill>
-                <a:srgbClr val="E2E8F0"/>
-              </a:solidFill>
-              <a:prstDash val="solid"/>
-              <a:round/>
-            </a:ln>
-          </c:spPr>
-        </c:majorGridlines>
-        <c:title>
-          <c:tx>
-            <c:rich>
-              <a:bodyPr/>
-              <a:lstStyle/>
-              <a:p>
-                <a:pPr>
-                  <a:defRPr sz="900" b="0" i="0" u="none" strike="noStrike">
-                    <a:solidFill>
-                      <a:srgbClr val="475569"/>
-                    </a:solidFill>
-                    <a:latin typeface="Calibri"/>
-                  </a:defRPr>
-                </a:pPr>
-                <a:r>
-                  <a:rPr lang="en-US" sz="900" b="0" i="0" u="none" strike="noStrike">
-                    <a:solidFill>
-                      <a:srgbClr val="475569"/>
-                    </a:solidFill>
-                    <a:latin typeface="Calibri"/>
-                  </a:rPr>
-                  <a:t>ms / </a:t>
-                </a:r>
-                <a:r>
-                  <a:rPr lang="ru-RU" sz="900" b="0" i="0" u="none" strike="noStrike">
-                    <a:solidFill>
-                      <a:srgbClr val="475569"/>
-                    </a:solidFill>
-                    <a:latin typeface="Calibri"/>
-                  </a:rPr>
-                  <a:t>запит (нижче — краще)</a:t>
-                </a:r>
-              </a:p>
-            </c:rich>
-          </c:tx>
-          <c:overlay val="0"/>
-        </c:title>
-        <c:numFmt formatCode="General" sourceLinked="1"/>
-        <c:majorTickMark val="none"/>
-        <c:minorTickMark val="none"/>
-        <c:tickLblPos val="nextTo"/>
-        <c:spPr>
-          <a:ln w="12700" cap="flat">
-            <a:solidFill>
-              <a:srgbClr val="888888"/>
-            </a:solidFill>
-            <a:prstDash val="solid"/>
-            <a:round/>
-          </a:ln>
-        </c:spPr>
-        <c:txPr>
-          <a:bodyPr/>
-          <a:lstStyle/>
-          <a:p>
-            <a:pPr>
-              <a:defRPr sz="800" b="0" i="0" u="none" strike="noStrike">
-                <a:solidFill>
-                  <a:srgbClr val="475569"/>
-                </a:solidFill>
-                <a:latin typeface="Calibri"/>
-              </a:defRPr>
-            </a:pPr>
-            <a:endParaRPr lang="en-US"/>
-          </a:p>
-        </c:txPr>
-        <c:crossAx val="2094734552"/>
-        <c:crosses val="autoZero"/>
-        <c:crossBetween val="midCat"/>
-      </c:valAx>
-      <c:valAx>
-        <c:axId val="2094734552"/>
-        <c:scaling>
-          <c:orientation val="minMax"/>
-          <c:max val="0.8"/>
-          <c:min val="0"/>
-        </c:scaling>
-        <c:delete val="0"/>
-        <c:axPos val="l"/>
-        <c:majorGridlines>
-          <c:spPr>
-            <a:ln w="6350" cap="flat">
-              <a:solidFill>
-                <a:srgbClr val="E2E8F0"/>
-              </a:solidFill>
-              <a:prstDash val="solid"/>
-              <a:round/>
-            </a:ln>
-          </c:spPr>
-        </c:majorGridlines>
-        <c:title>
-          <c:tx>
-            <c:rich>
-              <a:bodyPr/>
-              <a:lstStyle/>
-              <a:p>
-                <a:pPr>
-                  <a:defRPr sz="900" b="0" i="0" u="none" strike="noStrike">
-                    <a:solidFill>
-                      <a:srgbClr val="475569"/>
-                    </a:solidFill>
-                    <a:latin typeface="Calibri"/>
-                  </a:defRPr>
-                </a:pPr>
-                <a:r>
-                  <a:rPr lang="en-US" sz="900" b="0" i="0" u="none" strike="noStrike">
-                    <a:solidFill>
-                      <a:srgbClr val="475569"/>
-                    </a:solidFill>
-                    <a:latin typeface="Calibri"/>
-                  </a:rPr>
-                  <a:t>nDCG@10 (</a:t>
-                </a:r>
-                <a:r>
-                  <a:rPr lang="ru-RU" sz="900" b="0" i="0" u="none" strike="noStrike">
-                    <a:solidFill>
-                      <a:srgbClr val="475569"/>
-                    </a:solidFill>
-                    <a:latin typeface="Calibri"/>
-                  </a:rPr>
-                  <a:t>вище — краще)</a:t>
-                </a:r>
-              </a:p>
-            </c:rich>
-          </c:tx>
-          <c:overlay val="0"/>
-        </c:title>
-        <c:numFmt formatCode="General" sourceLinked="0"/>
-        <c:majorTickMark val="none"/>
-        <c:minorTickMark val="none"/>
-        <c:tickLblPos val="nextTo"/>
-        <c:spPr>
-          <a:ln w="12700" cap="flat">
-            <a:solidFill>
-              <a:srgbClr val="888888"/>
-            </a:solidFill>
-            <a:prstDash val="solid"/>
-            <a:round/>
-          </a:ln>
-        </c:spPr>
-        <c:txPr>
-          <a:bodyPr/>
-          <a:lstStyle/>
-          <a:p>
-            <a:pPr>
-              <a:defRPr sz="800" b="0" i="0" u="none" strike="noStrike">
-                <a:solidFill>
-                  <a:srgbClr val="475569"/>
-                </a:solidFill>
-                <a:latin typeface="Calibri"/>
-              </a:defRPr>
-            </a:pPr>
-            <a:endParaRPr lang="en-US"/>
-          </a:p>
-        </c:txPr>
-        <c:crossAx val="2094734554"/>
-        <c:crosses val="autoZero"/>
-        <c:crossBetween val="midCat"/>
-      </c:valAx>
-      <c:spPr>
-        <a:solidFill>
-          <a:srgbClr val="F8FAFC"/>
-        </a:solidFill>
-        <a:ln>
-          <a:noFill/>
-        </a:ln>
-        <a:effectLst/>
-      </c:spPr>
-    </c:plotArea>
-    <c:plotVisOnly val="1"/>
-    <c:dispBlanksAs val="span"/>
-    <c:showDLblsOverMax val="1"/>
-  </c:chart>
-  <c:spPr>
-    <a:solidFill>
-      <a:srgbClr val="F8FAFC"/>
-    </a:solidFill>
-    <a:ln>
-      <a:noFill/>
-    </a:ln>
-    <a:effectLst/>
-  </c:spPr>
-  <c:externalData r:id="rId1">
-    <c:autoUpdate val="0"/>
-  </c:externalData>
-</c:chartSpace>
-</file>
-
 <file path=ppt/charts/chart2.xml><?xml version="1.0" encoding="utf-8"?>
 <c:chartSpace xmlns:c="http://schemas.openxmlformats.org/drawingml/2006/chart" xmlns:a="http://schemas.openxmlformats.org/drawingml/2006/main" xmlns:r="http://schemas.openxmlformats.org/officeDocument/2006/relationships" xmlns:c16r2="http://schemas.microsoft.com/office/drawing/2015/06/chart">
   <c:date1904 val="0"/>
@@ -1992,7 +1669,7 @@
 </c:chartSpace>
 </file>
 
-<file path=ppt/charts/chart5.xml><?xml version="1.0" encoding="utf-8"?>
+<file path=ppt/charts/chart4.xml><?xml version="1.0" encoding="utf-8"?>
 <c:chartSpace xmlns:c="http://schemas.openxmlformats.org/drawingml/2006/chart" xmlns:a="http://schemas.openxmlformats.org/drawingml/2006/main" xmlns:r="http://schemas.openxmlformats.org/officeDocument/2006/relationships" xmlns:c16r2="http://schemas.microsoft.com/office/drawing/2015/06/chart">
   <c:date1904 val="0"/>
   <c:lang val="en-US"/>
@@ -2471,7 +2148,7 @@
 </c:chartSpace>
 </file>
 
-<file path=ppt/charts/chart6.xml><?xml version="1.0" encoding="utf-8"?>
+<file path=ppt/charts/chart5.xml><?xml version="1.0" encoding="utf-8"?>
 <c:chartSpace xmlns:c="http://schemas.openxmlformats.org/drawingml/2006/chart" xmlns:a="http://schemas.openxmlformats.org/drawingml/2006/main" xmlns:r="http://schemas.openxmlformats.org/officeDocument/2006/relationships" xmlns:c16r2="http://schemas.microsoft.com/office/drawing/2015/06/chart">
   <c:date1904 val="0"/>
   <c:lang val="en-US"/>
@@ -2930,7 +2607,7 @@
 </c:chartSpace>
 </file>
 
-<file path=ppt/charts/chart7.xml><?xml version="1.0" encoding="utf-8"?>
+<file path=ppt/charts/chart6.xml><?xml version="1.0" encoding="utf-8"?>
 <c:chartSpace xmlns:c="http://schemas.openxmlformats.org/drawingml/2006/chart" xmlns:a="http://schemas.openxmlformats.org/drawingml/2006/main" xmlns:r="http://schemas.openxmlformats.org/officeDocument/2006/relationships" xmlns:c16r2="http://schemas.microsoft.com/office/drawing/2015/06/chart">
   <c:date1904 val="0"/>
   <c:lang val="en-US"/>
@@ -3389,7 +3066,7 @@
 </c:chartSpace>
 </file>
 
-<file path=ppt/charts/chart8.xml><?xml version="1.0" encoding="utf-8"?>
+<file path=ppt/charts/chart7.xml><?xml version="1.0" encoding="utf-8"?>
 <c:chartSpace xmlns:c="http://schemas.openxmlformats.org/drawingml/2006/chart" xmlns:a="http://schemas.openxmlformats.org/drawingml/2006/main" xmlns:r="http://schemas.openxmlformats.org/officeDocument/2006/relationships" xmlns:c16r2="http://schemas.microsoft.com/office/drawing/2015/06/chart">
   <c:date1904 val="0"/>
   <c:lang val="en-US"/>
@@ -3848,7 +3525,7 @@
 </c:chartSpace>
 </file>
 
-<file path=ppt/charts/chart9.xml><?xml version="1.0" encoding="utf-8"?>
+<file path=ppt/charts/chart8.xml><?xml version="1.0" encoding="utf-8"?>
 <c:chartSpace xmlns:c="http://schemas.openxmlformats.org/drawingml/2006/chart" xmlns:a="http://schemas.openxmlformats.org/drawingml/2006/main" xmlns:r="http://schemas.openxmlformats.org/officeDocument/2006/relationships" xmlns:c16r2="http://schemas.microsoft.com/office/drawing/2015/06/chart">
   <c:date1904 val="0"/>
   <c:lang val="en-US"/>
@@ -4522,6 +4199,329 @@
 </c:chartSpace>
 </file>
 
+<file path=ppt/charts/chart9.xml><?xml version="1.0" encoding="utf-8"?>
+<c:chartSpace xmlns:c="http://schemas.openxmlformats.org/drawingml/2006/chart" xmlns:a="http://schemas.openxmlformats.org/drawingml/2006/main" xmlns:r="http://schemas.openxmlformats.org/officeDocument/2006/relationships" xmlns:c16r2="http://schemas.microsoft.com/office/drawing/2015/06/chart">
+  <c:date1904 val="0"/>
+  <c:lang val="en-US"/>
+  <c:roundedCorners val="1"/>
+  <c:style val="2"/>
+  <c:chart>
+    <c:autoTitleDeleted val="1"/>
+    <c:plotArea>
+      <c:layout/>
+      <c:scatterChart>
+        <c:scatterStyle val="lineMarker"/>
+        <c:varyColors val="0"/>
+        <c:ser>
+          <c:idx val="0"/>
+          <c:order val="0"/>
+          <c:tx>
+            <c:strRef>
+              <c:f>Sheet1!$B$1</c:f>
+              <c:strCache>
+                <c:ptCount val="1"/>
+                <c:pt idx="0">
+                  <c:v>nDCG@10</c:v>
+                </c:pt>
+              </c:strCache>
+            </c:strRef>
+          </c:tx>
+          <c:spPr>
+            <a:ln>
+              <a:noFill/>
+            </a:ln>
+            <a:effectLst/>
+          </c:spPr>
+          <c:marker>
+            <c:symbol val="circle"/>
+            <c:size val="14"/>
+            <c:spPr>
+              <a:solidFill>
+                <a:srgbClr val="1E40AF"/>
+              </a:solidFill>
+              <a:ln w="9525" cap="flat">
+                <a:solidFill>
+                  <a:srgbClr val="1E40AF"/>
+                </a:solidFill>
+                <a:prstDash val="solid"/>
+                <a:round/>
+              </a:ln>
+              <a:effectLst/>
+            </c:spPr>
+          </c:marker>
+          <c:xVal>
+            <c:numRef>
+              <c:f>Sheet1!$A$2:$A$6</c:f>
+              <c:numCache>
+                <c:formatCode>General</c:formatCode>
+                <c:ptCount val="5"/>
+                <c:pt idx="0">
+                  <c:v>0.4</c:v>
+                </c:pt>
+                <c:pt idx="1">
+                  <c:v>70.900000000000006</c:v>
+                </c:pt>
+                <c:pt idx="2">
+                  <c:v>124.8</c:v>
+                </c:pt>
+                <c:pt idx="3">
+                  <c:v>222.5</c:v>
+                </c:pt>
+                <c:pt idx="4">
+                  <c:v>463.4</c:v>
+                </c:pt>
+              </c:numCache>
+            </c:numRef>
+          </c:xVal>
+          <c:yVal>
+            <c:numRef>
+              <c:f>Sheet1!$B$2:$B$6</c:f>
+              <c:numCache>
+                <c:formatCode>General</c:formatCode>
+                <c:ptCount val="5"/>
+                <c:pt idx="0">
+                  <c:v>0.48609999999999998</c:v>
+                </c:pt>
+                <c:pt idx="1">
+                  <c:v>0.61209999999999998</c:v>
+                </c:pt>
+                <c:pt idx="2">
+                  <c:v>0.3765</c:v>
+                </c:pt>
+                <c:pt idx="3">
+                  <c:v>0.67220000000000002</c:v>
+                </c:pt>
+                <c:pt idx="4">
+                  <c:v>0.63249999999999995</c:v>
+                </c:pt>
+              </c:numCache>
+            </c:numRef>
+          </c:yVal>
+          <c:smooth val="0"/>
+          <c:extLst>
+            <c:ext xmlns:c16="http://schemas.microsoft.com/office/drawing/2014/chart" uri="{C3380CC4-5D6E-409C-BE32-E72D297353CC}">
+              <c16:uniqueId val="{00000000-2F12-4E1E-8CBB-62E4699DEDB3}"/>
+            </c:ext>
+          </c:extLst>
+        </c:ser>
+        <c:dLbls>
+          <c:showLegendKey val="0"/>
+          <c:showVal val="0"/>
+          <c:showCatName val="0"/>
+          <c:showSerName val="0"/>
+          <c:showPercent val="0"/>
+          <c:showBubbleSize val="0"/>
+        </c:dLbls>
+        <c:axId val="2094734554"/>
+        <c:axId val="2094734552"/>
+      </c:scatterChart>
+      <c:valAx>
+        <c:axId val="2094734554"/>
+        <c:scaling>
+          <c:orientation val="minMax"/>
+          <c:max val="500"/>
+          <c:min val="0"/>
+        </c:scaling>
+        <c:delete val="0"/>
+        <c:axPos val="b"/>
+        <c:majorGridlines>
+          <c:spPr>
+            <a:ln w="6350" cap="flat">
+              <a:solidFill>
+                <a:srgbClr val="E2E8F0"/>
+              </a:solidFill>
+              <a:prstDash val="solid"/>
+              <a:round/>
+            </a:ln>
+          </c:spPr>
+        </c:majorGridlines>
+        <c:title>
+          <c:tx>
+            <c:rich>
+              <a:bodyPr/>
+              <a:lstStyle/>
+              <a:p>
+                <a:pPr>
+                  <a:defRPr sz="900" b="0" i="0" u="none" strike="noStrike">
+                    <a:solidFill>
+                      <a:srgbClr val="475569"/>
+                    </a:solidFill>
+                    <a:latin typeface="Calibri"/>
+                  </a:defRPr>
+                </a:pPr>
+                <a:r>
+                  <a:rPr lang="en-US" sz="900" b="0" i="0" u="none" strike="noStrike">
+                    <a:solidFill>
+                      <a:srgbClr val="475569"/>
+                    </a:solidFill>
+                    <a:latin typeface="Calibri"/>
+                  </a:rPr>
+                  <a:t>ms / </a:t>
+                </a:r>
+                <a:r>
+                  <a:rPr lang="ru-RU" sz="900" b="0" i="0" u="none" strike="noStrike">
+                    <a:solidFill>
+                      <a:srgbClr val="475569"/>
+                    </a:solidFill>
+                    <a:latin typeface="Calibri"/>
+                  </a:rPr>
+                  <a:t>запит (нижче — краще)</a:t>
+                </a:r>
+              </a:p>
+            </c:rich>
+          </c:tx>
+          <c:overlay val="0"/>
+        </c:title>
+        <c:numFmt formatCode="General" sourceLinked="1"/>
+        <c:majorTickMark val="none"/>
+        <c:minorTickMark val="none"/>
+        <c:tickLblPos val="nextTo"/>
+        <c:spPr>
+          <a:ln w="12700" cap="flat">
+            <a:solidFill>
+              <a:srgbClr val="888888"/>
+            </a:solidFill>
+            <a:prstDash val="solid"/>
+            <a:round/>
+          </a:ln>
+        </c:spPr>
+        <c:txPr>
+          <a:bodyPr/>
+          <a:lstStyle/>
+          <a:p>
+            <a:pPr>
+              <a:defRPr sz="800" b="0" i="0" u="none" strike="noStrike">
+                <a:solidFill>
+                  <a:srgbClr val="475569"/>
+                </a:solidFill>
+                <a:latin typeface="Calibri"/>
+              </a:defRPr>
+            </a:pPr>
+            <a:endParaRPr lang="en-US"/>
+          </a:p>
+        </c:txPr>
+        <c:crossAx val="2094734552"/>
+        <c:crosses val="autoZero"/>
+        <c:crossBetween val="midCat"/>
+      </c:valAx>
+      <c:valAx>
+        <c:axId val="2094734552"/>
+        <c:scaling>
+          <c:orientation val="minMax"/>
+          <c:max val="0.8"/>
+          <c:min val="0"/>
+        </c:scaling>
+        <c:delete val="0"/>
+        <c:axPos val="l"/>
+        <c:majorGridlines>
+          <c:spPr>
+            <a:ln w="6350" cap="flat">
+              <a:solidFill>
+                <a:srgbClr val="E2E8F0"/>
+              </a:solidFill>
+              <a:prstDash val="solid"/>
+              <a:round/>
+            </a:ln>
+          </c:spPr>
+        </c:majorGridlines>
+        <c:title>
+          <c:tx>
+            <c:rich>
+              <a:bodyPr/>
+              <a:lstStyle/>
+              <a:p>
+                <a:pPr>
+                  <a:defRPr sz="900" b="0" i="0" u="none" strike="noStrike">
+                    <a:solidFill>
+                      <a:srgbClr val="475569"/>
+                    </a:solidFill>
+                    <a:latin typeface="Calibri"/>
+                  </a:defRPr>
+                </a:pPr>
+                <a:r>
+                  <a:rPr lang="en-US" sz="900" b="0" i="0" u="none" strike="noStrike">
+                    <a:solidFill>
+                      <a:srgbClr val="475569"/>
+                    </a:solidFill>
+                    <a:latin typeface="Calibri"/>
+                  </a:rPr>
+                  <a:t>nDCG@10 (</a:t>
+                </a:r>
+                <a:r>
+                  <a:rPr lang="ru-RU" sz="900" b="0" i="0" u="none" strike="noStrike">
+                    <a:solidFill>
+                      <a:srgbClr val="475569"/>
+                    </a:solidFill>
+                    <a:latin typeface="Calibri"/>
+                  </a:rPr>
+                  <a:t>вище — краще)</a:t>
+                </a:r>
+              </a:p>
+            </c:rich>
+          </c:tx>
+          <c:overlay val="0"/>
+        </c:title>
+        <c:numFmt formatCode="General" sourceLinked="0"/>
+        <c:majorTickMark val="none"/>
+        <c:minorTickMark val="none"/>
+        <c:tickLblPos val="nextTo"/>
+        <c:spPr>
+          <a:ln w="12700" cap="flat">
+            <a:solidFill>
+              <a:srgbClr val="888888"/>
+            </a:solidFill>
+            <a:prstDash val="solid"/>
+            <a:round/>
+          </a:ln>
+        </c:spPr>
+        <c:txPr>
+          <a:bodyPr/>
+          <a:lstStyle/>
+          <a:p>
+            <a:pPr>
+              <a:defRPr sz="800" b="0" i="0" u="none" strike="noStrike">
+                <a:solidFill>
+                  <a:srgbClr val="475569"/>
+                </a:solidFill>
+                <a:latin typeface="Calibri"/>
+              </a:defRPr>
+            </a:pPr>
+            <a:endParaRPr lang="en-US"/>
+          </a:p>
+        </c:txPr>
+        <c:crossAx val="2094734554"/>
+        <c:crosses val="autoZero"/>
+        <c:crossBetween val="midCat"/>
+      </c:valAx>
+      <c:spPr>
+        <a:solidFill>
+          <a:srgbClr val="F8FAFC"/>
+        </a:solidFill>
+        <a:ln>
+          <a:noFill/>
+        </a:ln>
+        <a:effectLst/>
+      </c:spPr>
+    </c:plotArea>
+    <c:plotVisOnly val="1"/>
+    <c:dispBlanksAs val="span"/>
+    <c:showDLblsOverMax val="1"/>
+  </c:chart>
+  <c:spPr>
+    <a:solidFill>
+      <a:srgbClr val="F8FAFC"/>
+    </a:solidFill>
+    <a:ln>
+      <a:noFill/>
+    </a:ln>
+    <a:effectLst/>
+  </c:spPr>
+  <c:externalData r:id="rId1">
+    <c:autoUpdate val="0"/>
+  </c:externalData>
+</c:chartSpace>
+</file>
+
 <file path=ppt/notesMasters/notesMaster1.xml><?xml version="1.0" encoding="utf-8"?>
 <p:notesMaster xmlns:a="http://schemas.openxmlformats.org/drawingml/2006/main" xmlns:r="http://schemas.openxmlformats.org/officeDocument/2006/relationships" xmlns:p="http://schemas.openxmlformats.org/presentationml/2006/main">
   <p:cSld>
@@ -5030,6 +5030,98 @@
 </p:notes>
 </file>
 
+<file path=ppt/notesSlides/notesSlide13.xml><?xml version="1.0" encoding="utf-8"?>
+<p:notes xmlns:a="http://schemas.openxmlformats.org/drawingml/2006/main" xmlns:r="http://schemas.openxmlformats.org/officeDocument/2006/relationships" xmlns:p="http://schemas.openxmlformats.org/presentationml/2006/main">
+  <p:cSld>
+    <p:spTree>
+      <p:nvGrpSpPr>
+        <p:cNvPr id="1" name=""/>
+        <p:cNvGrpSpPr/>
+        <p:nvPr/>
+      </p:nvGrpSpPr>
+      <p:grpSpPr>
+        <a:xfrm>
+          <a:off x="0" y="0"/>
+          <a:ext cx="0" cy="0"/>
+          <a:chOff x="0" y="0"/>
+          <a:chExt cx="0" cy="0"/>
+        </a:xfrm>
+      </p:grpSpPr>
+      <p:sp>
+        <p:nvSpPr>
+          <p:cNvPr id="2" name="Slide Image Placeholder 1"/>
+          <p:cNvSpPr>
+            <a:spLocks noGrp="1" noRot="1" noChangeAspect="1"/>
+          </p:cNvSpPr>
+          <p:nvPr>
+            <p:ph type="sldImg"/>
+          </p:nvPr>
+        </p:nvSpPr>
+        <p:spPr/>
+      </p:sp>
+      <p:sp>
+        <p:nvSpPr>
+          <p:cNvPr id="3" name="Notes Placeholder 2"/>
+          <p:cNvSpPr>
+            <a:spLocks noGrp="1"/>
+          </p:cNvSpPr>
+          <p:nvPr>
+            <p:ph type="body" idx="1"/>
+          </p:nvPr>
+        </p:nvSpPr>
+        <p:spPr/>
+        <p:txBody>
+          <a:bodyPr/>
+          <a:lstStyle/>
+          <a:p>
+            <a:r>
+              <a:t>⏱ 6:45 – 7:11  ·  слайд 13/17</a:t>
+            </a:r>
+            <a:endParaRPr lang="en-US" dirty="0"/>
+          </a:p>
+          <a:p>
+            <a:r>
+              <a:t>За окремими доменами картина така. Деталізовані метрики у розрізі трьох доменів — nDCG, MRR, Recall, Precision. Лідерство BGE-M3 послідовне за всіма чотирма метриками — це підтверджує робастність результату. На юридичному домені усі моделі показують нижчі значення — він складніший через формальний стиль і вузькоспеціалізовану термінологію.</a:t>
+            </a:r>
+          </a:p>
+        </p:txBody>
+      </p:sp>
+      <p:sp>
+        <p:nvSpPr>
+          <p:cNvPr id="4" name="Slide Number Placeholder 3"/>
+          <p:cNvSpPr>
+            <a:spLocks noGrp="1"/>
+          </p:cNvSpPr>
+          <p:nvPr>
+            <p:ph type="sldNum" sz="quarter" idx="10"/>
+          </p:nvPr>
+        </p:nvSpPr>
+        <p:spPr/>
+        <p:txBody>
+          <a:bodyPr/>
+          <a:lstStyle/>
+          <a:p>
+            <a:fld id="{F7021451-1387-4CA6-816F-3879F97B5CBC}" type="slidenum">
+              <a:rPr lang="en-US"/>
+              <a:t>13</a:t>
+            </a:fld>
+            <a:endParaRPr lang="en-US"/>
+          </a:p>
+        </p:txBody>
+      </p:sp>
+    </p:spTree>
+    <p:extLst>
+      <p:ext uri="{BB962C8B-B14F-4D97-AF65-F5344CB8AC3E}">
+        <p14:creationId xmlns:p14="http://schemas.microsoft.com/office/powerpoint/2010/main" val="1024086991"/>
+      </p:ext>
+    </p:extLst>
+  </p:cSld>
+  <p:clrMapOvr>
+    <a:masterClrMapping/>
+  </p:clrMapOvr>
+</p:notes>
+</file>
+
 <file path=ppt/notesSlides/notesSlide14.xml><?xml version="1.0" encoding="utf-8"?>
 <p:notes xmlns:a="http://schemas.openxmlformats.org/drawingml/2006/main" xmlns:r="http://schemas.openxmlformats.org/officeDocument/2006/relationships" xmlns:p="http://schemas.openxmlformats.org/presentationml/2006/main">
   <p:cSld>
@@ -5075,13 +5167,13 @@
           <a:lstStyle/>
           <a:p>
             <a:r>
-              <a:t>⏱ 6:45 – 7:11  ·  слайд 13/17</a:t>
+              <a:t>⏱ 7:11 – 7:51  ·  слайд 14/17</a:t>
             </a:r>
             <a:endParaRPr lang="en-US" dirty="0"/>
           </a:p>
           <a:p>
             <a:r>
-              <a:t>За окремими доменами картина така. Деталізовані метрики у розрізі трьох доменів — nDCG, MRR, Recall, Precision. Лідерство BGE-M3 послідовне за всіма чотирма метриками — це підтверджує робастність результату. На юридичному домені усі моделі показують нижчі значення — він складніший через формальний стиль і вузькоспеціалізовану термінологію.</a:t>
+              <a:t>Переходимо до інтегральної оцінки. Результати багатокритеріального вибору. Парето-оптимальна множина — BGE-M3, E5-base та BM25: три з п'яти моделей не домінуються жодною. BGE-M3 — лідер за nDCG, MRR, Recall на технічному і медичному доменах. E5-base — швидка альтернатива: 70 мілісекунд проти 228 у BGE-M3, тобто у три рази швидше. Qwen3 — лідер на юридичному (nDCG 0.320), але удвічі повільніший. Nomic — найслабші результати, в окремих доменах поступається навіть BM25.</a:t>
             </a:r>
           </a:p>
         </p:txBody>
@@ -5167,13 +5259,33 @@
           <a:lstStyle/>
           <a:p>
             <a:r>
-              <a:t>⏱ 7:11 – 7:51  ·  слайд 14/17</a:t>
+              <a:t>⏱ 7:51 – 8:41  ·  слайд 15/17</a:t>
             </a:r>
             <a:endParaRPr lang="en-US" dirty="0"/>
           </a:p>
           <a:p>
             <a:r>
-              <a:t>Переходимо до інтегральної оцінки. Результати багатокритеріального вибору. Парето-оптимальна множина — BGE-M3, E5-base та BM25: три з п'яти моделей не домінуються жодною. BGE-M3 — лідер за nDCG, MRR, Recall на технічному і медичному доменах. E5-base — швидка альтернатива: 70 мілісекунд проти 228 у BGE-M3, тобто у три рази швидше. Qwen3 — лідер на юридичному (nDCG 0.320), але удвічі повільніший. Nomic — найслабші результати, в окремих доменах поступається навіть BM25.</a:t>
+              <a:t>Той самий аналіз — у вигляді графіка. Компроміс якості та швидкодії на технічному домені. По осі X — час відповіді, по осі Y — nDCG@10. Парето-фронт виділено пунктиром.</a:t>
+            </a:r>
+          </a:p>
+          <a:p>
+            <a:r>
+              <a:t>BGE-M3 — Парето-оптимальна, лідер якості: nDCG 0.672, ~228 мілісекунд. Основний вибір для впровадження.</a:t>
+            </a:r>
+          </a:p>
+          <a:p>
+            <a:r>
+              <a:t>E5-base — Парето-оптимальна: ~70 мілісекунд, утричі швидше за BGE-M3 при якості на ~10% нижчій.</a:t>
+            </a:r>
+          </a:p>
+          <a:p>
+            <a:r>
+              <a:t>BM25 — Парето-оптимальна як baseline: менше 3 мілісекунд, найвища nDCG — ~0.49.</a:t>
+            </a:r>
+          </a:p>
+          <a:p>
+            <a:r>
+              <a:t>Qwen3 домінується на tech, але кращий на legal. Nomic не рекомендується — повністю домінується, поступається BM25 за якістю.</a:t>
             </a:r>
           </a:p>
         </p:txBody>
@@ -5259,33 +5371,38 @@
           <a:lstStyle/>
           <a:p>
             <a:r>
-              <a:t>⏱ 7:51 – 8:41  ·  слайд 15/17</a:t>
+              <a:t>⏱ 8:41 – 9:28  ·  слайд 16/17</a:t>
             </a:r>
             <a:endParaRPr lang="en-US" dirty="0"/>
           </a:p>
           <a:p>
             <a:r>
-              <a:t>Той самий аналіз — у вигляді графіка. Компроміс якості та швидкодії на технічному домені. По осі X — час відповіді, по осі Y — nDCG@10. Парето-фронт виділено пунктиром.</a:t>
-            </a:r>
-          </a:p>
-          <a:p>
-            <a:r>
-              <a:t>BGE-M3 — Парето-оптимальна, лідер якості: nDCG 0.672, ~228 мілісекунд. Основний вибір для впровадження.</a:t>
-            </a:r>
-          </a:p>
-          <a:p>
-            <a:r>
-              <a:t>E5-base — Парето-оптимальна: ~70 мілісекунд, утричі швидше за BGE-M3 при якості на ~10% нижчій.</a:t>
-            </a:r>
-          </a:p>
-          <a:p>
-            <a:r>
-              <a:t>BM25 — Парето-оптимальна як baseline: менше 3 мілісекунд, найвища nDCG — ~0.49.</a:t>
-            </a:r>
-          </a:p>
-          <a:p>
-            <a:r>
-              <a:t>Qwen3 домінується на tech, але кращий на legal. Nomic не рекомендується — повністю домінується, поступається BM25 за якістю.</a:t>
+              <a:t>Підсумовуючи: на основі багатокритеріального аналізу обґрунтовано рекомендації щодо вибору embedding-моделі для україномовного семантичного пошуку у корпоративних базах знань.</a:t>
+            </a:r>
+          </a:p>
+          <a:p>
+            <a:r>
+              <a:t>BGE-M3 — основна модель для впровадження: найкраща якість і стабільність у різних доменах.</a:t>
+            </a:r>
+          </a:p>
+          <a:p>
+            <a:r>
+              <a:t>E5-base — швидка альтернатива: якість на ~10% нижча за BGE-M3, але утричі швидше.</a:t>
+            </a:r>
+          </a:p>
+          <a:p>
+            <a:r>
+              <a:t>Qwen3 — оптимальний вибір для юридичних колекцій, де він демонструє найвищу якість.</a:t>
+            </a:r>
+          </a:p>
+          <a:p>
+            <a:r>
+              <a:t>BM25 — залишається конкурентним опорним методом у певних доменах і за дуже жорстких вимог до швидкості.</a:t>
+            </a:r>
+          </a:p>
+          <a:p>
+            <a:r>
+              <a:t>Усі задачі, поставлені в роботі, виконано. Мета досягнута.</a:t>
             </a:r>
           </a:p>
         </p:txBody>
@@ -5371,38 +5488,13 @@
           <a:lstStyle/>
           <a:p>
             <a:r>
-              <a:t>⏱ 8:41 – 9:28  ·  слайд 16/17</a:t>
+              <a:t>⏱ 9:28 – 10:00  ·  слайд 17/17</a:t>
             </a:r>
             <a:endParaRPr lang="en-US" dirty="0"/>
           </a:p>
           <a:p>
             <a:r>
-              <a:t>Підсумовуючи: embedding-моделі статистично значуще переважають BM25 для україномовного семантичного пошуку. Сформульовано практичні рекомендації щодо вибору моделі під конкретні умови.</a:t>
-            </a:r>
-          </a:p>
-          <a:p>
-            <a:r>
-              <a:t>BGE-M3 — основна модель для впровадження: найкраща якість і стабільність у різних доменах.</a:t>
-            </a:r>
-          </a:p>
-          <a:p>
-            <a:r>
-              <a:t>E5-base — швидка альтернатива: якість на ~10% нижча за BGE-M3, але утричі швидше.</a:t>
-            </a:r>
-          </a:p>
-          <a:p>
-            <a:r>
-              <a:t>Qwen3 — оптимальний вибір для юридичних колекцій, де він демонструє найвищу якість.</a:t>
-            </a:r>
-          </a:p>
-          <a:p>
-            <a:r>
-              <a:t>BM25 — залишається конкурентним baseline у певних доменах і за дуже жорстких вимог до швидкості.</a:t>
-            </a:r>
-          </a:p>
-          <a:p>
-            <a:r>
-              <a:t>Усі задачі, поставлені в роботі, виконано. Мета досягнута.</a:t>
+              <a:t>Окремо — про апробацію результатів роботи. Апробація: опубліковано дві наукові праці у співавторстві з науковим керівником. Перша — стаття на 2-й конференції «Innovative Research in Science and Economy» з benchmark-методологією. Друга — тези на 30-му форумі «Радіоелектроніка та молодь у XXI столітті» в ХНУРЕ про підвищення якості retrieval. Загалом — два виступи на міжнародних конференціях.</a:t>
             </a:r>
           </a:p>
         </p:txBody>
@@ -5425,98 +5517,6 @@
             <a:fld id="{F7021451-1387-4CA6-816F-3879F97B5CBC}" type="slidenum">
               <a:rPr lang="en-US"/>
               <a:t>17</a:t>
-            </a:fld>
-            <a:endParaRPr lang="en-US"/>
-          </a:p>
-        </p:txBody>
-      </p:sp>
-    </p:spTree>
-    <p:extLst>
-      <p:ext uri="{BB962C8B-B14F-4D97-AF65-F5344CB8AC3E}">
-        <p14:creationId xmlns:p14="http://schemas.microsoft.com/office/powerpoint/2010/main" val="1024086991"/>
-      </p:ext>
-    </p:extLst>
-  </p:cSld>
-  <p:clrMapOvr>
-    <a:masterClrMapping/>
-  </p:clrMapOvr>
-</p:notes>
-</file>
-
-<file path=ppt/notesSlides/notesSlide18.xml><?xml version="1.0" encoding="utf-8"?>
-<p:notes xmlns:a="http://schemas.openxmlformats.org/drawingml/2006/main" xmlns:r="http://schemas.openxmlformats.org/officeDocument/2006/relationships" xmlns:p="http://schemas.openxmlformats.org/presentationml/2006/main">
-  <p:cSld>
-    <p:spTree>
-      <p:nvGrpSpPr>
-        <p:cNvPr id="1" name=""/>
-        <p:cNvGrpSpPr/>
-        <p:nvPr/>
-      </p:nvGrpSpPr>
-      <p:grpSpPr>
-        <a:xfrm>
-          <a:off x="0" y="0"/>
-          <a:ext cx="0" cy="0"/>
-          <a:chOff x="0" y="0"/>
-          <a:chExt cx="0" cy="0"/>
-        </a:xfrm>
-      </p:grpSpPr>
-      <p:sp>
-        <p:nvSpPr>
-          <p:cNvPr id="2" name="Slide Image Placeholder 1"/>
-          <p:cNvSpPr>
-            <a:spLocks noGrp="1" noRot="1" noChangeAspect="1"/>
-          </p:cNvSpPr>
-          <p:nvPr>
-            <p:ph type="sldImg"/>
-          </p:nvPr>
-        </p:nvSpPr>
-        <p:spPr/>
-      </p:sp>
-      <p:sp>
-        <p:nvSpPr>
-          <p:cNvPr id="3" name="Notes Placeholder 2"/>
-          <p:cNvSpPr>
-            <a:spLocks noGrp="1"/>
-          </p:cNvSpPr>
-          <p:nvPr>
-            <p:ph type="body" idx="1"/>
-          </p:nvPr>
-        </p:nvSpPr>
-        <p:spPr/>
-        <p:txBody>
-          <a:bodyPr/>
-          <a:lstStyle/>
-          <a:p>
-            <a:r>
-              <a:t>⏱ 9:28 – 10:00  ·  слайд 17/17</a:t>
-            </a:r>
-            <a:endParaRPr lang="en-US" dirty="0"/>
-          </a:p>
-          <a:p>
-            <a:r>
-              <a:t>Окремо — про апробацію результатів роботи. Апробація: опубліковано дві наукові праці у співавторстві з науковим керівником. Перша — стаття на 2-й конференції «Innovative Research in Science and Economy» з benchmark-методологією. Друга — тези на 30-му форумі «Радіоелектроніка та молодь у XXI столітті» в ХНУРЕ про підвищення якості retrieval. Загалом — два виступи на міжнародних конференціях.</a:t>
-            </a:r>
-          </a:p>
-        </p:txBody>
-      </p:sp>
-      <p:sp>
-        <p:nvSpPr>
-          <p:cNvPr id="4" name="Slide Number Placeholder 3"/>
-          <p:cNvSpPr>
-            <a:spLocks noGrp="1"/>
-          </p:cNvSpPr>
-          <p:nvPr>
-            <p:ph type="sldNum" sz="quarter" idx="10"/>
-          </p:nvPr>
-        </p:nvSpPr>
-        <p:spPr/>
-        <p:txBody>
-          <a:bodyPr/>
-          <a:lstStyle/>
-          <a:p>
-            <a:fld id="{F7021451-1387-4CA6-816F-3879F97B5CBC}" type="slidenum">
-              <a:rPr lang="en-US"/>
-              <a:t>18</a:t>
             </a:fld>
             <a:endParaRPr lang="en-US"/>
           </a:p>
@@ -16457,7 +16457,7 @@
                 <a:ea typeface="Calibri" pitchFamily="34" charset="-122"/>
                 <a:cs typeface="Calibri" pitchFamily="34" charset="-120"/>
               </a:rPr>
-              <a:t>Embedding-моделі статистично значуще переважають BM25 для україномовного семантичного пошуку</a:t>
+              <a:t>Обґрунтовано рекомендації щодо вибору embedding-моделі для україномовного семантичного пошуку у корпоративних базах знань методом багатокритеріального аналізу</a:t>
             </a:r>
             <a:endParaRPr lang="en-US" sz="1100" dirty="0"/>
           </a:p>
@@ -17437,28 +17437,6 @@
                 <a:cs typeface="Calibri" pitchFamily="34" charset="-120"/>
               </a:rPr>
               <a:t>16 / 17</a:t>
-            </a:r>
-            <a:r>
-              <a:rPr lang="uk-UA" sz="900" dirty="0">
-                <a:solidFill>
-                  <a:srgbClr val="64748B"/>
-                </a:solidFill>
-                <a:latin typeface="Calibri" pitchFamily="34" charset="0"/>
-                <a:ea typeface="Calibri" pitchFamily="34" charset="-122"/>
-                <a:cs typeface="Calibri" pitchFamily="34" charset="-120"/>
-              </a:rPr>
-              <a:t/>
-            </a:r>
-            <a:r>
-              <a:rPr lang="en-US" sz="900" dirty="0">
-                <a:solidFill>
-                  <a:srgbClr val="64748B"/>
-                </a:solidFill>
-                <a:latin typeface="Calibri" pitchFamily="34" charset="0"/>
-                <a:ea typeface="Calibri" pitchFamily="34" charset="-122"/>
-                <a:cs typeface="Calibri" pitchFamily="34" charset="-120"/>
-              </a:rPr>
-              <a:t/>
             </a:r>
             <a:endParaRPr lang="en-US" sz="900" dirty="0"/>
           </a:p>
@@ -18482,28 +18460,6 @@
                 <a:cs typeface="Calibri" pitchFamily="34" charset="-120"/>
               </a:rPr>
               <a:t>17 / 17</a:t>
-            </a:r>
-            <a:r>
-              <a:rPr lang="uk-UA" sz="900" dirty="0">
-                <a:solidFill>
-                  <a:srgbClr val="64748B"/>
-                </a:solidFill>
-                <a:latin typeface="Calibri" pitchFamily="34" charset="0"/>
-                <a:ea typeface="Calibri" pitchFamily="34" charset="-122"/>
-                <a:cs typeface="Calibri" pitchFamily="34" charset="-120"/>
-              </a:rPr>
-              <a:t/>
-            </a:r>
-            <a:r>
-              <a:rPr lang="en-US" sz="900" dirty="0">
-                <a:solidFill>
-                  <a:srgbClr val="64748B"/>
-                </a:solidFill>
-                <a:latin typeface="Calibri" pitchFamily="34" charset="0"/>
-                <a:ea typeface="Calibri" pitchFamily="34" charset="-122"/>
-                <a:cs typeface="Calibri" pitchFamily="34" charset="-120"/>
-              </a:rPr>
-              <a:t/>
             </a:r>
             <a:endParaRPr lang="en-US" sz="900" dirty="0"/>
           </a:p>

</xml_diff>

<commit_message>
Slide 15: reposition «Парето-фронт» arrow next to the dashed line
Student moved the arrow label down from the top-left area (where it
looked like it pointed at the Y-axis) to right next to the dashed
front line between E5-base and BGE-M3 — now it's unambiguous that
the label refers to the line, not the axis.

Co-Authored-By: Claude Opus 4.7 (1M context) <noreply@anthropic.com>
</commit_message>
<xml_diff>
--- a/thesis/2026_М_ПІ_ІПЗм-24-1_Нестеренко_В_В.pptx
+++ b/thesis/2026_М_ПІ_ІПЗм-24-1_Нестеренко_В_В.pptx
@@ -15202,7 +15202,7 @@
         </p:nvSpPr>
         <p:spPr>
           <a:xfrm>
-            <a:off x="1188720" y="1307592"/>
+            <a:off x="1997872" y="1971130"/>
             <a:ext cx="1645920" cy="228600"/>
           </a:xfrm>
           <a:prstGeom prst="rect">
@@ -15365,7 +15365,7 @@
               <a:buNone/>
             </a:pPr>
             <a:r>
-              <a:rPr lang="en-US" sz="850" b="1" kern="0" spc="100" dirty="0">
+              <a:rPr lang="uk-UA" sz="850" b="1" kern="0" spc="100" dirty="0">
                 <a:solidFill>
                   <a:srgbClr val="64748B"/>
                 </a:solidFill>
@@ -15373,7 +15373,18 @@
                 <a:ea typeface="Calibri" pitchFamily="34" charset="-122"/>
                 <a:cs typeface="Calibri" pitchFamily="34" charset="-120"/>
               </a:rPr>
-              <a:t>Парето-оптимальна  ·  найвища nDCG</a:t>
+              <a:t>Найвища </a:t>
+            </a:r>
+            <a:r>
+              <a:rPr lang="en-US" sz="850" b="1" kern="0" spc="100" dirty="0" err="1">
+                <a:solidFill>
+                  <a:srgbClr val="64748B"/>
+                </a:solidFill>
+                <a:latin typeface="Calibri" pitchFamily="34" charset="0"/>
+                <a:ea typeface="Calibri" pitchFamily="34" charset="-122"/>
+                <a:cs typeface="Calibri" pitchFamily="34" charset="-120"/>
+              </a:rPr>
+              <a:t>nDCG</a:t>
             </a:r>
             <a:endParaRPr lang="en-US" sz="850" dirty="0"/>
           </a:p>
@@ -15558,7 +15569,7 @@
                 <a:ea typeface="Calibri" pitchFamily="34" charset="-122"/>
                 <a:cs typeface="Calibri" pitchFamily="34" charset="-120"/>
               </a:rPr>
-              <a:t>Парето-оптимальна  ·  ~3× швидше за BGE-M3</a:t>
+              <a:t>~3× швидше за BGE-M3</a:t>
             </a:r>
             <a:endParaRPr lang="en-US" sz="850" dirty="0"/>
           </a:p>
@@ -15735,6 +15746,17 @@
               <a:buNone/>
             </a:pPr>
             <a:r>
+              <a:rPr lang="uk-UA" sz="850" b="1" kern="0" spc="100" dirty="0">
+                <a:solidFill>
+                  <a:srgbClr val="64748B"/>
+                </a:solidFill>
+                <a:latin typeface="Calibri" pitchFamily="34" charset="0"/>
+                <a:ea typeface="Calibri" pitchFamily="34" charset="-122"/>
+                <a:cs typeface="Calibri" pitchFamily="34" charset="-120"/>
+              </a:rPr>
+              <a:t>Опорна</a:t>
+            </a:r>
+            <a:r>
               <a:rPr lang="en-US" sz="850" b="1" kern="0" spc="100" dirty="0">
                 <a:solidFill>
                   <a:srgbClr val="64748B"/>
@@ -15743,7 +15765,7 @@
                 <a:ea typeface="Calibri" pitchFamily="34" charset="-122"/>
                 <a:cs typeface="Calibri" pitchFamily="34" charset="-120"/>
               </a:rPr>
-              <a:t>Парето-оптимальна  ·  опорна модель</a:t>
+              <a:t> модель</a:t>
             </a:r>
             <a:endParaRPr lang="en-US" sz="850" dirty="0"/>
           </a:p>
@@ -15864,7 +15886,7 @@
           <a:bodyPr/>
           <a:lstStyle/>
           <a:p>
-            <a:endParaRPr lang="en-US"/>
+            <a:endParaRPr lang="en-US" dirty="0"/>
           </a:p>
         </p:txBody>
       </p:sp>
@@ -15920,6 +15942,17 @@
               <a:buNone/>
             </a:pPr>
             <a:r>
+              <a:rPr lang="uk-UA" sz="850" b="1" kern="0" spc="100" dirty="0">
+                <a:solidFill>
+                  <a:srgbClr val="64748B"/>
+                </a:solidFill>
+                <a:latin typeface="Calibri" pitchFamily="34" charset="0"/>
+                <a:ea typeface="Calibri" pitchFamily="34" charset="-122"/>
+                <a:cs typeface="Calibri" pitchFamily="34" charset="-120"/>
+              </a:rPr>
+              <a:t>Лідер</a:t>
+            </a:r>
+            <a:r>
               <a:rPr lang="en-US" sz="850" b="1" kern="0" spc="100" dirty="0">
                 <a:solidFill>
                   <a:srgbClr val="64748B"/>
@@ -15928,7 +15961,7 @@
                 <a:ea typeface="Calibri" pitchFamily="34" charset="-122"/>
                 <a:cs typeface="Calibri" pitchFamily="34" charset="-120"/>
               </a:rPr>
-              <a:t>Поза Парето на Tech  ·  лідер на Legal</a:t>
+              <a:t> на Legal</a:t>
             </a:r>
             <a:endParaRPr lang="en-US" sz="850" dirty="0"/>
           </a:p>

</xml_diff>